<commit_message>
feat(compliance): add pilot legal and policy pack
Add a starter legal pack, clinic data policy helpers and tests, and website compliance/privacy pages aligned with the dental clinic SaaS pilot posture.
</commit_message>
<xml_diff>
--- a/docs/pitch/clinic-package/outputs/clinic-deck/renvoo-clinic-deck.pptx
+++ b/docs/pitch/clinic-package/outputs/clinic-deck/renvoo-clinic-deck.pptx
@@ -2,22 +2,22 @@
 <file path=ppt/presentation.xml><?xml version="1.0" encoding="utf-8"?>
 <p:presentation xmlns:p="http://schemas.openxmlformats.org/presentationml/2006/main">
   <p:sldMasterIdLst>
-    <p:sldMasterId xmlns:r="http://schemas.openxmlformats.org/officeDocument/2006/relationships" id="2147483648" r:id="Rb0e6d3ebb5db4af8"/>
+    <p:sldMasterId xmlns:r="http://schemas.openxmlformats.org/officeDocument/2006/relationships" id="2147483648" r:id="Rb9c4a498ef8948bb"/>
   </p:sldMasterIdLst>
   <p:notesMasterIdLst>
-    <p:notesMasterId xmlns:r="http://schemas.openxmlformats.org/officeDocument/2006/relationships" r:id="R4faea0b1efa543e2"/>
+    <p:notesMasterId xmlns:r="http://schemas.openxmlformats.org/officeDocument/2006/relationships" r:id="Rd1bdd618a12541df"/>
   </p:notesMasterIdLst>
   <p:sldIdLst>
-    <p:sldId xmlns:r="http://schemas.openxmlformats.org/officeDocument/2006/relationships" id="256" r:id="R7463ae5ff6d14b3d"/>
-    <p:sldId xmlns:r="http://schemas.openxmlformats.org/officeDocument/2006/relationships" id="257" r:id="R28ef7d32c88b4e15"/>
-    <p:sldId xmlns:r="http://schemas.openxmlformats.org/officeDocument/2006/relationships" id="258" r:id="R01b1d76790184c1c"/>
-    <p:sldId xmlns:r="http://schemas.openxmlformats.org/officeDocument/2006/relationships" id="259" r:id="R7ed8642f43dc4180"/>
-    <p:sldId xmlns:r="http://schemas.openxmlformats.org/officeDocument/2006/relationships" id="260" r:id="Rac454e7dd6994b79"/>
-    <p:sldId xmlns:r="http://schemas.openxmlformats.org/officeDocument/2006/relationships" id="261" r:id="R3411802911a44420"/>
-    <p:sldId xmlns:r="http://schemas.openxmlformats.org/officeDocument/2006/relationships" id="262" r:id="Rc5dacd4d56d14ec3"/>
-    <p:sldId xmlns:r="http://schemas.openxmlformats.org/officeDocument/2006/relationships" id="263" r:id="Ra365ed99f74b440c"/>
-    <p:sldId xmlns:r="http://schemas.openxmlformats.org/officeDocument/2006/relationships" id="264" r:id="Rb6828042ac59499a"/>
-    <p:sldId xmlns:r="http://schemas.openxmlformats.org/officeDocument/2006/relationships" id="265" r:id="Ra596ceffad924f99"/>
+    <p:sldId xmlns:r="http://schemas.openxmlformats.org/officeDocument/2006/relationships" id="256" r:id="Rc6f1b329bb46421d"/>
+    <p:sldId xmlns:r="http://schemas.openxmlformats.org/officeDocument/2006/relationships" id="257" r:id="R9052b6aa7888438c"/>
+    <p:sldId xmlns:r="http://schemas.openxmlformats.org/officeDocument/2006/relationships" id="258" r:id="Re4adab0fe1854a22"/>
+    <p:sldId xmlns:r="http://schemas.openxmlformats.org/officeDocument/2006/relationships" id="259" r:id="R9c5720c624b542b3"/>
+    <p:sldId xmlns:r="http://schemas.openxmlformats.org/officeDocument/2006/relationships" id="260" r:id="R25109dd7ed0649e2"/>
+    <p:sldId xmlns:r="http://schemas.openxmlformats.org/officeDocument/2006/relationships" id="261" r:id="R63d1d0f25f124e9d"/>
+    <p:sldId xmlns:r="http://schemas.openxmlformats.org/officeDocument/2006/relationships" id="262" r:id="Re23c5214dfc045e7"/>
+    <p:sldId xmlns:r="http://schemas.openxmlformats.org/officeDocument/2006/relationships" id="263" r:id="R48920c315b7641a7"/>
+    <p:sldId xmlns:r="http://schemas.openxmlformats.org/officeDocument/2006/relationships" id="264" r:id="R6221547a6d91431e"/>
+    <p:sldId xmlns:r="http://schemas.openxmlformats.org/officeDocument/2006/relationships" id="265" r:id="Rfdcb4bb11e6b47f3"/>
   </p:sldIdLst>
   <p:sldSz cx="12192000" cy="6858000"/>
   <p:notesSz cx="6858000" cy="9144000"/>
@@ -1006,7 +1006,7 @@
           <a:lstStyle xmlns:a="http://schemas.openxmlformats.org/drawingml/2006/main"/>
           <a:p xmlns:a="http://schemas.openxmlformats.org/drawingml/2006/main">
             <a:r>
-              <a:t>This is where trust is built. Emphasize narrow data boundaries and low-friction operational fit.</a:t>
+              <a:t>This is where trust is built. Emphasize narrow data boundaries, low-friction operational fit, and the simple clinic-SaaS posture.</a:t>
             </a:r>
           </a:p>
         </p:txBody>
@@ -1123,7 +1123,7 @@
           <p:cNvPr id="1" name="Title 1">
             <a:extLst xmlns:a="http://schemas.openxmlformats.org/drawingml/2006/main">
               <a:ext uri="{FF2B5EF4-FFF2-40B4-BE49-F238E27FC236}">
-                <a16:creationId xmlns:a16="http://schemas.microsoft.com/office/drawing/2014/main" id="{3199AF1C-FF4B-4E08-A50A-81FD8CCE58E3}"/>
+                <a16:creationId xmlns:a16="http://schemas.microsoft.com/office/drawing/2014/main" id="{263A8804-052A-45B8-B32C-72E73645407D}"/>
               </a:ext>
             </a:extLst>
           </p:cNvPr>
@@ -1154,7 +1154,7 @@
           <p:cNvPr id="2" name="Subtitle 2">
             <a:extLst xmlns:a="http://schemas.openxmlformats.org/drawingml/2006/main">
               <a:ext uri="{FF2B5EF4-FFF2-40B4-BE49-F238E27FC236}">
-                <a16:creationId xmlns:a16="http://schemas.microsoft.com/office/drawing/2014/main" id="{974B2149-F389-460E-BB57-2F5D9F72B55D}"/>
+                <a16:creationId xmlns:a16="http://schemas.microsoft.com/office/drawing/2014/main" id="{6A70689F-1B44-41CE-A496-96DFCAA138E1}"/>
               </a:ext>
             </a:extLst>
           </p:cNvPr>
@@ -1217,7 +1217,7 @@
           <p:cNvPr id="3" name="Date Placeholder 3">
             <a:extLst xmlns:a="http://schemas.openxmlformats.org/drawingml/2006/main">
               <a:ext uri="{FF2B5EF4-FFF2-40B4-BE49-F238E27FC236}">
-                <a16:creationId xmlns:a16="http://schemas.microsoft.com/office/drawing/2014/main" id="{F9C21E91-99A2-481F-9592-F081C35F0DFD}"/>
+                <a16:creationId xmlns:a16="http://schemas.microsoft.com/office/drawing/2014/main" id="{D0148ADC-60B1-44C4-9E85-1A8E7E784BD7}"/>
               </a:ext>
             </a:extLst>
           </p:cNvPr>
@@ -1238,7 +1238,7 @@
           <p:cNvPr id="4" name="Footer Placeholder 4">
             <a:extLst xmlns:a="http://schemas.openxmlformats.org/drawingml/2006/main">
               <a:ext uri="{FF2B5EF4-FFF2-40B4-BE49-F238E27FC236}">
-                <a16:creationId xmlns:a16="http://schemas.microsoft.com/office/drawing/2014/main" id="{EBF21EB2-B279-41F8-BCEC-93BBCA35C0C7}"/>
+                <a16:creationId xmlns:a16="http://schemas.microsoft.com/office/drawing/2014/main" id="{618841F1-C5B4-43D5-BD94-F0D09C965974}"/>
               </a:ext>
             </a:extLst>
           </p:cNvPr>
@@ -1259,7 +1259,7 @@
           <p:cNvPr id="5" name="Slide Number Placeholder 5">
             <a:extLst xmlns:a="http://schemas.openxmlformats.org/drawingml/2006/main">
               <a:ext uri="{FF2B5EF4-FFF2-40B4-BE49-F238E27FC236}">
-                <a16:creationId xmlns:a16="http://schemas.microsoft.com/office/drawing/2014/main" id="{A2D8A6D6-5A49-46F7-8AC4-D6254B37C82A}"/>
+                <a16:creationId xmlns:a16="http://schemas.microsoft.com/office/drawing/2014/main" id="{9EDFBF68-94E1-445A-9556-759B9580ED01}"/>
               </a:ext>
             </a:extLst>
           </p:cNvPr>
@@ -1302,7 +1302,7 @@
           <p:cNvPr id="1" name="Slide Number Placeholder 5">
             <a:extLst xmlns:a="http://schemas.openxmlformats.org/drawingml/2006/main">
               <a:ext uri="{FF2B5EF4-FFF2-40B4-BE49-F238E27FC236}">
-                <a16:creationId xmlns:a16="http://schemas.microsoft.com/office/drawing/2014/main" id="{738EACFD-2F06-43E0-89CA-7EEF414ACFD3}"/>
+                <a16:creationId xmlns:a16="http://schemas.microsoft.com/office/drawing/2014/main" id="{59CA0FE0-2822-41E7-AB01-78CDC723CED9}"/>
               </a:ext>
             </a:extLst>
           </p:cNvPr>
@@ -1341,7 +1341,7 @@
   </p:cSld>
   <p:clrMap bg1="lt1" tx1="dk1" bg2="lt2" tx2="dk2" accent1="accent1" accent2="accent2" accent3="accent3" accent4="accent4" accent5="accent5" accent6="accent6" hlink="hlink" folHlink="folHlink"/>
   <p:sldLayoutIdLst>
-    <p:sldLayoutId xmlns:r="http://schemas.openxmlformats.org/officeDocument/2006/relationships" id="2147483649" r:id="Rd91b56798e0244b7"/>
+    <p:sldLayoutId xmlns:r="http://schemas.openxmlformats.org/officeDocument/2006/relationships" id="2147483649" r:id="R506570b88a01488d"/>
   </p:sldLayoutIdLst>
   <p:txStyles>
     <p:titleStyle>
@@ -1647,7 +1647,7 @@
           <p:cNvPr id="1" name="Slide Number Placeholder 5">
             <a:extLst xmlns:a="http://schemas.openxmlformats.org/drawingml/2006/main">
               <a:ext uri="{FF2B5EF4-FFF2-40B4-BE49-F238E27FC236}">
-                <a16:creationId xmlns:a16="http://schemas.microsoft.com/office/drawing/2014/main" id="{A2D8A6D6-5A49-46F7-8AC4-D6254B37C82A}"/>
+                <a16:creationId xmlns:a16="http://schemas.microsoft.com/office/drawing/2014/main" id="{9EDFBF68-94E1-445A-9556-759B9580ED01}"/>
               </a:ext>
             </a:extLst>
           </p:cNvPr>
@@ -1679,7 +1679,7 @@
           <p:cNvPr id="2" name="">
             <a:extLst xmlns:a="http://schemas.openxmlformats.org/drawingml/2006/main">
               <a:ext uri="{FF2B5EF4-FFF2-40B4-BE49-F238E27FC236}">
-                <a16:creationId xmlns:a16="http://schemas.microsoft.com/office/drawing/2014/main" id="{328981B5-EA97-469F-B949-F5D6195678AC}"/>
+                <a16:creationId xmlns:a16="http://schemas.microsoft.com/office/drawing/2014/main" id="{07813E9D-99C1-4467-B5DF-3F8F2DFE41E5}"/>
               </a:ext>
             </a:extLst>
           </p:cNvPr>
@@ -1714,7 +1714,7 @@
           <p:cNvPr id="3" name="">
             <a:extLst xmlns:a="http://schemas.openxmlformats.org/drawingml/2006/main">
               <a:ext uri="{FF2B5EF4-FFF2-40B4-BE49-F238E27FC236}">
-                <a16:creationId xmlns:a16="http://schemas.microsoft.com/office/drawing/2014/main" id="{C694B299-57C6-45D6-A539-2976FA84531C}"/>
+                <a16:creationId xmlns:a16="http://schemas.microsoft.com/office/drawing/2014/main" id="{D84E0AF7-CEE6-495A-A564-9558F7CD875F}"/>
               </a:ext>
             </a:extLst>
           </p:cNvPr>
@@ -1749,7 +1749,7 @@
           <p:cNvPr id="4" name="">
             <a:extLst xmlns:a="http://schemas.openxmlformats.org/drawingml/2006/main">
               <a:ext uri="{FF2B5EF4-FFF2-40B4-BE49-F238E27FC236}">
-                <a16:creationId xmlns:a16="http://schemas.microsoft.com/office/drawing/2014/main" id="{64CDD56F-4A00-4CEA-ACD5-13184CDBC1EC}"/>
+                <a16:creationId xmlns:a16="http://schemas.microsoft.com/office/drawing/2014/main" id="{829DF830-C953-4537-8BA7-77F9BC5EB24F}"/>
               </a:ext>
             </a:extLst>
           </p:cNvPr>
@@ -1784,7 +1784,7 @@
           <p:cNvPr id="5" name="">
             <a:extLst xmlns:a="http://schemas.openxmlformats.org/drawingml/2006/main">
               <a:ext uri="{FF2B5EF4-FFF2-40B4-BE49-F238E27FC236}">
-                <a16:creationId xmlns:a16="http://schemas.microsoft.com/office/drawing/2014/main" id="{A69F668D-3457-451C-A1FC-EC42C7BF05DE}"/>
+                <a16:creationId xmlns:a16="http://schemas.microsoft.com/office/drawing/2014/main" id="{A5501515-ACF9-4F1A-950C-50F1406EDEDD}"/>
               </a:ext>
             </a:extLst>
           </p:cNvPr>
@@ -1819,7 +1819,7 @@
           <p:cNvPr id="6" name="">
             <a:extLst xmlns:a="http://schemas.openxmlformats.org/drawingml/2006/main">
               <a:ext uri="{FF2B5EF4-FFF2-40B4-BE49-F238E27FC236}">
-                <a16:creationId xmlns:a16="http://schemas.microsoft.com/office/drawing/2014/main" id="{2563A13F-0F74-4608-82C0-9C06C20A898A}"/>
+                <a16:creationId xmlns:a16="http://schemas.microsoft.com/office/drawing/2014/main" id="{0F12369D-BC7E-42E1-B4DE-C79531910E99}"/>
               </a:ext>
             </a:extLst>
           </p:cNvPr>
@@ -1854,7 +1854,7 @@
           <p:cNvPr id="7" name="">
             <a:extLst xmlns:a="http://schemas.openxmlformats.org/drawingml/2006/main">
               <a:ext uri="{FF2B5EF4-FFF2-40B4-BE49-F238E27FC236}">
-                <a16:creationId xmlns:a16="http://schemas.microsoft.com/office/drawing/2014/main" id="{2BBA161C-D1DC-430C-A021-CB38CC62C5F9}"/>
+                <a16:creationId xmlns:a16="http://schemas.microsoft.com/office/drawing/2014/main" id="{4AC57C97-21D8-4E20-870C-51135256411F}"/>
               </a:ext>
             </a:extLst>
           </p:cNvPr>
@@ -1889,7 +1889,7 @@
           <p:cNvPr id="8" name="">
             <a:extLst xmlns:a="http://schemas.openxmlformats.org/drawingml/2006/main">
               <a:ext uri="{FF2B5EF4-FFF2-40B4-BE49-F238E27FC236}">
-                <a16:creationId xmlns:a16="http://schemas.microsoft.com/office/drawing/2014/main" id="{50163219-7D42-4AFC-953A-EE2CA8638465}"/>
+                <a16:creationId xmlns:a16="http://schemas.microsoft.com/office/drawing/2014/main" id="{A427700C-2200-4E32-9CC8-4FF744522DD5}"/>
               </a:ext>
             </a:extLst>
           </p:cNvPr>
@@ -1947,7 +1947,7 @@
           <p:cNvPr id="9" name="">
             <a:extLst xmlns:a="http://schemas.openxmlformats.org/drawingml/2006/main">
               <a:ext uri="{FF2B5EF4-FFF2-40B4-BE49-F238E27FC236}">
-                <a16:creationId xmlns:a16="http://schemas.microsoft.com/office/drawing/2014/main" id="{5B1759A0-B7A9-44FA-82E6-7CBC4F8BDCE3}"/>
+                <a16:creationId xmlns:a16="http://schemas.microsoft.com/office/drawing/2014/main" id="{0FCD9E2E-1411-4523-90BA-FD3756D72CD4}"/>
               </a:ext>
             </a:extLst>
           </p:cNvPr>
@@ -1982,7 +1982,7 @@
           <p:cNvPr id="10" name="">
             <a:extLst xmlns:a="http://schemas.openxmlformats.org/drawingml/2006/main">
               <a:ext uri="{FF2B5EF4-FFF2-40B4-BE49-F238E27FC236}">
-                <a16:creationId xmlns:a16="http://schemas.microsoft.com/office/drawing/2014/main" id="{B437E982-EFDB-4B99-9918-5ECAF79E6BB1}"/>
+                <a16:creationId xmlns:a16="http://schemas.microsoft.com/office/drawing/2014/main" id="{66D5596C-BE75-4747-B917-ED111E83E6B2}"/>
               </a:ext>
             </a:extLst>
           </p:cNvPr>
@@ -2040,7 +2040,7 @@
           <p:cNvPr id="11" name="">
             <a:extLst xmlns:a="http://schemas.openxmlformats.org/drawingml/2006/main">
               <a:ext uri="{FF2B5EF4-FFF2-40B4-BE49-F238E27FC236}">
-                <a16:creationId xmlns:a16="http://schemas.microsoft.com/office/drawing/2014/main" id="{490D869B-97EB-405F-AE63-9C85BEF6E285}"/>
+                <a16:creationId xmlns:a16="http://schemas.microsoft.com/office/drawing/2014/main" id="{9DB66086-E205-4312-A8F2-839FC32CC246}"/>
               </a:ext>
             </a:extLst>
           </p:cNvPr>
@@ -2100,7 +2100,7 @@
           <p:cNvPr id="12" name="">
             <a:extLst xmlns:a="http://schemas.openxmlformats.org/drawingml/2006/main">
               <a:ext uri="{FF2B5EF4-FFF2-40B4-BE49-F238E27FC236}">
-                <a16:creationId xmlns:a16="http://schemas.microsoft.com/office/drawing/2014/main" id="{AB938AB1-8A8F-4E91-9D40-AC5C1164C6D8}"/>
+                <a16:creationId xmlns:a16="http://schemas.microsoft.com/office/drawing/2014/main" id="{0123E606-FAAF-4463-BA2C-FBA5701BF30B}"/>
               </a:ext>
             </a:extLst>
           </p:cNvPr>
@@ -2133,7 +2133,7 @@
         </p:spPr>
         <p:txBody>
           <a:bodyPr xmlns:a="http://schemas.openxmlformats.org/drawingml/2006/main" lIns="0" tIns="0" rIns="0" bIns="0" anchor="t">
-            <a:normAutofit fontScale="97489"/>
+            <a:normAutofit fontScale="87633"/>
           </a:bodyPr>
           <a:lstStyle xmlns:a="http://schemas.openxmlformats.org/drawingml/2006/main"/>
           <a:p xmlns:a="http://schemas.openxmlformats.org/drawingml/2006/main">
@@ -2150,7 +2150,7 @@
                   <a:srgbClr val="5D757C"/>
                 </a:solidFill>
               </a:rPr>
-              <a:t>Renvoo helps dental clinics reduce no-shows, handle late cancellations earlier, and recover lost appointment capacity without adding front-desk work.</a:t>
+              <a:t>Renvoo is a B2B clinic SaaS for Dutch dental clinics that helps reduce no-shows, handle late cancellations earlier, and recover lost appointment capacity without adding front-desk work.</a:t>
             </a:r>
           </a:p>
         </p:txBody>
@@ -2160,7 +2160,7 @@
           <p:cNvPr id="13" name="">
             <a:extLst xmlns:a="http://schemas.openxmlformats.org/drawingml/2006/main">
               <a:ext uri="{FF2B5EF4-FFF2-40B4-BE49-F238E27FC236}">
-                <a16:creationId xmlns:a16="http://schemas.microsoft.com/office/drawing/2014/main" id="{813273CD-D6C0-4787-A624-B4A985197284}"/>
+                <a16:creationId xmlns:a16="http://schemas.microsoft.com/office/drawing/2014/main" id="{75BC0878-CA50-4279-BACB-511D2402D2B1}"/>
               </a:ext>
             </a:extLst>
           </p:cNvPr>
@@ -2195,7 +2195,7 @@
           <p:cNvPr id="14" name="">
             <a:extLst xmlns:a="http://schemas.openxmlformats.org/drawingml/2006/main">
               <a:ext uri="{FF2B5EF4-FFF2-40B4-BE49-F238E27FC236}">
-                <a16:creationId xmlns:a16="http://schemas.microsoft.com/office/drawing/2014/main" id="{1433E2D3-EF27-497D-862B-CEEB10746FFE}"/>
+                <a16:creationId xmlns:a16="http://schemas.microsoft.com/office/drawing/2014/main" id="{959C9129-D143-446B-89F6-51C28099E205}"/>
               </a:ext>
             </a:extLst>
           </p:cNvPr>
@@ -2253,7 +2253,7 @@
           <p:cNvPr id="15" name="">
             <a:extLst xmlns:a="http://schemas.openxmlformats.org/drawingml/2006/main">
               <a:ext uri="{FF2B5EF4-FFF2-40B4-BE49-F238E27FC236}">
-                <a16:creationId xmlns:a16="http://schemas.microsoft.com/office/drawing/2014/main" id="{8EC02A28-BC09-44DC-8655-D450DA793C94}"/>
+                <a16:creationId xmlns:a16="http://schemas.microsoft.com/office/drawing/2014/main" id="{DB289E8A-1201-404F-8E62-116052EC8DEF}"/>
               </a:ext>
             </a:extLst>
           </p:cNvPr>
@@ -2288,7 +2288,7 @@
           <p:cNvPr id="16" name="">
             <a:extLst xmlns:a="http://schemas.openxmlformats.org/drawingml/2006/main">
               <a:ext uri="{FF2B5EF4-FFF2-40B4-BE49-F238E27FC236}">
-                <a16:creationId xmlns:a16="http://schemas.microsoft.com/office/drawing/2014/main" id="{0D272B72-014D-4C83-B25F-21A24223A8C8}"/>
+                <a16:creationId xmlns:a16="http://schemas.microsoft.com/office/drawing/2014/main" id="{1DF0DE6E-FEB0-44C9-9BA9-BF866C44D71A}"/>
               </a:ext>
             </a:extLst>
           </p:cNvPr>
@@ -2346,7 +2346,7 @@
           <p:cNvPr id="17" name="">
             <a:extLst xmlns:a="http://schemas.openxmlformats.org/drawingml/2006/main">
               <a:ext uri="{FF2B5EF4-FFF2-40B4-BE49-F238E27FC236}">
-                <a16:creationId xmlns:a16="http://schemas.microsoft.com/office/drawing/2014/main" id="{BC3B1B29-19E2-4B26-A429-6BC2F6530201}"/>
+                <a16:creationId xmlns:a16="http://schemas.microsoft.com/office/drawing/2014/main" id="{7463330F-7C6F-4541-AA44-EFCA97B251E8}"/>
               </a:ext>
             </a:extLst>
           </p:cNvPr>
@@ -2381,7 +2381,7 @@
           <p:cNvPr id="18" name="">
             <a:extLst xmlns:a="http://schemas.openxmlformats.org/drawingml/2006/main">
               <a:ext uri="{FF2B5EF4-FFF2-40B4-BE49-F238E27FC236}">
-                <a16:creationId xmlns:a16="http://schemas.microsoft.com/office/drawing/2014/main" id="{425E2FDF-FE62-4653-8338-2A75197E1162}"/>
+                <a16:creationId xmlns:a16="http://schemas.microsoft.com/office/drawing/2014/main" id="{B79FE0BE-847F-4FB7-B2DA-E4FBA6356790}"/>
               </a:ext>
             </a:extLst>
           </p:cNvPr>
@@ -2439,7 +2439,7 @@
           <p:cNvPr id="19" name="">
             <a:extLst xmlns:a="http://schemas.openxmlformats.org/drawingml/2006/main">
               <a:ext uri="{FF2B5EF4-FFF2-40B4-BE49-F238E27FC236}">
-                <a16:creationId xmlns:a16="http://schemas.microsoft.com/office/drawing/2014/main" id="{7042E34E-899E-48D4-8AD5-2A2EEC166090}"/>
+                <a16:creationId xmlns:a16="http://schemas.microsoft.com/office/drawing/2014/main" id="{84C5255E-76B3-4D97-B967-3C05A0E99CDB}"/>
               </a:ext>
             </a:extLst>
           </p:cNvPr>
@@ -2474,7 +2474,7 @@
           <p:cNvPr id="20" name="">
             <a:extLst xmlns:a="http://schemas.openxmlformats.org/drawingml/2006/main">
               <a:ext uri="{FF2B5EF4-FFF2-40B4-BE49-F238E27FC236}">
-                <a16:creationId xmlns:a16="http://schemas.microsoft.com/office/drawing/2014/main" id="{5018845D-B726-4381-9BAB-319693EBDC25}"/>
+                <a16:creationId xmlns:a16="http://schemas.microsoft.com/office/drawing/2014/main" id="{66FF5B60-43B4-4DFD-B3E7-F14A7CB06033}"/>
               </a:ext>
             </a:extLst>
           </p:cNvPr>
@@ -2509,7 +2509,7 @@
           <p:cNvPr id="21" name="">
             <a:extLst xmlns:a="http://schemas.openxmlformats.org/drawingml/2006/main">
               <a:ext uri="{FF2B5EF4-FFF2-40B4-BE49-F238E27FC236}">
-                <a16:creationId xmlns:a16="http://schemas.microsoft.com/office/drawing/2014/main" id="{43639263-F107-4754-9C18-14F01A8E81D9}"/>
+                <a16:creationId xmlns:a16="http://schemas.microsoft.com/office/drawing/2014/main" id="{1C9892D3-53F1-49D1-95E3-36FC4DE619F2}"/>
               </a:ext>
             </a:extLst>
           </p:cNvPr>
@@ -2569,7 +2569,7 @@
           <p:cNvPr id="22" name="">
             <a:extLst xmlns:a="http://schemas.openxmlformats.org/drawingml/2006/main">
               <a:ext uri="{FF2B5EF4-FFF2-40B4-BE49-F238E27FC236}">
-                <a16:creationId xmlns:a16="http://schemas.microsoft.com/office/drawing/2014/main" id="{D25A9275-CE8A-467F-8955-37E80189DE0D}"/>
+                <a16:creationId xmlns:a16="http://schemas.microsoft.com/office/drawing/2014/main" id="{CCA8AB47-6B86-4EB3-9DC3-FB5C841715C6}"/>
               </a:ext>
             </a:extLst>
           </p:cNvPr>
@@ -2629,7 +2629,7 @@
           <p:cNvPr id="23" name="">
             <a:extLst xmlns:a="http://schemas.openxmlformats.org/drawingml/2006/main">
               <a:ext uri="{FF2B5EF4-FFF2-40B4-BE49-F238E27FC236}">
-                <a16:creationId xmlns:a16="http://schemas.microsoft.com/office/drawing/2014/main" id="{F2E2BC82-56CF-4116-89B9-6462B80F7529}"/>
+                <a16:creationId xmlns:a16="http://schemas.microsoft.com/office/drawing/2014/main" id="{407B2FEC-FBCB-4974-839B-C736FB5CCE51}"/>
               </a:ext>
             </a:extLst>
           </p:cNvPr>
@@ -2664,7 +2664,7 @@
           <p:cNvPr id="24" name="">
             <a:extLst xmlns:a="http://schemas.openxmlformats.org/drawingml/2006/main">
               <a:ext uri="{FF2B5EF4-FFF2-40B4-BE49-F238E27FC236}">
-                <a16:creationId xmlns:a16="http://schemas.microsoft.com/office/drawing/2014/main" id="{87681DF6-863F-4DE3-8CDB-7F1B77D84C12}"/>
+                <a16:creationId xmlns:a16="http://schemas.microsoft.com/office/drawing/2014/main" id="{EC59CC0A-79C1-42BE-94A7-F323CD9D5B34}"/>
               </a:ext>
             </a:extLst>
           </p:cNvPr>
@@ -2699,7 +2699,7 @@
           <p:cNvPr id="25" name="">
             <a:extLst xmlns:a="http://schemas.openxmlformats.org/drawingml/2006/main">
               <a:ext uri="{FF2B5EF4-FFF2-40B4-BE49-F238E27FC236}">
-                <a16:creationId xmlns:a16="http://schemas.microsoft.com/office/drawing/2014/main" id="{1B6D4B17-7634-4F3E-AFD0-27B5E4E022F7}"/>
+                <a16:creationId xmlns:a16="http://schemas.microsoft.com/office/drawing/2014/main" id="{CABB44AC-5D5F-4FC1-A323-5729F2E4DC87}"/>
               </a:ext>
             </a:extLst>
           </p:cNvPr>
@@ -2734,7 +2734,7 @@
           <p:cNvPr id="26" name="">
             <a:extLst xmlns:a="http://schemas.openxmlformats.org/drawingml/2006/main">
               <a:ext uri="{FF2B5EF4-FFF2-40B4-BE49-F238E27FC236}">
-                <a16:creationId xmlns:a16="http://schemas.microsoft.com/office/drawing/2014/main" id="{3E4F50CA-F2B8-40D1-9A02-E5DF62488999}"/>
+                <a16:creationId xmlns:a16="http://schemas.microsoft.com/office/drawing/2014/main" id="{DB6F8701-2A7B-4868-BF61-4A9826061745}"/>
               </a:ext>
             </a:extLst>
           </p:cNvPr>
@@ -2792,7 +2792,7 @@
           <p:cNvPr id="27" name="">
             <a:extLst xmlns:a="http://schemas.openxmlformats.org/drawingml/2006/main">
               <a:ext uri="{FF2B5EF4-FFF2-40B4-BE49-F238E27FC236}">
-                <a16:creationId xmlns:a16="http://schemas.microsoft.com/office/drawing/2014/main" id="{A7146E1C-E1CF-4794-B77D-3551F255F8F1}"/>
+                <a16:creationId xmlns:a16="http://schemas.microsoft.com/office/drawing/2014/main" id="{29B2FDD0-40E4-4C24-B2A6-58032A11F091}"/>
               </a:ext>
             </a:extLst>
           </p:cNvPr>
@@ -2827,7 +2827,7 @@
           <p:cNvPr id="28" name="">
             <a:extLst xmlns:a="http://schemas.openxmlformats.org/drawingml/2006/main">
               <a:ext uri="{FF2B5EF4-FFF2-40B4-BE49-F238E27FC236}">
-                <a16:creationId xmlns:a16="http://schemas.microsoft.com/office/drawing/2014/main" id="{FE2AC359-F81B-4542-9B35-2D57DDB4CDF3}"/>
+                <a16:creationId xmlns:a16="http://schemas.microsoft.com/office/drawing/2014/main" id="{02DABD74-54E3-449B-A146-B6EDD6C8F559}"/>
               </a:ext>
             </a:extLst>
           </p:cNvPr>
@@ -2862,7 +2862,7 @@
           <p:cNvPr id="29" name="">
             <a:extLst xmlns:a="http://schemas.openxmlformats.org/drawingml/2006/main">
               <a:ext uri="{FF2B5EF4-FFF2-40B4-BE49-F238E27FC236}">
-                <a16:creationId xmlns:a16="http://schemas.microsoft.com/office/drawing/2014/main" id="{5F703A69-D8D9-410D-9CAD-01F5D7FC10CF}"/>
+                <a16:creationId xmlns:a16="http://schemas.microsoft.com/office/drawing/2014/main" id="{07EA7C11-D3FC-4061-B3E9-2906256B1692}"/>
               </a:ext>
             </a:extLst>
           </p:cNvPr>
@@ -2897,7 +2897,7 @@
           <p:cNvPr id="30" name="">
             <a:extLst xmlns:a="http://schemas.openxmlformats.org/drawingml/2006/main">
               <a:ext uri="{FF2B5EF4-FFF2-40B4-BE49-F238E27FC236}">
-                <a16:creationId xmlns:a16="http://schemas.microsoft.com/office/drawing/2014/main" id="{8D50CFA6-A269-4A63-AB1E-72A44A4F3EC1}"/>
+                <a16:creationId xmlns:a16="http://schemas.microsoft.com/office/drawing/2014/main" id="{8148BB71-84C1-46CE-BCE7-2DB28BC2B176}"/>
               </a:ext>
             </a:extLst>
           </p:cNvPr>
@@ -2932,7 +2932,7 @@
           <p:cNvPr id="31" name="">
             <a:extLst xmlns:a="http://schemas.openxmlformats.org/drawingml/2006/main">
               <a:ext uri="{FF2B5EF4-FFF2-40B4-BE49-F238E27FC236}">
-                <a16:creationId xmlns:a16="http://schemas.microsoft.com/office/drawing/2014/main" id="{F3291FBC-B2D1-4659-A137-E2696BA63D82}"/>
+                <a16:creationId xmlns:a16="http://schemas.microsoft.com/office/drawing/2014/main" id="{FC3BDDBE-F61D-4F5B-AD66-78999D2E43D0}"/>
               </a:ext>
             </a:extLst>
           </p:cNvPr>
@@ -2967,7 +2967,7 @@
           <p:cNvPr id="32" name="">
             <a:extLst xmlns:a="http://schemas.openxmlformats.org/drawingml/2006/main">
               <a:ext uri="{FF2B5EF4-FFF2-40B4-BE49-F238E27FC236}">
-                <a16:creationId xmlns:a16="http://schemas.microsoft.com/office/drawing/2014/main" id="{2362D4EB-22AD-4761-9513-0021B075119E}"/>
+                <a16:creationId xmlns:a16="http://schemas.microsoft.com/office/drawing/2014/main" id="{FB0C66D7-2E4A-4482-AF72-5D7D06515EBE}"/>
               </a:ext>
             </a:extLst>
           </p:cNvPr>
@@ -3002,7 +3002,7 @@
           <p:cNvPr id="33" name="">
             <a:extLst xmlns:a="http://schemas.openxmlformats.org/drawingml/2006/main">
               <a:ext uri="{FF2B5EF4-FFF2-40B4-BE49-F238E27FC236}">
-                <a16:creationId xmlns:a16="http://schemas.microsoft.com/office/drawing/2014/main" id="{942F62E7-DD3A-4F29-B753-48663BB35657}"/>
+                <a16:creationId xmlns:a16="http://schemas.microsoft.com/office/drawing/2014/main" id="{30E6CBC4-C5A2-4AC1-A7A6-7DB06E3B3972}"/>
               </a:ext>
             </a:extLst>
           </p:cNvPr>
@@ -3037,7 +3037,7 @@
           <p:cNvPr id="34" name="">
             <a:extLst xmlns:a="http://schemas.openxmlformats.org/drawingml/2006/main">
               <a:ext uri="{FF2B5EF4-FFF2-40B4-BE49-F238E27FC236}">
-                <a16:creationId xmlns:a16="http://schemas.microsoft.com/office/drawing/2014/main" id="{4920A6DE-897E-4D9A-BEEB-97978FBBC914}"/>
+                <a16:creationId xmlns:a16="http://schemas.microsoft.com/office/drawing/2014/main" id="{EF9E99F8-2205-45FB-B5EA-6905BBFAE6A2}"/>
               </a:ext>
             </a:extLst>
           </p:cNvPr>
@@ -3072,7 +3072,7 @@
           <p:cNvPr id="35" name="">
             <a:extLst xmlns:a="http://schemas.openxmlformats.org/drawingml/2006/main">
               <a:ext uri="{FF2B5EF4-FFF2-40B4-BE49-F238E27FC236}">
-                <a16:creationId xmlns:a16="http://schemas.microsoft.com/office/drawing/2014/main" id="{ABDA5F11-9FDF-4836-8C0B-39E3FCBA2881}"/>
+                <a16:creationId xmlns:a16="http://schemas.microsoft.com/office/drawing/2014/main" id="{A3C1A566-7447-47F6-8956-F1CD7A3687F5}"/>
               </a:ext>
             </a:extLst>
           </p:cNvPr>
@@ -3107,7 +3107,7 @@
           <p:cNvPr id="36" name="">
             <a:extLst xmlns:a="http://schemas.openxmlformats.org/drawingml/2006/main">
               <a:ext uri="{FF2B5EF4-FFF2-40B4-BE49-F238E27FC236}">
-                <a16:creationId xmlns:a16="http://schemas.microsoft.com/office/drawing/2014/main" id="{3D9CA665-258B-45A2-8576-AD21DCFB55A8}"/>
+                <a16:creationId xmlns:a16="http://schemas.microsoft.com/office/drawing/2014/main" id="{F750E227-99F0-4179-8D13-BC7D47ED862F}"/>
               </a:ext>
             </a:extLst>
           </p:cNvPr>
@@ -3142,7 +3142,7 @@
           <p:cNvPr id="37" name="">
             <a:extLst xmlns:a="http://schemas.openxmlformats.org/drawingml/2006/main">
               <a:ext uri="{FF2B5EF4-FFF2-40B4-BE49-F238E27FC236}">
-                <a16:creationId xmlns:a16="http://schemas.microsoft.com/office/drawing/2014/main" id="{7ED9190F-DD4C-4DAB-983B-E00E9D5E8B63}"/>
+                <a16:creationId xmlns:a16="http://schemas.microsoft.com/office/drawing/2014/main" id="{8C653C13-E303-4007-A2FF-0DC98871F0FC}"/>
               </a:ext>
             </a:extLst>
           </p:cNvPr>
@@ -3177,7 +3177,7 @@
           <p:cNvPr id="38" name="">
             <a:extLst xmlns:a="http://schemas.openxmlformats.org/drawingml/2006/main">
               <a:ext uri="{FF2B5EF4-FFF2-40B4-BE49-F238E27FC236}">
-                <a16:creationId xmlns:a16="http://schemas.microsoft.com/office/drawing/2014/main" id="{E4E26CA8-2AE3-4870-B563-F73F0D257733}"/>
+                <a16:creationId xmlns:a16="http://schemas.microsoft.com/office/drawing/2014/main" id="{AAC51D6E-BD00-4B5D-AA2A-FB02665760EE}"/>
               </a:ext>
             </a:extLst>
           </p:cNvPr>
@@ -3212,7 +3212,7 @@
           <p:cNvPr id="39" name="">
             <a:extLst xmlns:a="http://schemas.openxmlformats.org/drawingml/2006/main">
               <a:ext uri="{FF2B5EF4-FFF2-40B4-BE49-F238E27FC236}">
-                <a16:creationId xmlns:a16="http://schemas.microsoft.com/office/drawing/2014/main" id="{1483AA75-8DD8-4C71-ACB6-2F92B4E07573}"/>
+                <a16:creationId xmlns:a16="http://schemas.microsoft.com/office/drawing/2014/main" id="{FCCA952E-9E56-4B2E-9170-13E6AFBAF00F}"/>
               </a:ext>
             </a:extLst>
           </p:cNvPr>
@@ -3247,7 +3247,7 @@
           <p:cNvPr id="40" name="">
             <a:extLst xmlns:a="http://schemas.openxmlformats.org/drawingml/2006/main">
               <a:ext uri="{FF2B5EF4-FFF2-40B4-BE49-F238E27FC236}">
-                <a16:creationId xmlns:a16="http://schemas.microsoft.com/office/drawing/2014/main" id="{2D19B3BD-5EEA-456E-AA43-F274358FB88F}"/>
+                <a16:creationId xmlns:a16="http://schemas.microsoft.com/office/drawing/2014/main" id="{58C2158A-86C3-4B9A-9AB2-FA00E2E62A77}"/>
               </a:ext>
             </a:extLst>
           </p:cNvPr>
@@ -3282,7 +3282,7 @@
           <p:cNvPr id="41" name="">
             <a:extLst xmlns:a="http://schemas.openxmlformats.org/drawingml/2006/main">
               <a:ext uri="{FF2B5EF4-FFF2-40B4-BE49-F238E27FC236}">
-                <a16:creationId xmlns:a16="http://schemas.microsoft.com/office/drawing/2014/main" id="{89A662B1-8C42-4694-BF46-9BCAD87E7313}"/>
+                <a16:creationId xmlns:a16="http://schemas.microsoft.com/office/drawing/2014/main" id="{33C1ED37-47B6-43E0-BCCA-F9ABE78D654E}"/>
               </a:ext>
             </a:extLst>
           </p:cNvPr>
@@ -3317,7 +3317,7 @@
           <p:cNvPr id="42" name="">
             <a:extLst xmlns:a="http://schemas.openxmlformats.org/drawingml/2006/main">
               <a:ext uri="{FF2B5EF4-FFF2-40B4-BE49-F238E27FC236}">
-                <a16:creationId xmlns:a16="http://schemas.microsoft.com/office/drawing/2014/main" id="{E3F10781-48BF-44EE-A27C-DEA5674E1031}"/>
+                <a16:creationId xmlns:a16="http://schemas.microsoft.com/office/drawing/2014/main" id="{C332E105-12F8-45BC-83FF-82492F0915EE}"/>
               </a:ext>
             </a:extLst>
           </p:cNvPr>
@@ -3352,7 +3352,7 @@
           <p:cNvPr id="43" name="">
             <a:extLst xmlns:a="http://schemas.openxmlformats.org/drawingml/2006/main">
               <a:ext uri="{FF2B5EF4-FFF2-40B4-BE49-F238E27FC236}">
-                <a16:creationId xmlns:a16="http://schemas.microsoft.com/office/drawing/2014/main" id="{AFE28CEA-F335-412A-A1BB-5E01749170BF}"/>
+                <a16:creationId xmlns:a16="http://schemas.microsoft.com/office/drawing/2014/main" id="{F45BFB67-774F-4CB8-B591-699BC09BEBEE}"/>
               </a:ext>
             </a:extLst>
           </p:cNvPr>
@@ -3387,7 +3387,7 @@
           <p:cNvPr id="44" name="">
             <a:extLst xmlns:a="http://schemas.openxmlformats.org/drawingml/2006/main">
               <a:ext uri="{FF2B5EF4-FFF2-40B4-BE49-F238E27FC236}">
-                <a16:creationId xmlns:a16="http://schemas.microsoft.com/office/drawing/2014/main" id="{0D1A5E15-045E-4C04-A570-1DDD383B5F02}"/>
+                <a16:creationId xmlns:a16="http://schemas.microsoft.com/office/drawing/2014/main" id="{F5508150-9C95-4073-9699-4180E0D4D7DB}"/>
               </a:ext>
             </a:extLst>
           </p:cNvPr>
@@ -3422,7 +3422,7 @@
           <p:cNvPr id="45" name="">
             <a:extLst xmlns:a="http://schemas.openxmlformats.org/drawingml/2006/main">
               <a:ext uri="{FF2B5EF4-FFF2-40B4-BE49-F238E27FC236}">
-                <a16:creationId xmlns:a16="http://schemas.microsoft.com/office/drawing/2014/main" id="{BEA3DE81-1AA7-4AEE-8232-FF4F15BA3C44}"/>
+                <a16:creationId xmlns:a16="http://schemas.microsoft.com/office/drawing/2014/main" id="{4E61A110-9363-42B1-948D-178DD396A919}"/>
               </a:ext>
             </a:extLst>
           </p:cNvPr>
@@ -3457,7 +3457,7 @@
           <p:cNvPr id="46" name="">
             <a:extLst xmlns:a="http://schemas.openxmlformats.org/drawingml/2006/main">
               <a:ext uri="{FF2B5EF4-FFF2-40B4-BE49-F238E27FC236}">
-                <a16:creationId xmlns:a16="http://schemas.microsoft.com/office/drawing/2014/main" id="{5D61E367-C4C4-4420-83C7-64D4D22BAD14}"/>
+                <a16:creationId xmlns:a16="http://schemas.microsoft.com/office/drawing/2014/main" id="{3864F1DF-2A78-4313-BADA-F9C322024E6E}"/>
               </a:ext>
             </a:extLst>
           </p:cNvPr>
@@ -3492,7 +3492,7 @@
           <p:cNvPr id="47" name="">
             <a:extLst xmlns:a="http://schemas.openxmlformats.org/drawingml/2006/main">
               <a:ext uri="{FF2B5EF4-FFF2-40B4-BE49-F238E27FC236}">
-                <a16:creationId xmlns:a16="http://schemas.microsoft.com/office/drawing/2014/main" id="{189E5881-662D-4B5A-B055-86DBFC056CC0}"/>
+                <a16:creationId xmlns:a16="http://schemas.microsoft.com/office/drawing/2014/main" id="{B30021EF-6C93-4924-91C1-997FD5BED20C}"/>
               </a:ext>
             </a:extLst>
           </p:cNvPr>
@@ -3527,7 +3527,7 @@
           <p:cNvPr id="48" name="">
             <a:extLst xmlns:a="http://schemas.openxmlformats.org/drawingml/2006/main">
               <a:ext uri="{FF2B5EF4-FFF2-40B4-BE49-F238E27FC236}">
-                <a16:creationId xmlns:a16="http://schemas.microsoft.com/office/drawing/2014/main" id="{FA7625C3-F12A-42AC-A186-D693C5F0302C}"/>
+                <a16:creationId xmlns:a16="http://schemas.microsoft.com/office/drawing/2014/main" id="{42A12B04-8B29-457A-ABBC-3421527A44DD}"/>
               </a:ext>
             </a:extLst>
           </p:cNvPr>
@@ -3562,7 +3562,7 @@
           <p:cNvPr id="49" name="">
             <a:extLst xmlns:a="http://schemas.openxmlformats.org/drawingml/2006/main">
               <a:ext uri="{FF2B5EF4-FFF2-40B4-BE49-F238E27FC236}">
-                <a16:creationId xmlns:a16="http://schemas.microsoft.com/office/drawing/2014/main" id="{777FCB6C-A68B-435C-9482-B009C355483F}"/>
+                <a16:creationId xmlns:a16="http://schemas.microsoft.com/office/drawing/2014/main" id="{F7CD5B0B-8126-4954-A87E-93ED1E0D44E1}"/>
               </a:ext>
             </a:extLst>
           </p:cNvPr>
@@ -3597,7 +3597,7 @@
           <p:cNvPr id="50" name="">
             <a:extLst xmlns:a="http://schemas.openxmlformats.org/drawingml/2006/main">
               <a:ext uri="{FF2B5EF4-FFF2-40B4-BE49-F238E27FC236}">
-                <a16:creationId xmlns:a16="http://schemas.microsoft.com/office/drawing/2014/main" id="{A75FD627-A770-42CB-90E5-2D0DE42C5816}"/>
+                <a16:creationId xmlns:a16="http://schemas.microsoft.com/office/drawing/2014/main" id="{0FDD63D0-B9D8-4011-A956-87E1D6AE45BE}"/>
               </a:ext>
             </a:extLst>
           </p:cNvPr>
@@ -3655,7 +3655,7 @@
           <p:cNvPr id="51" name="">
             <a:extLst xmlns:a="http://schemas.openxmlformats.org/drawingml/2006/main">
               <a:ext uri="{FF2B5EF4-FFF2-40B4-BE49-F238E27FC236}">
-                <a16:creationId xmlns:a16="http://schemas.microsoft.com/office/drawing/2014/main" id="{E69494AF-C48F-4C17-9928-66163602826D}"/>
+                <a16:creationId xmlns:a16="http://schemas.microsoft.com/office/drawing/2014/main" id="{9DF7E1A0-3A95-4DC6-9562-5D1F65508D22}"/>
               </a:ext>
             </a:extLst>
           </p:cNvPr>
@@ -3690,7 +3690,7 @@
           <p:cNvPr id="52" name="">
             <a:extLst xmlns:a="http://schemas.openxmlformats.org/drawingml/2006/main">
               <a:ext uri="{FF2B5EF4-FFF2-40B4-BE49-F238E27FC236}">
-                <a16:creationId xmlns:a16="http://schemas.microsoft.com/office/drawing/2014/main" id="{F00C198A-51F0-4EE8-A0D1-5158BFFA55E9}"/>
+                <a16:creationId xmlns:a16="http://schemas.microsoft.com/office/drawing/2014/main" id="{8937EA72-F01B-470B-BDEE-2C4232455B11}"/>
               </a:ext>
             </a:extLst>
           </p:cNvPr>
@@ -3725,7 +3725,7 @@
           <p:cNvPr id="53" name="">
             <a:extLst xmlns:a="http://schemas.openxmlformats.org/drawingml/2006/main">
               <a:ext uri="{FF2B5EF4-FFF2-40B4-BE49-F238E27FC236}">
-                <a16:creationId xmlns:a16="http://schemas.microsoft.com/office/drawing/2014/main" id="{82867790-CC5E-49CB-9A14-3E4F9EEDDAFA}"/>
+                <a16:creationId xmlns:a16="http://schemas.microsoft.com/office/drawing/2014/main" id="{974C2095-C091-4D00-ABEE-C351E4EBC34C}"/>
               </a:ext>
             </a:extLst>
           </p:cNvPr>
@@ -3785,7 +3785,7 @@
           <p:cNvPr id="54" name="">
             <a:extLst xmlns:a="http://schemas.openxmlformats.org/drawingml/2006/main">
               <a:ext uri="{FF2B5EF4-FFF2-40B4-BE49-F238E27FC236}">
-                <a16:creationId xmlns:a16="http://schemas.microsoft.com/office/drawing/2014/main" id="{0E789A3C-7389-42AA-AD83-F0F8E6F42356}"/>
+                <a16:creationId xmlns:a16="http://schemas.microsoft.com/office/drawing/2014/main" id="{5F0DB024-C88E-4111-A077-7D5F39920875}"/>
               </a:ext>
             </a:extLst>
           </p:cNvPr>
@@ -3845,7 +3845,7 @@
           <p:cNvPr id="55" name="">
             <a:extLst xmlns:a="http://schemas.openxmlformats.org/drawingml/2006/main">
               <a:ext uri="{FF2B5EF4-FFF2-40B4-BE49-F238E27FC236}">
-                <a16:creationId xmlns:a16="http://schemas.microsoft.com/office/drawing/2014/main" id="{560FB95E-A997-419F-AD3F-2774F9AB6544}"/>
+                <a16:creationId xmlns:a16="http://schemas.microsoft.com/office/drawing/2014/main" id="{C73D0187-1E17-4E72-A776-763CD091817C}"/>
               </a:ext>
             </a:extLst>
           </p:cNvPr>
@@ -3880,7 +3880,7 @@
           <p:cNvPr id="56" name="">
             <a:extLst xmlns:a="http://schemas.openxmlformats.org/drawingml/2006/main">
               <a:ext uri="{FF2B5EF4-FFF2-40B4-BE49-F238E27FC236}">
-                <a16:creationId xmlns:a16="http://schemas.microsoft.com/office/drawing/2014/main" id="{DD7246AB-C778-4128-BA34-437164FCAD2E}"/>
+                <a16:creationId xmlns:a16="http://schemas.microsoft.com/office/drawing/2014/main" id="{6FAC7DFF-7098-4C55-A138-28CB47DF1E15}"/>
               </a:ext>
             </a:extLst>
           </p:cNvPr>
@@ -3915,7 +3915,7 @@
           <p:cNvPr id="57" name="">
             <a:extLst xmlns:a="http://schemas.openxmlformats.org/drawingml/2006/main">
               <a:ext uri="{FF2B5EF4-FFF2-40B4-BE49-F238E27FC236}">
-                <a16:creationId xmlns:a16="http://schemas.microsoft.com/office/drawing/2014/main" id="{2DA3F478-04D5-4345-AF75-C84BAEAA6F25}"/>
+                <a16:creationId xmlns:a16="http://schemas.microsoft.com/office/drawing/2014/main" id="{C9926F83-4803-48F5-B474-B79D4CF7C0D7}"/>
               </a:ext>
             </a:extLst>
           </p:cNvPr>
@@ -3975,7 +3975,7 @@
           <p:cNvPr id="58" name="">
             <a:extLst xmlns:a="http://schemas.openxmlformats.org/drawingml/2006/main">
               <a:ext uri="{FF2B5EF4-FFF2-40B4-BE49-F238E27FC236}">
-                <a16:creationId xmlns:a16="http://schemas.microsoft.com/office/drawing/2014/main" id="{657C220F-77D4-4392-85B2-D75389AC516A}"/>
+                <a16:creationId xmlns:a16="http://schemas.microsoft.com/office/drawing/2014/main" id="{2FC2E55B-21C6-474E-8835-1EBFA77D45AE}"/>
               </a:ext>
             </a:extLst>
           </p:cNvPr>
@@ -4035,7 +4035,7 @@
           <p:cNvPr id="59" name="">
             <a:extLst xmlns:a="http://schemas.openxmlformats.org/drawingml/2006/main">
               <a:ext uri="{FF2B5EF4-FFF2-40B4-BE49-F238E27FC236}">
-                <a16:creationId xmlns:a16="http://schemas.microsoft.com/office/drawing/2014/main" id="{E3AFCA9C-54CC-4F78-ADD9-5FBDC4E584A2}"/>
+                <a16:creationId xmlns:a16="http://schemas.microsoft.com/office/drawing/2014/main" id="{61B46CB0-3DF0-4FFD-B3F4-C4F6DB3DEB6C}"/>
               </a:ext>
             </a:extLst>
           </p:cNvPr>
@@ -4070,7 +4070,7 @@
           <p:cNvPr id="60" name="">
             <a:extLst xmlns:a="http://schemas.openxmlformats.org/drawingml/2006/main">
               <a:ext uri="{FF2B5EF4-FFF2-40B4-BE49-F238E27FC236}">
-                <a16:creationId xmlns:a16="http://schemas.microsoft.com/office/drawing/2014/main" id="{DA4802AE-5962-443B-8333-BDE3AA55632C}"/>
+                <a16:creationId xmlns:a16="http://schemas.microsoft.com/office/drawing/2014/main" id="{D5181AE6-A4D1-4034-825C-2DEDF2E2639D}"/>
               </a:ext>
             </a:extLst>
           </p:cNvPr>
@@ -4105,7 +4105,7 @@
           <p:cNvPr id="61" name="">
             <a:extLst xmlns:a="http://schemas.openxmlformats.org/drawingml/2006/main">
               <a:ext uri="{FF2B5EF4-FFF2-40B4-BE49-F238E27FC236}">
-                <a16:creationId xmlns:a16="http://schemas.microsoft.com/office/drawing/2014/main" id="{42CA9D78-BE30-447E-8E02-2D5202FFD782}"/>
+                <a16:creationId xmlns:a16="http://schemas.microsoft.com/office/drawing/2014/main" id="{D7F44DBB-1A8E-4092-94DF-5A270DC0C3D4}"/>
               </a:ext>
             </a:extLst>
           </p:cNvPr>
@@ -4165,7 +4165,7 @@
           <p:cNvPr id="62" name="">
             <a:extLst xmlns:a="http://schemas.openxmlformats.org/drawingml/2006/main">
               <a:ext uri="{FF2B5EF4-FFF2-40B4-BE49-F238E27FC236}">
-                <a16:creationId xmlns:a16="http://schemas.microsoft.com/office/drawing/2014/main" id="{17913144-FF6D-4D22-A486-27B0240C3D10}"/>
+                <a16:creationId xmlns:a16="http://schemas.microsoft.com/office/drawing/2014/main" id="{0037BF56-35BF-48ED-8A74-E37233D89C96}"/>
               </a:ext>
             </a:extLst>
           </p:cNvPr>
@@ -4223,7 +4223,7 @@
     </p:spTree>
     <p:extLst>
       <p:ext uri="{BB962C8B-B14F-4D97-AF65-F5344CB8AC3E}">
-        <p14:creationId xmlns:p14="http://schemas.microsoft.com/office/powerpoint/2010/main" val="1082426419"/>
+        <p14:creationId xmlns:p14="http://schemas.microsoft.com/office/powerpoint/2010/main" val="425556869"/>
       </p:ext>
     </p:extLst>
   </p:cSld>
@@ -4254,7 +4254,7 @@
           <p:cNvPr id="1" name="Slide Number Placeholder 5">
             <a:extLst xmlns:a="http://schemas.openxmlformats.org/drawingml/2006/main">
               <a:ext uri="{FF2B5EF4-FFF2-40B4-BE49-F238E27FC236}">
-                <a16:creationId xmlns:a16="http://schemas.microsoft.com/office/drawing/2014/main" id="{A2D8A6D6-5A49-46F7-8AC4-D6254B37C82A}"/>
+                <a16:creationId xmlns:a16="http://schemas.microsoft.com/office/drawing/2014/main" id="{9EDFBF68-94E1-445A-9556-759B9580ED01}"/>
               </a:ext>
             </a:extLst>
           </p:cNvPr>
@@ -4286,7 +4286,7 @@
           <p:cNvPr id="2" name="">
             <a:extLst xmlns:a="http://schemas.openxmlformats.org/drawingml/2006/main">
               <a:ext uri="{FF2B5EF4-FFF2-40B4-BE49-F238E27FC236}">
-                <a16:creationId xmlns:a16="http://schemas.microsoft.com/office/drawing/2014/main" id="{744267FD-E8C5-4980-86F1-AC7760A93A2B}"/>
+                <a16:creationId xmlns:a16="http://schemas.microsoft.com/office/drawing/2014/main" id="{496D70C2-1B10-46F1-9157-67E6AD2C2064}"/>
               </a:ext>
             </a:extLst>
           </p:cNvPr>
@@ -4321,7 +4321,7 @@
           <p:cNvPr id="3" name="">
             <a:extLst xmlns:a="http://schemas.openxmlformats.org/drawingml/2006/main">
               <a:ext uri="{FF2B5EF4-FFF2-40B4-BE49-F238E27FC236}">
-                <a16:creationId xmlns:a16="http://schemas.microsoft.com/office/drawing/2014/main" id="{5682C03A-5CD9-40DD-AEA7-F67FF7F1F01A}"/>
+                <a16:creationId xmlns:a16="http://schemas.microsoft.com/office/drawing/2014/main" id="{D20B070D-6C34-45DE-81A2-530108ABD3F0}"/>
               </a:ext>
             </a:extLst>
           </p:cNvPr>
@@ -4356,7 +4356,7 @@
           <p:cNvPr id="4" name="">
             <a:extLst xmlns:a="http://schemas.openxmlformats.org/drawingml/2006/main">
               <a:ext uri="{FF2B5EF4-FFF2-40B4-BE49-F238E27FC236}">
-                <a16:creationId xmlns:a16="http://schemas.microsoft.com/office/drawing/2014/main" id="{B680F66E-D79C-4B53-A5AB-89D90C006F53}"/>
+                <a16:creationId xmlns:a16="http://schemas.microsoft.com/office/drawing/2014/main" id="{0EC56825-40E5-46B6-9218-C7332B191123}"/>
               </a:ext>
             </a:extLst>
           </p:cNvPr>
@@ -4391,7 +4391,7 @@
           <p:cNvPr id="5" name="">
             <a:extLst xmlns:a="http://schemas.openxmlformats.org/drawingml/2006/main">
               <a:ext uri="{FF2B5EF4-FFF2-40B4-BE49-F238E27FC236}">
-                <a16:creationId xmlns:a16="http://schemas.microsoft.com/office/drawing/2014/main" id="{749CA938-A51D-4C17-AEFF-A5EC2352804D}"/>
+                <a16:creationId xmlns:a16="http://schemas.microsoft.com/office/drawing/2014/main" id="{25DE4845-1D3B-4D04-82BD-A87909DB8DB0}"/>
               </a:ext>
             </a:extLst>
           </p:cNvPr>
@@ -4426,7 +4426,7 @@
           <p:cNvPr id="6" name="">
             <a:extLst xmlns:a="http://schemas.openxmlformats.org/drawingml/2006/main">
               <a:ext uri="{FF2B5EF4-FFF2-40B4-BE49-F238E27FC236}">
-                <a16:creationId xmlns:a16="http://schemas.microsoft.com/office/drawing/2014/main" id="{57414CBD-3331-4E6E-83CF-F62BF7BA91E7}"/>
+                <a16:creationId xmlns:a16="http://schemas.microsoft.com/office/drawing/2014/main" id="{1CD30FD5-23C3-4DB8-82E4-3BF12349D4B6}"/>
               </a:ext>
             </a:extLst>
           </p:cNvPr>
@@ -4461,7 +4461,7 @@
           <p:cNvPr id="7" name="">
             <a:extLst xmlns:a="http://schemas.openxmlformats.org/drawingml/2006/main">
               <a:ext uri="{FF2B5EF4-FFF2-40B4-BE49-F238E27FC236}">
-                <a16:creationId xmlns:a16="http://schemas.microsoft.com/office/drawing/2014/main" id="{56600E14-7008-43FE-8298-19514A692151}"/>
+                <a16:creationId xmlns:a16="http://schemas.microsoft.com/office/drawing/2014/main" id="{3AC87DDA-A40A-46E2-B7D9-0FC5ABEC8B46}"/>
               </a:ext>
             </a:extLst>
           </p:cNvPr>
@@ -4519,7 +4519,7 @@
           <p:cNvPr id="8" name="">
             <a:extLst xmlns:a="http://schemas.openxmlformats.org/drawingml/2006/main">
               <a:ext uri="{FF2B5EF4-FFF2-40B4-BE49-F238E27FC236}">
-                <a16:creationId xmlns:a16="http://schemas.microsoft.com/office/drawing/2014/main" id="{1909F515-2292-4F59-B514-80B602CAC9DA}"/>
+                <a16:creationId xmlns:a16="http://schemas.microsoft.com/office/drawing/2014/main" id="{665EB14D-8BD4-4AF6-B103-9127D0F6EDAA}"/>
               </a:ext>
             </a:extLst>
           </p:cNvPr>
@@ -4577,7 +4577,7 @@
           <p:cNvPr id="9" name="">
             <a:extLst xmlns:a="http://schemas.openxmlformats.org/drawingml/2006/main">
               <a:ext uri="{FF2B5EF4-FFF2-40B4-BE49-F238E27FC236}">
-                <a16:creationId xmlns:a16="http://schemas.microsoft.com/office/drawing/2014/main" id="{463B915B-7AB7-4446-B6D6-E96533CEBA12}"/>
+                <a16:creationId xmlns:a16="http://schemas.microsoft.com/office/drawing/2014/main" id="{878AED03-1DE4-4383-AD1F-662FBC6679C6}"/>
               </a:ext>
             </a:extLst>
           </p:cNvPr>
@@ -4635,7 +4635,7 @@
           <p:cNvPr id="10" name="">
             <a:extLst xmlns:a="http://schemas.openxmlformats.org/drawingml/2006/main">
               <a:ext uri="{FF2B5EF4-FFF2-40B4-BE49-F238E27FC236}">
-                <a16:creationId xmlns:a16="http://schemas.microsoft.com/office/drawing/2014/main" id="{D6DD17DF-8317-4194-892A-3EDA80AFEDF4}"/>
+                <a16:creationId xmlns:a16="http://schemas.microsoft.com/office/drawing/2014/main" id="{1FFC6DC5-73D7-423D-98EB-693860BB4536}"/>
               </a:ext>
             </a:extLst>
           </p:cNvPr>
@@ -4670,7 +4670,7 @@
           <p:cNvPr id="11" name="">
             <a:extLst xmlns:a="http://schemas.openxmlformats.org/drawingml/2006/main">
               <a:ext uri="{FF2B5EF4-FFF2-40B4-BE49-F238E27FC236}">
-                <a16:creationId xmlns:a16="http://schemas.microsoft.com/office/drawing/2014/main" id="{C07CD3DC-3691-4084-894E-1B68DD7471D6}"/>
+                <a16:creationId xmlns:a16="http://schemas.microsoft.com/office/drawing/2014/main" id="{574377B7-5114-48E4-8C7F-B545326921FE}"/>
               </a:ext>
             </a:extLst>
           </p:cNvPr>
@@ -4730,7 +4730,7 @@
           <p:cNvPr id="12" name="">
             <a:extLst xmlns:a="http://schemas.openxmlformats.org/drawingml/2006/main">
               <a:ext uri="{FF2B5EF4-FFF2-40B4-BE49-F238E27FC236}">
-                <a16:creationId xmlns:a16="http://schemas.microsoft.com/office/drawing/2014/main" id="{8D8C6F73-21F4-4CAC-99DE-8C15A1F8EF94}"/>
+                <a16:creationId xmlns:a16="http://schemas.microsoft.com/office/drawing/2014/main" id="{A03C6C1D-ABC1-4B57-A004-1F636A6F3EF5}"/>
               </a:ext>
             </a:extLst>
           </p:cNvPr>
@@ -4765,7 +4765,7 @@
           <p:cNvPr id="13" name="">
             <a:extLst xmlns:a="http://schemas.openxmlformats.org/drawingml/2006/main">
               <a:ext uri="{FF2B5EF4-FFF2-40B4-BE49-F238E27FC236}">
-                <a16:creationId xmlns:a16="http://schemas.microsoft.com/office/drawing/2014/main" id="{75FD0CE2-8796-479D-BB1F-6D00843B6E5D}"/>
+                <a16:creationId xmlns:a16="http://schemas.microsoft.com/office/drawing/2014/main" id="{7D39DF53-391A-460B-890D-814D4E898882}"/>
               </a:ext>
             </a:extLst>
           </p:cNvPr>
@@ -4798,7 +4798,7 @@
           <p:cNvPr id="14" name="">
             <a:extLst xmlns:a="http://schemas.openxmlformats.org/drawingml/2006/main">
               <a:ext uri="{FF2B5EF4-FFF2-40B4-BE49-F238E27FC236}">
-                <a16:creationId xmlns:a16="http://schemas.microsoft.com/office/drawing/2014/main" id="{B5B21381-65FC-49AE-B5B7-EE202E82A461}"/>
+                <a16:creationId xmlns:a16="http://schemas.microsoft.com/office/drawing/2014/main" id="{C8454F72-6EB6-4872-8709-E11F14A89391}"/>
               </a:ext>
             </a:extLst>
           </p:cNvPr>
@@ -4856,7 +4856,7 @@
           <p:cNvPr id="15" name="">
             <a:extLst xmlns:a="http://schemas.openxmlformats.org/drawingml/2006/main">
               <a:ext uri="{FF2B5EF4-FFF2-40B4-BE49-F238E27FC236}">
-                <a16:creationId xmlns:a16="http://schemas.microsoft.com/office/drawing/2014/main" id="{518135D9-0A41-4441-847E-8DF2C91E9FAF}"/>
+                <a16:creationId xmlns:a16="http://schemas.microsoft.com/office/drawing/2014/main" id="{700E8DF0-7F3E-4F1E-806C-65B6A2736F6C}"/>
               </a:ext>
             </a:extLst>
           </p:cNvPr>
@@ -4916,7 +4916,7 @@
           <p:cNvPr id="16" name="">
             <a:extLst xmlns:a="http://schemas.openxmlformats.org/drawingml/2006/main">
               <a:ext uri="{FF2B5EF4-FFF2-40B4-BE49-F238E27FC236}">
-                <a16:creationId xmlns:a16="http://schemas.microsoft.com/office/drawing/2014/main" id="{7D9B98A8-A1A6-443D-90A3-6FF1AA34F1AC}"/>
+                <a16:creationId xmlns:a16="http://schemas.microsoft.com/office/drawing/2014/main" id="{B2B04185-0D54-4DFD-92CF-69C53CA67FB8}"/>
               </a:ext>
             </a:extLst>
           </p:cNvPr>
@@ -4976,7 +4976,7 @@
           <p:cNvPr id="17" name="">
             <a:extLst xmlns:a="http://schemas.openxmlformats.org/drawingml/2006/main">
               <a:ext uri="{FF2B5EF4-FFF2-40B4-BE49-F238E27FC236}">
-                <a16:creationId xmlns:a16="http://schemas.microsoft.com/office/drawing/2014/main" id="{95BB7989-5678-4E07-A0C1-3CA2E4EF3298}"/>
+                <a16:creationId xmlns:a16="http://schemas.microsoft.com/office/drawing/2014/main" id="{877A4906-98E3-4D4C-A10C-EB04A028259E}"/>
               </a:ext>
             </a:extLst>
           </p:cNvPr>
@@ -5011,7 +5011,7 @@
           <p:cNvPr id="18" name="">
             <a:extLst xmlns:a="http://schemas.openxmlformats.org/drawingml/2006/main">
               <a:ext uri="{FF2B5EF4-FFF2-40B4-BE49-F238E27FC236}">
-                <a16:creationId xmlns:a16="http://schemas.microsoft.com/office/drawing/2014/main" id="{BF2CCAAF-2487-4DDE-A88D-59F1AEF7C868}"/>
+                <a16:creationId xmlns:a16="http://schemas.microsoft.com/office/drawing/2014/main" id="{6D5ECCA7-A228-4283-8816-BEBDB6089C92}"/>
               </a:ext>
             </a:extLst>
           </p:cNvPr>
@@ -5046,7 +5046,7 @@
           <p:cNvPr id="19" name="">
             <a:extLst xmlns:a="http://schemas.openxmlformats.org/drawingml/2006/main">
               <a:ext uri="{FF2B5EF4-FFF2-40B4-BE49-F238E27FC236}">
-                <a16:creationId xmlns:a16="http://schemas.microsoft.com/office/drawing/2014/main" id="{869BD87E-CC56-4F9E-89D6-DF1D0C868C65}"/>
+                <a16:creationId xmlns:a16="http://schemas.microsoft.com/office/drawing/2014/main" id="{48F5ACB5-7870-4503-A696-8D9C7CCFA8F9}"/>
               </a:ext>
             </a:extLst>
           </p:cNvPr>
@@ -5106,7 +5106,7 @@
           <p:cNvPr id="20" name="">
             <a:extLst xmlns:a="http://schemas.openxmlformats.org/drawingml/2006/main">
               <a:ext uri="{FF2B5EF4-FFF2-40B4-BE49-F238E27FC236}">
-                <a16:creationId xmlns:a16="http://schemas.microsoft.com/office/drawing/2014/main" id="{0D6B8321-7F9D-4247-B28F-2F18617F3D0C}"/>
+                <a16:creationId xmlns:a16="http://schemas.microsoft.com/office/drawing/2014/main" id="{D8FC4172-D6B7-4F1C-8AB1-C7042A6B8A73}"/>
               </a:ext>
             </a:extLst>
           </p:cNvPr>
@@ -5166,7 +5166,7 @@
           <p:cNvPr id="21" name="">
             <a:extLst xmlns:a="http://schemas.openxmlformats.org/drawingml/2006/main">
               <a:ext uri="{FF2B5EF4-FFF2-40B4-BE49-F238E27FC236}">
-                <a16:creationId xmlns:a16="http://schemas.microsoft.com/office/drawing/2014/main" id="{5412438B-BB8A-46AE-9DB4-BB72A9B5FE72}"/>
+                <a16:creationId xmlns:a16="http://schemas.microsoft.com/office/drawing/2014/main" id="{C2581255-91D9-48C6-A73C-ECD73687ACE5}"/>
               </a:ext>
             </a:extLst>
           </p:cNvPr>
@@ -5201,7 +5201,7 @@
           <p:cNvPr id="22" name="">
             <a:extLst xmlns:a="http://schemas.openxmlformats.org/drawingml/2006/main">
               <a:ext uri="{FF2B5EF4-FFF2-40B4-BE49-F238E27FC236}">
-                <a16:creationId xmlns:a16="http://schemas.microsoft.com/office/drawing/2014/main" id="{93F42F96-8AEC-4DC1-98BF-C17647FA9970}"/>
+                <a16:creationId xmlns:a16="http://schemas.microsoft.com/office/drawing/2014/main" id="{8AC91224-A94E-4708-B5D3-373C68D4DB42}"/>
               </a:ext>
             </a:extLst>
           </p:cNvPr>
@@ -5236,7 +5236,7 @@
           <p:cNvPr id="23" name="">
             <a:extLst xmlns:a="http://schemas.openxmlformats.org/drawingml/2006/main">
               <a:ext uri="{FF2B5EF4-FFF2-40B4-BE49-F238E27FC236}">
-                <a16:creationId xmlns:a16="http://schemas.microsoft.com/office/drawing/2014/main" id="{9B380398-B47C-40D0-A55A-CD40C3706CC6}"/>
+                <a16:creationId xmlns:a16="http://schemas.microsoft.com/office/drawing/2014/main" id="{A00CC9C0-EBFA-44C0-9226-3E8B628CB838}"/>
               </a:ext>
             </a:extLst>
           </p:cNvPr>
@@ -5296,7 +5296,7 @@
           <p:cNvPr id="24" name="">
             <a:extLst xmlns:a="http://schemas.openxmlformats.org/drawingml/2006/main">
               <a:ext uri="{FF2B5EF4-FFF2-40B4-BE49-F238E27FC236}">
-                <a16:creationId xmlns:a16="http://schemas.microsoft.com/office/drawing/2014/main" id="{79E1A9D6-A879-4F0D-AA0C-25995AF9094E}"/>
+                <a16:creationId xmlns:a16="http://schemas.microsoft.com/office/drawing/2014/main" id="{B38FD21C-D6D2-4762-8BEA-9E16AF438859}"/>
               </a:ext>
             </a:extLst>
           </p:cNvPr>
@@ -5356,7 +5356,7 @@
           <p:cNvPr id="25" name="">
             <a:extLst xmlns:a="http://schemas.openxmlformats.org/drawingml/2006/main">
               <a:ext uri="{FF2B5EF4-FFF2-40B4-BE49-F238E27FC236}">
-                <a16:creationId xmlns:a16="http://schemas.microsoft.com/office/drawing/2014/main" id="{2014956A-4470-4190-9EAE-233A818C0079}"/>
+                <a16:creationId xmlns:a16="http://schemas.microsoft.com/office/drawing/2014/main" id="{6F4EEDFE-DFB0-4DD7-BF1E-131A7A0825A7}"/>
               </a:ext>
             </a:extLst>
           </p:cNvPr>
@@ -5391,7 +5391,7 @@
           <p:cNvPr id="26" name="">
             <a:extLst xmlns:a="http://schemas.openxmlformats.org/drawingml/2006/main">
               <a:ext uri="{FF2B5EF4-FFF2-40B4-BE49-F238E27FC236}">
-                <a16:creationId xmlns:a16="http://schemas.microsoft.com/office/drawing/2014/main" id="{52F98561-4458-4864-9EA7-A37545DD1ED3}"/>
+                <a16:creationId xmlns:a16="http://schemas.microsoft.com/office/drawing/2014/main" id="{88C0E70E-078D-496E-A031-76860EDC9F2F}"/>
               </a:ext>
             </a:extLst>
           </p:cNvPr>
@@ -5426,7 +5426,7 @@
           <p:cNvPr id="27" name="">
             <a:extLst xmlns:a="http://schemas.openxmlformats.org/drawingml/2006/main">
               <a:ext uri="{FF2B5EF4-FFF2-40B4-BE49-F238E27FC236}">
-                <a16:creationId xmlns:a16="http://schemas.microsoft.com/office/drawing/2014/main" id="{82272042-B931-461E-A104-FA48A19E63CA}"/>
+                <a16:creationId xmlns:a16="http://schemas.microsoft.com/office/drawing/2014/main" id="{C1843E60-C1D7-46A7-9EF9-28C27149975D}"/>
               </a:ext>
             </a:extLst>
           </p:cNvPr>
@@ -5486,7 +5486,7 @@
           <p:cNvPr id="28" name="">
             <a:extLst xmlns:a="http://schemas.openxmlformats.org/drawingml/2006/main">
               <a:ext uri="{FF2B5EF4-FFF2-40B4-BE49-F238E27FC236}">
-                <a16:creationId xmlns:a16="http://schemas.microsoft.com/office/drawing/2014/main" id="{D9CFA89C-ED19-48D9-A2C9-806B3A211EC6}"/>
+                <a16:creationId xmlns:a16="http://schemas.microsoft.com/office/drawing/2014/main" id="{5F0255C1-F9FD-478B-A5BE-FBD7B4130EA3}"/>
               </a:ext>
             </a:extLst>
           </p:cNvPr>
@@ -5546,7 +5546,7 @@
           <p:cNvPr id="29" name="">
             <a:extLst xmlns:a="http://schemas.openxmlformats.org/drawingml/2006/main">
               <a:ext uri="{FF2B5EF4-FFF2-40B4-BE49-F238E27FC236}">
-                <a16:creationId xmlns:a16="http://schemas.microsoft.com/office/drawing/2014/main" id="{C636EF68-FF69-4B65-A647-13A4B0E7EDFB}"/>
+                <a16:creationId xmlns:a16="http://schemas.microsoft.com/office/drawing/2014/main" id="{26C9C2C0-774D-489D-8439-4745C82364CF}"/>
               </a:ext>
             </a:extLst>
           </p:cNvPr>
@@ -5581,7 +5581,7 @@
           <p:cNvPr id="30" name="">
             <a:extLst xmlns:a="http://schemas.openxmlformats.org/drawingml/2006/main">
               <a:ext uri="{FF2B5EF4-FFF2-40B4-BE49-F238E27FC236}">
-                <a16:creationId xmlns:a16="http://schemas.microsoft.com/office/drawing/2014/main" id="{EA658DEE-8D75-4C33-B8D1-EF19995874E8}"/>
+                <a16:creationId xmlns:a16="http://schemas.microsoft.com/office/drawing/2014/main" id="{3FDEB518-0959-4894-A186-2CC484D3DF01}"/>
               </a:ext>
             </a:extLst>
           </p:cNvPr>
@@ -5616,7 +5616,7 @@
           <p:cNvPr id="31" name="">
             <a:extLst xmlns:a="http://schemas.openxmlformats.org/drawingml/2006/main">
               <a:ext uri="{FF2B5EF4-FFF2-40B4-BE49-F238E27FC236}">
-                <a16:creationId xmlns:a16="http://schemas.microsoft.com/office/drawing/2014/main" id="{CB6709F2-EC93-4112-9E7F-277714122CA1}"/>
+                <a16:creationId xmlns:a16="http://schemas.microsoft.com/office/drawing/2014/main" id="{774DD076-F569-4295-8740-A80265EDFA54}"/>
               </a:ext>
             </a:extLst>
           </p:cNvPr>
@@ -5676,7 +5676,7 @@
           <p:cNvPr id="32" name="">
             <a:extLst xmlns:a="http://schemas.openxmlformats.org/drawingml/2006/main">
               <a:ext uri="{FF2B5EF4-FFF2-40B4-BE49-F238E27FC236}">
-                <a16:creationId xmlns:a16="http://schemas.microsoft.com/office/drawing/2014/main" id="{5ADFBA19-9C3E-456E-B28C-C57B1C500E93}"/>
+                <a16:creationId xmlns:a16="http://schemas.microsoft.com/office/drawing/2014/main" id="{1F813D9B-AC5E-413F-9BD9-2077093CE132}"/>
               </a:ext>
             </a:extLst>
           </p:cNvPr>
@@ -5734,7 +5734,7 @@
     </p:spTree>
     <p:extLst>
       <p:ext uri="{BB962C8B-B14F-4D97-AF65-F5344CB8AC3E}">
-        <p14:creationId xmlns:p14="http://schemas.microsoft.com/office/powerpoint/2010/main" val="337901935"/>
+        <p14:creationId xmlns:p14="http://schemas.microsoft.com/office/powerpoint/2010/main" val="221786562"/>
       </p:ext>
     </p:extLst>
   </p:cSld>
@@ -5765,7 +5765,7 @@
           <p:cNvPr id="1" name="Slide Number Placeholder 5">
             <a:extLst xmlns:a="http://schemas.openxmlformats.org/drawingml/2006/main">
               <a:ext uri="{FF2B5EF4-FFF2-40B4-BE49-F238E27FC236}">
-                <a16:creationId xmlns:a16="http://schemas.microsoft.com/office/drawing/2014/main" id="{A2D8A6D6-5A49-46F7-8AC4-D6254B37C82A}"/>
+                <a16:creationId xmlns:a16="http://schemas.microsoft.com/office/drawing/2014/main" id="{9EDFBF68-94E1-445A-9556-759B9580ED01}"/>
               </a:ext>
             </a:extLst>
           </p:cNvPr>
@@ -5797,7 +5797,7 @@
           <p:cNvPr id="2" name="">
             <a:extLst xmlns:a="http://schemas.openxmlformats.org/drawingml/2006/main">
               <a:ext uri="{FF2B5EF4-FFF2-40B4-BE49-F238E27FC236}">
-                <a16:creationId xmlns:a16="http://schemas.microsoft.com/office/drawing/2014/main" id="{48A97147-B2DE-4910-A664-D41C9E1F6F7F}"/>
+                <a16:creationId xmlns:a16="http://schemas.microsoft.com/office/drawing/2014/main" id="{BFF643E5-CB64-4096-903C-AAE7B8F5002F}"/>
               </a:ext>
             </a:extLst>
           </p:cNvPr>
@@ -5832,7 +5832,7 @@
           <p:cNvPr id="3" name="">
             <a:extLst xmlns:a="http://schemas.openxmlformats.org/drawingml/2006/main">
               <a:ext uri="{FF2B5EF4-FFF2-40B4-BE49-F238E27FC236}">
-                <a16:creationId xmlns:a16="http://schemas.microsoft.com/office/drawing/2014/main" id="{023D317E-384C-42BF-AA74-81F91EE05745}"/>
+                <a16:creationId xmlns:a16="http://schemas.microsoft.com/office/drawing/2014/main" id="{729CD0EA-C3AF-4D01-BA10-15F2EC083525}"/>
               </a:ext>
             </a:extLst>
           </p:cNvPr>
@@ -5867,7 +5867,7 @@
           <p:cNvPr id="4" name="">
             <a:extLst xmlns:a="http://schemas.openxmlformats.org/drawingml/2006/main">
               <a:ext uri="{FF2B5EF4-FFF2-40B4-BE49-F238E27FC236}">
-                <a16:creationId xmlns:a16="http://schemas.microsoft.com/office/drawing/2014/main" id="{CAACA0D0-4DFC-4FC9-9C72-6DCAC611F6EF}"/>
+                <a16:creationId xmlns:a16="http://schemas.microsoft.com/office/drawing/2014/main" id="{1018222B-83CC-4D42-83FA-F1A95CD5442F}"/>
               </a:ext>
             </a:extLst>
           </p:cNvPr>
@@ -5902,7 +5902,7 @@
           <p:cNvPr id="5" name="">
             <a:extLst xmlns:a="http://schemas.openxmlformats.org/drawingml/2006/main">
               <a:ext uri="{FF2B5EF4-FFF2-40B4-BE49-F238E27FC236}">
-                <a16:creationId xmlns:a16="http://schemas.microsoft.com/office/drawing/2014/main" id="{B4B2E0B5-DD02-4C86-BC42-D9E5D0D6236A}"/>
+                <a16:creationId xmlns:a16="http://schemas.microsoft.com/office/drawing/2014/main" id="{29CC2219-8267-4D00-AA98-82AAF3DCF784}"/>
               </a:ext>
             </a:extLst>
           </p:cNvPr>
@@ -5937,7 +5937,7 @@
           <p:cNvPr id="6" name="">
             <a:extLst xmlns:a="http://schemas.openxmlformats.org/drawingml/2006/main">
               <a:ext uri="{FF2B5EF4-FFF2-40B4-BE49-F238E27FC236}">
-                <a16:creationId xmlns:a16="http://schemas.microsoft.com/office/drawing/2014/main" id="{8C5BC65D-371B-444E-9EC6-F3A46F584063}"/>
+                <a16:creationId xmlns:a16="http://schemas.microsoft.com/office/drawing/2014/main" id="{7B32407C-F1AE-43AF-A857-784846FC0A4D}"/>
               </a:ext>
             </a:extLst>
           </p:cNvPr>
@@ -5972,7 +5972,7 @@
           <p:cNvPr id="7" name="">
             <a:extLst xmlns:a="http://schemas.openxmlformats.org/drawingml/2006/main">
               <a:ext uri="{FF2B5EF4-FFF2-40B4-BE49-F238E27FC236}">
-                <a16:creationId xmlns:a16="http://schemas.microsoft.com/office/drawing/2014/main" id="{655600C8-2942-4466-8394-1EF68EEF666D}"/>
+                <a16:creationId xmlns:a16="http://schemas.microsoft.com/office/drawing/2014/main" id="{D13D4980-2EE1-44B0-86C0-38426B12D90A}"/>
               </a:ext>
             </a:extLst>
           </p:cNvPr>
@@ -6030,7 +6030,7 @@
           <p:cNvPr id="8" name="">
             <a:extLst xmlns:a="http://schemas.openxmlformats.org/drawingml/2006/main">
               <a:ext uri="{FF2B5EF4-FFF2-40B4-BE49-F238E27FC236}">
-                <a16:creationId xmlns:a16="http://schemas.microsoft.com/office/drawing/2014/main" id="{DA0EAA71-D89D-45BC-9AFB-A11ABD7AE3BD}"/>
+                <a16:creationId xmlns:a16="http://schemas.microsoft.com/office/drawing/2014/main" id="{C056DE6F-7D2E-4779-8901-79E6A9F11055}"/>
               </a:ext>
             </a:extLst>
           </p:cNvPr>
@@ -6088,7 +6088,7 @@
           <p:cNvPr id="9" name="">
             <a:extLst xmlns:a="http://schemas.openxmlformats.org/drawingml/2006/main">
               <a:ext uri="{FF2B5EF4-FFF2-40B4-BE49-F238E27FC236}">
-                <a16:creationId xmlns:a16="http://schemas.microsoft.com/office/drawing/2014/main" id="{72C561DF-6487-4A17-83EE-A6F4C3549156}"/>
+                <a16:creationId xmlns:a16="http://schemas.microsoft.com/office/drawing/2014/main" id="{E6B4F0E2-755B-454B-86E0-407D484014E1}"/>
               </a:ext>
             </a:extLst>
           </p:cNvPr>
@@ -6146,7 +6146,7 @@
           <p:cNvPr id="10" name="">
             <a:extLst xmlns:a="http://schemas.openxmlformats.org/drawingml/2006/main">
               <a:ext uri="{FF2B5EF4-FFF2-40B4-BE49-F238E27FC236}">
-                <a16:creationId xmlns:a16="http://schemas.microsoft.com/office/drawing/2014/main" id="{2526F12A-909E-49A3-9E8B-7E7958B8561E}"/>
+                <a16:creationId xmlns:a16="http://schemas.microsoft.com/office/drawing/2014/main" id="{553B23B3-1E31-4C7F-9EB3-C3DADA4FD6B5}"/>
               </a:ext>
             </a:extLst>
           </p:cNvPr>
@@ -6181,7 +6181,7 @@
           <p:cNvPr id="11" name="">
             <a:extLst xmlns:a="http://schemas.openxmlformats.org/drawingml/2006/main">
               <a:ext uri="{FF2B5EF4-FFF2-40B4-BE49-F238E27FC236}">
-                <a16:creationId xmlns:a16="http://schemas.microsoft.com/office/drawing/2014/main" id="{FDC73741-CEFB-47B5-9D1B-5948D5481909}"/>
+                <a16:creationId xmlns:a16="http://schemas.microsoft.com/office/drawing/2014/main" id="{E828D1C3-2152-40BF-98CA-A50A5FFAF33B}"/>
               </a:ext>
             </a:extLst>
           </p:cNvPr>
@@ -6241,7 +6241,7 @@
           <p:cNvPr id="12" name="">
             <a:extLst xmlns:a="http://schemas.openxmlformats.org/drawingml/2006/main">
               <a:ext uri="{FF2B5EF4-FFF2-40B4-BE49-F238E27FC236}">
-                <a16:creationId xmlns:a16="http://schemas.microsoft.com/office/drawing/2014/main" id="{56053577-5729-4FA0-BE04-B30A519A006F}"/>
+                <a16:creationId xmlns:a16="http://schemas.microsoft.com/office/drawing/2014/main" id="{FE889AF7-4739-4381-B6A0-30B4C7A0F023}"/>
               </a:ext>
             </a:extLst>
           </p:cNvPr>
@@ -6301,7 +6301,7 @@
           <p:cNvPr id="13" name="">
             <a:extLst xmlns:a="http://schemas.openxmlformats.org/drawingml/2006/main">
               <a:ext uri="{FF2B5EF4-FFF2-40B4-BE49-F238E27FC236}">
-                <a16:creationId xmlns:a16="http://schemas.microsoft.com/office/drawing/2014/main" id="{1229E412-D63F-4E3D-BB53-38166EB16B8E}"/>
+                <a16:creationId xmlns:a16="http://schemas.microsoft.com/office/drawing/2014/main" id="{DCCBDD80-E193-415D-81C7-EAEDA29DB7C3}"/>
               </a:ext>
             </a:extLst>
           </p:cNvPr>
@@ -6336,7 +6336,7 @@
           <p:cNvPr id="14" name="">
             <a:extLst xmlns:a="http://schemas.openxmlformats.org/drawingml/2006/main">
               <a:ext uri="{FF2B5EF4-FFF2-40B4-BE49-F238E27FC236}">
-                <a16:creationId xmlns:a16="http://schemas.microsoft.com/office/drawing/2014/main" id="{92F29D8F-1B1C-480F-99D5-613BE56DCE83}"/>
+                <a16:creationId xmlns:a16="http://schemas.microsoft.com/office/drawing/2014/main" id="{130CCD0F-FAE1-49CD-9313-14329A31D572}"/>
               </a:ext>
             </a:extLst>
           </p:cNvPr>
@@ -6371,7 +6371,7 @@
           <p:cNvPr id="15" name="">
             <a:extLst xmlns:a="http://schemas.openxmlformats.org/drawingml/2006/main">
               <a:ext uri="{FF2B5EF4-FFF2-40B4-BE49-F238E27FC236}">
-                <a16:creationId xmlns:a16="http://schemas.microsoft.com/office/drawing/2014/main" id="{EA5D7AAD-CBCE-41D5-BB16-D9FA06C4921E}"/>
+                <a16:creationId xmlns:a16="http://schemas.microsoft.com/office/drawing/2014/main" id="{EC526E88-A786-422C-8DD4-FF45D6EB4428}"/>
               </a:ext>
             </a:extLst>
           </p:cNvPr>
@@ -6431,7 +6431,7 @@
           <p:cNvPr id="16" name="">
             <a:extLst xmlns:a="http://schemas.openxmlformats.org/drawingml/2006/main">
               <a:ext uri="{FF2B5EF4-FFF2-40B4-BE49-F238E27FC236}">
-                <a16:creationId xmlns:a16="http://schemas.microsoft.com/office/drawing/2014/main" id="{3261117B-95FF-46B1-A2BB-E9004E40864D}"/>
+                <a16:creationId xmlns:a16="http://schemas.microsoft.com/office/drawing/2014/main" id="{C92E8C9E-A0E6-4D55-8B60-3711434975A3}"/>
               </a:ext>
             </a:extLst>
           </p:cNvPr>
@@ -6491,7 +6491,7 @@
           <p:cNvPr id="17" name="">
             <a:extLst xmlns:a="http://schemas.openxmlformats.org/drawingml/2006/main">
               <a:ext uri="{FF2B5EF4-FFF2-40B4-BE49-F238E27FC236}">
-                <a16:creationId xmlns:a16="http://schemas.microsoft.com/office/drawing/2014/main" id="{68E25525-F588-4C90-BD50-89D0EC54F02D}"/>
+                <a16:creationId xmlns:a16="http://schemas.microsoft.com/office/drawing/2014/main" id="{CA50C796-B485-4C89-B435-A3BD10ED45D5}"/>
               </a:ext>
             </a:extLst>
           </p:cNvPr>
@@ -6526,7 +6526,7 @@
           <p:cNvPr id="18" name="">
             <a:extLst xmlns:a="http://schemas.openxmlformats.org/drawingml/2006/main">
               <a:ext uri="{FF2B5EF4-FFF2-40B4-BE49-F238E27FC236}">
-                <a16:creationId xmlns:a16="http://schemas.microsoft.com/office/drawing/2014/main" id="{2FE800DC-2C89-4251-AB06-B6DDD0708E37}"/>
+                <a16:creationId xmlns:a16="http://schemas.microsoft.com/office/drawing/2014/main" id="{DE08A464-0904-4BF7-B478-4BA08BA7C717}"/>
               </a:ext>
             </a:extLst>
           </p:cNvPr>
@@ -6561,7 +6561,7 @@
           <p:cNvPr id="19" name="">
             <a:extLst xmlns:a="http://schemas.openxmlformats.org/drawingml/2006/main">
               <a:ext uri="{FF2B5EF4-FFF2-40B4-BE49-F238E27FC236}">
-                <a16:creationId xmlns:a16="http://schemas.microsoft.com/office/drawing/2014/main" id="{AB551C6A-EF16-41B6-84ED-3CD55A396D03}"/>
+                <a16:creationId xmlns:a16="http://schemas.microsoft.com/office/drawing/2014/main" id="{CD384F2F-43C6-4CB5-BE11-DD6FF959E688}"/>
               </a:ext>
             </a:extLst>
           </p:cNvPr>
@@ -6621,7 +6621,7 @@
           <p:cNvPr id="20" name="">
             <a:extLst xmlns:a="http://schemas.openxmlformats.org/drawingml/2006/main">
               <a:ext uri="{FF2B5EF4-FFF2-40B4-BE49-F238E27FC236}">
-                <a16:creationId xmlns:a16="http://schemas.microsoft.com/office/drawing/2014/main" id="{5499D7B7-9865-4239-861F-D6B6BB3A1A36}"/>
+                <a16:creationId xmlns:a16="http://schemas.microsoft.com/office/drawing/2014/main" id="{430815FC-2DCD-44D3-8FCD-6DD4768F3248}"/>
               </a:ext>
             </a:extLst>
           </p:cNvPr>
@@ -6681,7 +6681,7 @@
           <p:cNvPr id="21" name="">
             <a:extLst xmlns:a="http://schemas.openxmlformats.org/drawingml/2006/main">
               <a:ext uri="{FF2B5EF4-FFF2-40B4-BE49-F238E27FC236}">
-                <a16:creationId xmlns:a16="http://schemas.microsoft.com/office/drawing/2014/main" id="{14B218D0-1051-40F3-83C0-0F2E45109896}"/>
+                <a16:creationId xmlns:a16="http://schemas.microsoft.com/office/drawing/2014/main" id="{6D1B356F-E743-44F6-8935-89707D640BF2}"/>
               </a:ext>
             </a:extLst>
           </p:cNvPr>
@@ -6716,7 +6716,7 @@
           <p:cNvPr id="22" name="">
             <a:extLst xmlns:a="http://schemas.openxmlformats.org/drawingml/2006/main">
               <a:ext uri="{FF2B5EF4-FFF2-40B4-BE49-F238E27FC236}">
-                <a16:creationId xmlns:a16="http://schemas.microsoft.com/office/drawing/2014/main" id="{573E109C-1E26-4710-AC27-4A11456753D7}"/>
+                <a16:creationId xmlns:a16="http://schemas.microsoft.com/office/drawing/2014/main" id="{0897FA34-DD41-4270-83AF-7F76837B9CDA}"/>
               </a:ext>
             </a:extLst>
           </p:cNvPr>
@@ -6751,7 +6751,7 @@
           <p:cNvPr id="23" name="">
             <a:extLst xmlns:a="http://schemas.openxmlformats.org/drawingml/2006/main">
               <a:ext uri="{FF2B5EF4-FFF2-40B4-BE49-F238E27FC236}">
-                <a16:creationId xmlns:a16="http://schemas.microsoft.com/office/drawing/2014/main" id="{EAD5F439-DA49-48B0-8B87-E4A2A5EA94DB}"/>
+                <a16:creationId xmlns:a16="http://schemas.microsoft.com/office/drawing/2014/main" id="{402B40DB-58B4-4769-8350-D7EA2F32EA50}"/>
               </a:ext>
             </a:extLst>
           </p:cNvPr>
@@ -6811,7 +6811,7 @@
           <p:cNvPr id="24" name="">
             <a:extLst xmlns:a="http://schemas.openxmlformats.org/drawingml/2006/main">
               <a:ext uri="{FF2B5EF4-FFF2-40B4-BE49-F238E27FC236}">
-                <a16:creationId xmlns:a16="http://schemas.microsoft.com/office/drawing/2014/main" id="{E5300DA8-86CC-449B-90C7-6AFDE0E2273D}"/>
+                <a16:creationId xmlns:a16="http://schemas.microsoft.com/office/drawing/2014/main" id="{027174D9-6219-4581-9A81-0805C02CABBD}"/>
               </a:ext>
             </a:extLst>
           </p:cNvPr>
@@ -6871,7 +6871,7 @@
           <p:cNvPr id="25" name="">
             <a:extLst xmlns:a="http://schemas.openxmlformats.org/drawingml/2006/main">
               <a:ext uri="{FF2B5EF4-FFF2-40B4-BE49-F238E27FC236}">
-                <a16:creationId xmlns:a16="http://schemas.microsoft.com/office/drawing/2014/main" id="{5ABB0645-7ECB-4826-A4FB-22D9EA65D522}"/>
+                <a16:creationId xmlns:a16="http://schemas.microsoft.com/office/drawing/2014/main" id="{9F692B2F-B9C2-4E3F-B6C8-D8DC12197235}"/>
               </a:ext>
             </a:extLst>
           </p:cNvPr>
@@ -6906,7 +6906,7 @@
           <p:cNvPr id="26" name="">
             <a:extLst xmlns:a="http://schemas.openxmlformats.org/drawingml/2006/main">
               <a:ext uri="{FF2B5EF4-FFF2-40B4-BE49-F238E27FC236}">
-                <a16:creationId xmlns:a16="http://schemas.microsoft.com/office/drawing/2014/main" id="{B030BB06-3FEB-4D15-AF3C-8E812807395B}"/>
+                <a16:creationId xmlns:a16="http://schemas.microsoft.com/office/drawing/2014/main" id="{ED45FF02-2D9E-4DCB-8DA4-D2396BE46733}"/>
               </a:ext>
             </a:extLst>
           </p:cNvPr>
@@ -6966,7 +6966,7 @@
           <p:cNvPr id="27" name="">
             <a:extLst xmlns:a="http://schemas.openxmlformats.org/drawingml/2006/main">
               <a:ext uri="{FF2B5EF4-FFF2-40B4-BE49-F238E27FC236}">
-                <a16:creationId xmlns:a16="http://schemas.microsoft.com/office/drawing/2014/main" id="{7DF99AD0-314C-436D-BA6E-476AD833308B}"/>
+                <a16:creationId xmlns:a16="http://schemas.microsoft.com/office/drawing/2014/main" id="{636AB727-06DB-4141-BDE4-F3EA4A226B37}"/>
               </a:ext>
             </a:extLst>
           </p:cNvPr>
@@ -7026,7 +7026,7 @@
           <p:cNvPr id="28" name="">
             <a:extLst xmlns:a="http://schemas.openxmlformats.org/drawingml/2006/main">
               <a:ext uri="{FF2B5EF4-FFF2-40B4-BE49-F238E27FC236}">
-                <a16:creationId xmlns:a16="http://schemas.microsoft.com/office/drawing/2014/main" id="{116D416A-2815-4111-9DAB-C385197FA27A}"/>
+                <a16:creationId xmlns:a16="http://schemas.microsoft.com/office/drawing/2014/main" id="{A8D0B83A-9EE9-4117-88CC-45287AFCF8BF}"/>
               </a:ext>
             </a:extLst>
           </p:cNvPr>
@@ -7061,7 +7061,7 @@
           <p:cNvPr id="29" name="">
             <a:extLst xmlns:a="http://schemas.openxmlformats.org/drawingml/2006/main">
               <a:ext uri="{FF2B5EF4-FFF2-40B4-BE49-F238E27FC236}">
-                <a16:creationId xmlns:a16="http://schemas.microsoft.com/office/drawing/2014/main" id="{101E8DD3-D661-40C9-8C45-67AE57C64846}"/>
+                <a16:creationId xmlns:a16="http://schemas.microsoft.com/office/drawing/2014/main" id="{AD04F92E-874B-4285-8B45-B90EC4F8BAB1}"/>
               </a:ext>
             </a:extLst>
           </p:cNvPr>
@@ -7121,7 +7121,7 @@
           <p:cNvPr id="30" name="">
             <a:extLst xmlns:a="http://schemas.openxmlformats.org/drawingml/2006/main">
               <a:ext uri="{FF2B5EF4-FFF2-40B4-BE49-F238E27FC236}">
-                <a16:creationId xmlns:a16="http://schemas.microsoft.com/office/drawing/2014/main" id="{0538A824-D786-4E5C-8253-6E217B39BE1E}"/>
+                <a16:creationId xmlns:a16="http://schemas.microsoft.com/office/drawing/2014/main" id="{593E6642-3FF2-4B68-8CC0-40B1ADD3D342}"/>
               </a:ext>
             </a:extLst>
           </p:cNvPr>
@@ -7181,7 +7181,7 @@
           <p:cNvPr id="31" name="">
             <a:extLst xmlns:a="http://schemas.openxmlformats.org/drawingml/2006/main">
               <a:ext uri="{FF2B5EF4-FFF2-40B4-BE49-F238E27FC236}">
-                <a16:creationId xmlns:a16="http://schemas.microsoft.com/office/drawing/2014/main" id="{9BD3704D-FB60-4A6E-85CE-2BAC450FF81F}"/>
+                <a16:creationId xmlns:a16="http://schemas.microsoft.com/office/drawing/2014/main" id="{8748DF41-4531-49C5-9D20-3ECED302C6DF}"/>
               </a:ext>
             </a:extLst>
           </p:cNvPr>
@@ -7216,7 +7216,7 @@
           <p:cNvPr id="32" name="">
             <a:extLst xmlns:a="http://schemas.openxmlformats.org/drawingml/2006/main">
               <a:ext uri="{FF2B5EF4-FFF2-40B4-BE49-F238E27FC236}">
-                <a16:creationId xmlns:a16="http://schemas.microsoft.com/office/drawing/2014/main" id="{577D2AEB-4138-4293-B53F-609A71D835F1}"/>
+                <a16:creationId xmlns:a16="http://schemas.microsoft.com/office/drawing/2014/main" id="{615B24A2-80A2-4331-AF3F-20C37B783E10}"/>
               </a:ext>
             </a:extLst>
           </p:cNvPr>
@@ -7276,7 +7276,7 @@
           <p:cNvPr id="33" name="">
             <a:extLst xmlns:a="http://schemas.openxmlformats.org/drawingml/2006/main">
               <a:ext uri="{FF2B5EF4-FFF2-40B4-BE49-F238E27FC236}">
-                <a16:creationId xmlns:a16="http://schemas.microsoft.com/office/drawing/2014/main" id="{DD45B7E5-D20C-4E05-97E3-C507078E21BF}"/>
+                <a16:creationId xmlns:a16="http://schemas.microsoft.com/office/drawing/2014/main" id="{274E9D4B-AF12-49A4-9A17-07B366E01E79}"/>
               </a:ext>
             </a:extLst>
           </p:cNvPr>
@@ -7336,7 +7336,7 @@
           <p:cNvPr id="34" name="">
             <a:extLst xmlns:a="http://schemas.openxmlformats.org/drawingml/2006/main">
               <a:ext uri="{FF2B5EF4-FFF2-40B4-BE49-F238E27FC236}">
-                <a16:creationId xmlns:a16="http://schemas.microsoft.com/office/drawing/2014/main" id="{3CB388AB-E3C0-4DC4-A331-6C094836132D}"/>
+                <a16:creationId xmlns:a16="http://schemas.microsoft.com/office/drawing/2014/main" id="{E0E591C5-40DD-4920-B646-1B2DB4DA6268}"/>
               </a:ext>
             </a:extLst>
           </p:cNvPr>
@@ -7392,7 +7392,7 @@
     </p:spTree>
     <p:extLst>
       <p:ext uri="{BB962C8B-B14F-4D97-AF65-F5344CB8AC3E}">
-        <p14:creationId xmlns:p14="http://schemas.microsoft.com/office/powerpoint/2010/main" val="1491795661"/>
+        <p14:creationId xmlns:p14="http://schemas.microsoft.com/office/powerpoint/2010/main" val="400262076"/>
       </p:ext>
     </p:extLst>
   </p:cSld>
@@ -7423,7 +7423,7 @@
           <p:cNvPr id="1" name="Slide Number Placeholder 5">
             <a:extLst xmlns:a="http://schemas.openxmlformats.org/drawingml/2006/main">
               <a:ext uri="{FF2B5EF4-FFF2-40B4-BE49-F238E27FC236}">
-                <a16:creationId xmlns:a16="http://schemas.microsoft.com/office/drawing/2014/main" id="{A2D8A6D6-5A49-46F7-8AC4-D6254B37C82A}"/>
+                <a16:creationId xmlns:a16="http://schemas.microsoft.com/office/drawing/2014/main" id="{9EDFBF68-94E1-445A-9556-759B9580ED01}"/>
               </a:ext>
             </a:extLst>
           </p:cNvPr>
@@ -7455,7 +7455,7 @@
           <p:cNvPr id="2" name="">
             <a:extLst xmlns:a="http://schemas.openxmlformats.org/drawingml/2006/main">
               <a:ext uri="{FF2B5EF4-FFF2-40B4-BE49-F238E27FC236}">
-                <a16:creationId xmlns:a16="http://schemas.microsoft.com/office/drawing/2014/main" id="{A38C9DB2-0769-48D6-AD66-9AC52C62C384}"/>
+                <a16:creationId xmlns:a16="http://schemas.microsoft.com/office/drawing/2014/main" id="{5F9352A1-7439-4730-9853-2960998D972A}"/>
               </a:ext>
             </a:extLst>
           </p:cNvPr>
@@ -7490,7 +7490,7 @@
           <p:cNvPr id="3" name="">
             <a:extLst xmlns:a="http://schemas.openxmlformats.org/drawingml/2006/main">
               <a:ext uri="{FF2B5EF4-FFF2-40B4-BE49-F238E27FC236}">
-                <a16:creationId xmlns:a16="http://schemas.microsoft.com/office/drawing/2014/main" id="{A96711EF-0253-4106-B5B1-7331F7B76EBD}"/>
+                <a16:creationId xmlns:a16="http://schemas.microsoft.com/office/drawing/2014/main" id="{B5DD908E-EC2C-4CEF-B8F1-B2508B85B4F6}"/>
               </a:ext>
             </a:extLst>
           </p:cNvPr>
@@ -7525,7 +7525,7 @@
           <p:cNvPr id="4" name="">
             <a:extLst xmlns:a="http://schemas.openxmlformats.org/drawingml/2006/main">
               <a:ext uri="{FF2B5EF4-FFF2-40B4-BE49-F238E27FC236}">
-                <a16:creationId xmlns:a16="http://schemas.microsoft.com/office/drawing/2014/main" id="{8F89EDAB-C25E-4B1C-B4B4-F1C84FB5159E}"/>
+                <a16:creationId xmlns:a16="http://schemas.microsoft.com/office/drawing/2014/main" id="{1FFCE287-31CC-49F9-A598-AFAC140F8DCF}"/>
               </a:ext>
             </a:extLst>
           </p:cNvPr>
@@ -7560,7 +7560,7 @@
           <p:cNvPr id="5" name="">
             <a:extLst xmlns:a="http://schemas.openxmlformats.org/drawingml/2006/main">
               <a:ext uri="{FF2B5EF4-FFF2-40B4-BE49-F238E27FC236}">
-                <a16:creationId xmlns:a16="http://schemas.microsoft.com/office/drawing/2014/main" id="{76DE69E7-9525-4F76-9444-FB23AA5D3F84}"/>
+                <a16:creationId xmlns:a16="http://schemas.microsoft.com/office/drawing/2014/main" id="{87DBEF47-7E42-4BDA-BB4B-BE55867D29E9}"/>
               </a:ext>
             </a:extLst>
           </p:cNvPr>
@@ -7595,7 +7595,7 @@
           <p:cNvPr id="6" name="">
             <a:extLst xmlns:a="http://schemas.openxmlformats.org/drawingml/2006/main">
               <a:ext uri="{FF2B5EF4-FFF2-40B4-BE49-F238E27FC236}">
-                <a16:creationId xmlns:a16="http://schemas.microsoft.com/office/drawing/2014/main" id="{6335932F-D8B0-4112-9614-176E622B3AAF}"/>
+                <a16:creationId xmlns:a16="http://schemas.microsoft.com/office/drawing/2014/main" id="{DCD8681A-8560-49F8-8E8D-DEC792D6CEFB}"/>
               </a:ext>
             </a:extLst>
           </p:cNvPr>
@@ -7630,7 +7630,7 @@
           <p:cNvPr id="7" name="">
             <a:extLst xmlns:a="http://schemas.openxmlformats.org/drawingml/2006/main">
               <a:ext uri="{FF2B5EF4-FFF2-40B4-BE49-F238E27FC236}">
-                <a16:creationId xmlns:a16="http://schemas.microsoft.com/office/drawing/2014/main" id="{5D884F27-8FDB-4BE3-A71A-EFC3E88BB971}"/>
+                <a16:creationId xmlns:a16="http://schemas.microsoft.com/office/drawing/2014/main" id="{9F436D18-1C2D-4336-8010-6D246B372483}"/>
               </a:ext>
             </a:extLst>
           </p:cNvPr>
@@ -7688,7 +7688,7 @@
           <p:cNvPr id="8" name="">
             <a:extLst xmlns:a="http://schemas.openxmlformats.org/drawingml/2006/main">
               <a:ext uri="{FF2B5EF4-FFF2-40B4-BE49-F238E27FC236}">
-                <a16:creationId xmlns:a16="http://schemas.microsoft.com/office/drawing/2014/main" id="{F00AD13B-0120-415F-B921-C09253235A61}"/>
+                <a16:creationId xmlns:a16="http://schemas.microsoft.com/office/drawing/2014/main" id="{2EE119E9-F347-4427-93AB-7E12A1BE39BE}"/>
               </a:ext>
             </a:extLst>
           </p:cNvPr>
@@ -7746,7 +7746,7 @@
           <p:cNvPr id="9" name="">
             <a:extLst xmlns:a="http://schemas.openxmlformats.org/drawingml/2006/main">
               <a:ext uri="{FF2B5EF4-FFF2-40B4-BE49-F238E27FC236}">
-                <a16:creationId xmlns:a16="http://schemas.microsoft.com/office/drawing/2014/main" id="{F6A58B49-0ACA-46F0-98A6-E6D5B9F4F086}"/>
+                <a16:creationId xmlns:a16="http://schemas.microsoft.com/office/drawing/2014/main" id="{AE7FDCDB-D453-4FDA-9B50-B7651B39CEE8}"/>
               </a:ext>
             </a:extLst>
           </p:cNvPr>
@@ -7804,7 +7804,7 @@
           <p:cNvPr id="10" name="">
             <a:extLst xmlns:a="http://schemas.openxmlformats.org/drawingml/2006/main">
               <a:ext uri="{FF2B5EF4-FFF2-40B4-BE49-F238E27FC236}">
-                <a16:creationId xmlns:a16="http://schemas.microsoft.com/office/drawing/2014/main" id="{8DD82E69-65D7-4025-AE4D-19F1BB680390}"/>
+                <a16:creationId xmlns:a16="http://schemas.microsoft.com/office/drawing/2014/main" id="{010CFCD9-CC44-4FE5-91A3-A0875342D218}"/>
               </a:ext>
             </a:extLst>
           </p:cNvPr>
@@ -7839,7 +7839,7 @@
           <p:cNvPr id="11" name="">
             <a:extLst xmlns:a="http://schemas.openxmlformats.org/drawingml/2006/main">
               <a:ext uri="{FF2B5EF4-FFF2-40B4-BE49-F238E27FC236}">
-                <a16:creationId xmlns:a16="http://schemas.microsoft.com/office/drawing/2014/main" id="{E64BA8B3-CA32-4691-BA72-CC25C15E6996}"/>
+                <a16:creationId xmlns:a16="http://schemas.microsoft.com/office/drawing/2014/main" id="{C35E7297-44B6-41AC-A5D9-75F9DEFB03D6}"/>
               </a:ext>
             </a:extLst>
           </p:cNvPr>
@@ -7899,7 +7899,7 @@
           <p:cNvPr id="12" name="">
             <a:extLst xmlns:a="http://schemas.openxmlformats.org/drawingml/2006/main">
               <a:ext uri="{FF2B5EF4-FFF2-40B4-BE49-F238E27FC236}">
-                <a16:creationId xmlns:a16="http://schemas.microsoft.com/office/drawing/2014/main" id="{415DE97B-D37A-4785-ABDF-9E5FC0C5A1FE}"/>
+                <a16:creationId xmlns:a16="http://schemas.microsoft.com/office/drawing/2014/main" id="{7CF23E9C-7C78-4353-89CC-59C82D80645F}"/>
               </a:ext>
             </a:extLst>
           </p:cNvPr>
@@ -7959,7 +7959,7 @@
           <p:cNvPr id="13" name="">
             <a:extLst xmlns:a="http://schemas.openxmlformats.org/drawingml/2006/main">
               <a:ext uri="{FF2B5EF4-FFF2-40B4-BE49-F238E27FC236}">
-                <a16:creationId xmlns:a16="http://schemas.microsoft.com/office/drawing/2014/main" id="{034A8252-E91F-46FD-B52C-AC5C14CB0942}"/>
+                <a16:creationId xmlns:a16="http://schemas.microsoft.com/office/drawing/2014/main" id="{C363CC41-E785-4B62-8792-FF280FBD0AF1}"/>
               </a:ext>
             </a:extLst>
           </p:cNvPr>
@@ -7994,7 +7994,7 @@
           <p:cNvPr id="14" name="">
             <a:extLst xmlns:a="http://schemas.openxmlformats.org/drawingml/2006/main">
               <a:ext uri="{FF2B5EF4-FFF2-40B4-BE49-F238E27FC236}">
-                <a16:creationId xmlns:a16="http://schemas.microsoft.com/office/drawing/2014/main" id="{7F56AF93-7071-4553-9A03-44215C014316}"/>
+                <a16:creationId xmlns:a16="http://schemas.microsoft.com/office/drawing/2014/main" id="{9EA50552-1121-4040-A6F9-9543EF867D5D}"/>
               </a:ext>
             </a:extLst>
           </p:cNvPr>
@@ -8029,7 +8029,7 @@
           <p:cNvPr id="15" name="">
             <a:extLst xmlns:a="http://schemas.openxmlformats.org/drawingml/2006/main">
               <a:ext uri="{FF2B5EF4-FFF2-40B4-BE49-F238E27FC236}">
-                <a16:creationId xmlns:a16="http://schemas.microsoft.com/office/drawing/2014/main" id="{03A6BB99-FB28-475C-805D-8B4799A44A1A}"/>
+                <a16:creationId xmlns:a16="http://schemas.microsoft.com/office/drawing/2014/main" id="{F7BBDFD3-F978-417D-A575-6084C26E34C7}"/>
               </a:ext>
             </a:extLst>
           </p:cNvPr>
@@ -8089,7 +8089,7 @@
           <p:cNvPr id="16" name="">
             <a:extLst xmlns:a="http://schemas.openxmlformats.org/drawingml/2006/main">
               <a:ext uri="{FF2B5EF4-FFF2-40B4-BE49-F238E27FC236}">
-                <a16:creationId xmlns:a16="http://schemas.microsoft.com/office/drawing/2014/main" id="{05FB0BCE-80EF-46B8-8B34-4CAD4A199E89}"/>
+                <a16:creationId xmlns:a16="http://schemas.microsoft.com/office/drawing/2014/main" id="{A78144A0-AE6C-468B-8DBA-DC84B1B2DEB0}"/>
               </a:ext>
             </a:extLst>
           </p:cNvPr>
@@ -8149,7 +8149,7 @@
           <p:cNvPr id="17" name="">
             <a:extLst xmlns:a="http://schemas.openxmlformats.org/drawingml/2006/main">
               <a:ext uri="{FF2B5EF4-FFF2-40B4-BE49-F238E27FC236}">
-                <a16:creationId xmlns:a16="http://schemas.microsoft.com/office/drawing/2014/main" id="{822840A7-E8D3-4CA1-AC83-E40CD5E52C8F}"/>
+                <a16:creationId xmlns:a16="http://schemas.microsoft.com/office/drawing/2014/main" id="{1E5E0B98-98B9-42D0-8121-B960EDFB5D80}"/>
               </a:ext>
             </a:extLst>
           </p:cNvPr>
@@ -8184,7 +8184,7 @@
           <p:cNvPr id="18" name="">
             <a:extLst xmlns:a="http://schemas.openxmlformats.org/drawingml/2006/main">
               <a:ext uri="{FF2B5EF4-FFF2-40B4-BE49-F238E27FC236}">
-                <a16:creationId xmlns:a16="http://schemas.microsoft.com/office/drawing/2014/main" id="{CECB92A6-1727-452B-B938-BA05942681C8}"/>
+                <a16:creationId xmlns:a16="http://schemas.microsoft.com/office/drawing/2014/main" id="{7A5B8CBA-3458-4225-A0C1-6BE9E6DC1390}"/>
               </a:ext>
             </a:extLst>
           </p:cNvPr>
@@ -8219,7 +8219,7 @@
           <p:cNvPr id="19" name="">
             <a:extLst xmlns:a="http://schemas.openxmlformats.org/drawingml/2006/main">
               <a:ext uri="{FF2B5EF4-FFF2-40B4-BE49-F238E27FC236}">
-                <a16:creationId xmlns:a16="http://schemas.microsoft.com/office/drawing/2014/main" id="{1D0B1234-6EC0-4D67-AADA-4DE17D4245D5}"/>
+                <a16:creationId xmlns:a16="http://schemas.microsoft.com/office/drawing/2014/main" id="{F9B4FA1E-68CE-4187-9904-AA9643E3BBE7}"/>
               </a:ext>
             </a:extLst>
           </p:cNvPr>
@@ -8279,7 +8279,7 @@
           <p:cNvPr id="20" name="">
             <a:extLst xmlns:a="http://schemas.openxmlformats.org/drawingml/2006/main">
               <a:ext uri="{FF2B5EF4-FFF2-40B4-BE49-F238E27FC236}">
-                <a16:creationId xmlns:a16="http://schemas.microsoft.com/office/drawing/2014/main" id="{AA46EC34-24AE-4C43-9691-7767AAC5759B}"/>
+                <a16:creationId xmlns:a16="http://schemas.microsoft.com/office/drawing/2014/main" id="{4ECCBC51-7FF5-4F87-9329-52B7EBA05143}"/>
               </a:ext>
             </a:extLst>
           </p:cNvPr>
@@ -8339,7 +8339,7 @@
           <p:cNvPr id="21" name="">
             <a:extLst xmlns:a="http://schemas.openxmlformats.org/drawingml/2006/main">
               <a:ext uri="{FF2B5EF4-FFF2-40B4-BE49-F238E27FC236}">
-                <a16:creationId xmlns:a16="http://schemas.microsoft.com/office/drawing/2014/main" id="{FAE12221-4B1E-4E65-B533-096344385824}"/>
+                <a16:creationId xmlns:a16="http://schemas.microsoft.com/office/drawing/2014/main" id="{7B740FFE-C9E4-4493-906F-E0CC2F6BC8F0}"/>
               </a:ext>
             </a:extLst>
           </p:cNvPr>
@@ -8374,7 +8374,7 @@
           <p:cNvPr id="22" name="">
             <a:extLst xmlns:a="http://schemas.openxmlformats.org/drawingml/2006/main">
               <a:ext uri="{FF2B5EF4-FFF2-40B4-BE49-F238E27FC236}">
-                <a16:creationId xmlns:a16="http://schemas.microsoft.com/office/drawing/2014/main" id="{49FB01A0-3215-429C-AD1B-9D65EC324A63}"/>
+                <a16:creationId xmlns:a16="http://schemas.microsoft.com/office/drawing/2014/main" id="{42DC6317-81B4-4DC6-A924-0215831A5C34}"/>
               </a:ext>
             </a:extLst>
           </p:cNvPr>
@@ -8409,7 +8409,7 @@
           <p:cNvPr id="23" name="">
             <a:extLst xmlns:a="http://schemas.openxmlformats.org/drawingml/2006/main">
               <a:ext uri="{FF2B5EF4-FFF2-40B4-BE49-F238E27FC236}">
-                <a16:creationId xmlns:a16="http://schemas.microsoft.com/office/drawing/2014/main" id="{D77CFD50-FFEE-4778-8828-36FF47EED08C}"/>
+                <a16:creationId xmlns:a16="http://schemas.microsoft.com/office/drawing/2014/main" id="{C4278374-F636-413C-8A8D-64D37721E7ED}"/>
               </a:ext>
             </a:extLst>
           </p:cNvPr>
@@ -8469,7 +8469,7 @@
           <p:cNvPr id="24" name="">
             <a:extLst xmlns:a="http://schemas.openxmlformats.org/drawingml/2006/main">
               <a:ext uri="{FF2B5EF4-FFF2-40B4-BE49-F238E27FC236}">
-                <a16:creationId xmlns:a16="http://schemas.microsoft.com/office/drawing/2014/main" id="{70D2E434-B5C2-47D5-98B8-68E753929336}"/>
+                <a16:creationId xmlns:a16="http://schemas.microsoft.com/office/drawing/2014/main" id="{7DC80684-83B7-4427-A8E9-C2E2B1D5B9E3}"/>
               </a:ext>
             </a:extLst>
           </p:cNvPr>
@@ -8529,7 +8529,7 @@
           <p:cNvPr id="25" name="">
             <a:extLst xmlns:a="http://schemas.openxmlformats.org/drawingml/2006/main">
               <a:ext uri="{FF2B5EF4-FFF2-40B4-BE49-F238E27FC236}">
-                <a16:creationId xmlns:a16="http://schemas.microsoft.com/office/drawing/2014/main" id="{A5758A71-8219-47B4-B5D5-75B4B884A73E}"/>
+                <a16:creationId xmlns:a16="http://schemas.microsoft.com/office/drawing/2014/main" id="{D0475E87-F392-4498-A4B2-7CCE94C77942}"/>
               </a:ext>
             </a:extLst>
           </p:cNvPr>
@@ -8564,7 +8564,7 @@
           <p:cNvPr id="26" name="">
             <a:extLst xmlns:a="http://schemas.openxmlformats.org/drawingml/2006/main">
               <a:ext uri="{FF2B5EF4-FFF2-40B4-BE49-F238E27FC236}">
-                <a16:creationId xmlns:a16="http://schemas.microsoft.com/office/drawing/2014/main" id="{BBC475E7-37EB-42FF-8781-363680A8B350}"/>
+                <a16:creationId xmlns:a16="http://schemas.microsoft.com/office/drawing/2014/main" id="{F17088C0-E316-4A82-80F1-B0C3A9A352E4}"/>
               </a:ext>
             </a:extLst>
           </p:cNvPr>
@@ -8599,7 +8599,7 @@
           <p:cNvPr id="27" name="">
             <a:extLst xmlns:a="http://schemas.openxmlformats.org/drawingml/2006/main">
               <a:ext uri="{FF2B5EF4-FFF2-40B4-BE49-F238E27FC236}">
-                <a16:creationId xmlns:a16="http://schemas.microsoft.com/office/drawing/2014/main" id="{B001B2B9-91C2-4557-BD98-0692AD5945A0}"/>
+                <a16:creationId xmlns:a16="http://schemas.microsoft.com/office/drawing/2014/main" id="{53BE1D20-450B-4BC0-933B-DEF8367B9479}"/>
               </a:ext>
             </a:extLst>
           </p:cNvPr>
@@ -8659,7 +8659,7 @@
           <p:cNvPr id="28" name="">
             <a:extLst xmlns:a="http://schemas.openxmlformats.org/drawingml/2006/main">
               <a:ext uri="{FF2B5EF4-FFF2-40B4-BE49-F238E27FC236}">
-                <a16:creationId xmlns:a16="http://schemas.microsoft.com/office/drawing/2014/main" id="{4543D99F-1561-4330-8003-043C69738E13}"/>
+                <a16:creationId xmlns:a16="http://schemas.microsoft.com/office/drawing/2014/main" id="{9E874476-F98A-4EA2-A64E-504AF7ADC81F}"/>
               </a:ext>
             </a:extLst>
           </p:cNvPr>
@@ -8717,7 +8717,7 @@
     </p:spTree>
     <p:extLst>
       <p:ext uri="{BB962C8B-B14F-4D97-AF65-F5344CB8AC3E}">
-        <p14:creationId xmlns:p14="http://schemas.microsoft.com/office/powerpoint/2010/main" val="787609196"/>
+        <p14:creationId xmlns:p14="http://schemas.microsoft.com/office/powerpoint/2010/main" val="285910846"/>
       </p:ext>
     </p:extLst>
   </p:cSld>
@@ -8748,7 +8748,7 @@
           <p:cNvPr id="1" name="Slide Number Placeholder 5">
             <a:extLst xmlns:a="http://schemas.openxmlformats.org/drawingml/2006/main">
               <a:ext uri="{FF2B5EF4-FFF2-40B4-BE49-F238E27FC236}">
-                <a16:creationId xmlns:a16="http://schemas.microsoft.com/office/drawing/2014/main" id="{A2D8A6D6-5A49-46F7-8AC4-D6254B37C82A}"/>
+                <a16:creationId xmlns:a16="http://schemas.microsoft.com/office/drawing/2014/main" id="{9EDFBF68-94E1-445A-9556-759B9580ED01}"/>
               </a:ext>
             </a:extLst>
           </p:cNvPr>
@@ -8780,7 +8780,7 @@
           <p:cNvPr id="2" name="">
             <a:extLst xmlns:a="http://schemas.openxmlformats.org/drawingml/2006/main">
               <a:ext uri="{FF2B5EF4-FFF2-40B4-BE49-F238E27FC236}">
-                <a16:creationId xmlns:a16="http://schemas.microsoft.com/office/drawing/2014/main" id="{982DDC7F-ED80-4496-91A5-71390D505EB1}"/>
+                <a16:creationId xmlns:a16="http://schemas.microsoft.com/office/drawing/2014/main" id="{AA9336E9-B583-4664-9449-B4561A71EB13}"/>
               </a:ext>
             </a:extLst>
           </p:cNvPr>
@@ -8815,7 +8815,7 @@
           <p:cNvPr id="3" name="">
             <a:extLst xmlns:a="http://schemas.openxmlformats.org/drawingml/2006/main">
               <a:ext uri="{FF2B5EF4-FFF2-40B4-BE49-F238E27FC236}">
-                <a16:creationId xmlns:a16="http://schemas.microsoft.com/office/drawing/2014/main" id="{7C1BEC8E-448F-4BC6-A41B-47144526DF1E}"/>
+                <a16:creationId xmlns:a16="http://schemas.microsoft.com/office/drawing/2014/main" id="{E8F07396-A959-4D1F-8D74-434FC51886D5}"/>
               </a:ext>
             </a:extLst>
           </p:cNvPr>
@@ -8850,7 +8850,7 @@
           <p:cNvPr id="4" name="">
             <a:extLst xmlns:a="http://schemas.openxmlformats.org/drawingml/2006/main">
               <a:ext uri="{FF2B5EF4-FFF2-40B4-BE49-F238E27FC236}">
-                <a16:creationId xmlns:a16="http://schemas.microsoft.com/office/drawing/2014/main" id="{2158F615-4317-42DE-B092-96A6FDA9EB6B}"/>
+                <a16:creationId xmlns:a16="http://schemas.microsoft.com/office/drawing/2014/main" id="{F428987C-8B00-4A54-82BA-BCDD8A120D56}"/>
               </a:ext>
             </a:extLst>
           </p:cNvPr>
@@ -8885,7 +8885,7 @@
           <p:cNvPr id="5" name="">
             <a:extLst xmlns:a="http://schemas.openxmlformats.org/drawingml/2006/main">
               <a:ext uri="{FF2B5EF4-FFF2-40B4-BE49-F238E27FC236}">
-                <a16:creationId xmlns:a16="http://schemas.microsoft.com/office/drawing/2014/main" id="{D2B80095-7985-4950-98A7-EF66E3C8BD4D}"/>
+                <a16:creationId xmlns:a16="http://schemas.microsoft.com/office/drawing/2014/main" id="{86C0DEB4-845E-405F-AA09-5B5F5A41E315}"/>
               </a:ext>
             </a:extLst>
           </p:cNvPr>
@@ -8920,7 +8920,7 @@
           <p:cNvPr id="6" name="">
             <a:extLst xmlns:a="http://schemas.openxmlformats.org/drawingml/2006/main">
               <a:ext uri="{FF2B5EF4-FFF2-40B4-BE49-F238E27FC236}">
-                <a16:creationId xmlns:a16="http://schemas.microsoft.com/office/drawing/2014/main" id="{B05B243D-756E-4475-9541-65AA16FA6832}"/>
+                <a16:creationId xmlns:a16="http://schemas.microsoft.com/office/drawing/2014/main" id="{242C0FFE-F836-40D7-955D-AC97F5D3DB1E}"/>
               </a:ext>
             </a:extLst>
           </p:cNvPr>
@@ -8955,7 +8955,7 @@
           <p:cNvPr id="7" name="">
             <a:extLst xmlns:a="http://schemas.openxmlformats.org/drawingml/2006/main">
               <a:ext uri="{FF2B5EF4-FFF2-40B4-BE49-F238E27FC236}">
-                <a16:creationId xmlns:a16="http://schemas.microsoft.com/office/drawing/2014/main" id="{A8F347F8-0C1B-4045-A622-88DD1C60A94A}"/>
+                <a16:creationId xmlns:a16="http://schemas.microsoft.com/office/drawing/2014/main" id="{8D639816-9009-4B19-8846-443A3E415B31}"/>
               </a:ext>
             </a:extLst>
           </p:cNvPr>
@@ -9013,7 +9013,7 @@
           <p:cNvPr id="8" name="">
             <a:extLst xmlns:a="http://schemas.openxmlformats.org/drawingml/2006/main">
               <a:ext uri="{FF2B5EF4-FFF2-40B4-BE49-F238E27FC236}">
-                <a16:creationId xmlns:a16="http://schemas.microsoft.com/office/drawing/2014/main" id="{8EA04854-D2E8-499A-A8FA-5BD4546B4F6B}"/>
+                <a16:creationId xmlns:a16="http://schemas.microsoft.com/office/drawing/2014/main" id="{8D60E769-42CE-48A2-95A9-161F46EA7804}"/>
               </a:ext>
             </a:extLst>
           </p:cNvPr>
@@ -9071,7 +9071,7 @@
           <p:cNvPr id="9" name="">
             <a:extLst xmlns:a="http://schemas.openxmlformats.org/drawingml/2006/main">
               <a:ext uri="{FF2B5EF4-FFF2-40B4-BE49-F238E27FC236}">
-                <a16:creationId xmlns:a16="http://schemas.microsoft.com/office/drawing/2014/main" id="{5186CA3A-68FC-444B-A67B-FC0260BF0ADA}"/>
+                <a16:creationId xmlns:a16="http://schemas.microsoft.com/office/drawing/2014/main" id="{87A2B8A0-E103-4C3C-9C25-0D3993C6D1A2}"/>
               </a:ext>
             </a:extLst>
           </p:cNvPr>
@@ -9129,7 +9129,7 @@
           <p:cNvPr id="10" name="">
             <a:extLst xmlns:a="http://schemas.openxmlformats.org/drawingml/2006/main">
               <a:ext uri="{FF2B5EF4-FFF2-40B4-BE49-F238E27FC236}">
-                <a16:creationId xmlns:a16="http://schemas.microsoft.com/office/drawing/2014/main" id="{C4896DDF-D38A-4AA6-B545-7EE746E254AF}"/>
+                <a16:creationId xmlns:a16="http://schemas.microsoft.com/office/drawing/2014/main" id="{55905395-D985-4800-A050-4E7EAF3791F4}"/>
               </a:ext>
             </a:extLst>
           </p:cNvPr>
@@ -9164,7 +9164,7 @@
           <p:cNvPr id="11" name="">
             <a:extLst xmlns:a="http://schemas.openxmlformats.org/drawingml/2006/main">
               <a:ext uri="{FF2B5EF4-FFF2-40B4-BE49-F238E27FC236}">
-                <a16:creationId xmlns:a16="http://schemas.microsoft.com/office/drawing/2014/main" id="{CE74558B-CA63-4D8C-B897-A1C2AA245F2C}"/>
+                <a16:creationId xmlns:a16="http://schemas.microsoft.com/office/drawing/2014/main" id="{08B5F144-E208-4019-B819-93786B1A35BE}"/>
               </a:ext>
             </a:extLst>
           </p:cNvPr>
@@ -9224,7 +9224,7 @@
           <p:cNvPr id="12" name="">
             <a:extLst xmlns:a="http://schemas.openxmlformats.org/drawingml/2006/main">
               <a:ext uri="{FF2B5EF4-FFF2-40B4-BE49-F238E27FC236}">
-                <a16:creationId xmlns:a16="http://schemas.microsoft.com/office/drawing/2014/main" id="{C7889151-1899-4211-A11D-6E0E70AFFA9A}"/>
+                <a16:creationId xmlns:a16="http://schemas.microsoft.com/office/drawing/2014/main" id="{5BB1221D-2182-4FEB-A7F0-AABB18932A2D}"/>
               </a:ext>
             </a:extLst>
           </p:cNvPr>
@@ -9284,7 +9284,7 @@
           <p:cNvPr id="13" name="">
             <a:extLst xmlns:a="http://schemas.openxmlformats.org/drawingml/2006/main">
               <a:ext uri="{FF2B5EF4-FFF2-40B4-BE49-F238E27FC236}">
-                <a16:creationId xmlns:a16="http://schemas.microsoft.com/office/drawing/2014/main" id="{15B969EE-EC3C-42CB-A589-ECF46E1514B0}"/>
+                <a16:creationId xmlns:a16="http://schemas.microsoft.com/office/drawing/2014/main" id="{CC28A219-C937-4888-AB76-83CAF28CCF48}"/>
               </a:ext>
             </a:extLst>
           </p:cNvPr>
@@ -9319,7 +9319,7 @@
           <p:cNvPr id="14" name="">
             <a:extLst xmlns:a="http://schemas.openxmlformats.org/drawingml/2006/main">
               <a:ext uri="{FF2B5EF4-FFF2-40B4-BE49-F238E27FC236}">
-                <a16:creationId xmlns:a16="http://schemas.microsoft.com/office/drawing/2014/main" id="{8DDF3D49-15DC-4AC6-98E4-7481A8B4FB24}"/>
+                <a16:creationId xmlns:a16="http://schemas.microsoft.com/office/drawing/2014/main" id="{88CB0212-08E3-4705-BC1E-3A05D56C74B4}"/>
               </a:ext>
             </a:extLst>
           </p:cNvPr>
@@ -9379,7 +9379,7 @@
           <p:cNvPr id="15" name="">
             <a:extLst xmlns:a="http://schemas.openxmlformats.org/drawingml/2006/main">
               <a:ext uri="{FF2B5EF4-FFF2-40B4-BE49-F238E27FC236}">
-                <a16:creationId xmlns:a16="http://schemas.microsoft.com/office/drawing/2014/main" id="{1A980861-AF9E-446B-8E5B-8172BD06006A}"/>
+                <a16:creationId xmlns:a16="http://schemas.microsoft.com/office/drawing/2014/main" id="{3A9DD0A4-1349-41A7-A4FE-231A2C8485FB}"/>
               </a:ext>
             </a:extLst>
           </p:cNvPr>
@@ -9414,7 +9414,7 @@
           <p:cNvPr id="16" name="">
             <a:extLst xmlns:a="http://schemas.openxmlformats.org/drawingml/2006/main">
               <a:ext uri="{FF2B5EF4-FFF2-40B4-BE49-F238E27FC236}">
-                <a16:creationId xmlns:a16="http://schemas.microsoft.com/office/drawing/2014/main" id="{7F30C1CC-0CA2-4B35-B7A8-9C6CEA08D350}"/>
+                <a16:creationId xmlns:a16="http://schemas.microsoft.com/office/drawing/2014/main" id="{A03C1F73-DA0A-46B0-9374-D8934B6BBD1C}"/>
               </a:ext>
             </a:extLst>
           </p:cNvPr>
@@ -9472,7 +9472,7 @@
           <p:cNvPr id="17" name="">
             <a:extLst xmlns:a="http://schemas.openxmlformats.org/drawingml/2006/main">
               <a:ext uri="{FF2B5EF4-FFF2-40B4-BE49-F238E27FC236}">
-                <a16:creationId xmlns:a16="http://schemas.microsoft.com/office/drawing/2014/main" id="{CCD9722D-7DCD-4BE1-B7B6-07A29CA2A9A5}"/>
+                <a16:creationId xmlns:a16="http://schemas.microsoft.com/office/drawing/2014/main" id="{B2E6471B-7F2A-4C12-BFFE-8819D8D3D18C}"/>
               </a:ext>
             </a:extLst>
           </p:cNvPr>
@@ -9507,7 +9507,7 @@
           <p:cNvPr id="18" name="">
             <a:extLst xmlns:a="http://schemas.openxmlformats.org/drawingml/2006/main">
               <a:ext uri="{FF2B5EF4-FFF2-40B4-BE49-F238E27FC236}">
-                <a16:creationId xmlns:a16="http://schemas.microsoft.com/office/drawing/2014/main" id="{685A23AE-53F2-4371-8AAC-EFE969EDCA50}"/>
+                <a16:creationId xmlns:a16="http://schemas.microsoft.com/office/drawing/2014/main" id="{DD96A577-00D2-45A3-A52C-22F946641261}"/>
               </a:ext>
             </a:extLst>
           </p:cNvPr>
@@ -9565,7 +9565,7 @@
           <p:cNvPr id="19" name="">
             <a:extLst xmlns:a="http://schemas.openxmlformats.org/drawingml/2006/main">
               <a:ext uri="{FF2B5EF4-FFF2-40B4-BE49-F238E27FC236}">
-                <a16:creationId xmlns:a16="http://schemas.microsoft.com/office/drawing/2014/main" id="{3B674314-91E4-475F-904D-6060AB27B43D}"/>
+                <a16:creationId xmlns:a16="http://schemas.microsoft.com/office/drawing/2014/main" id="{E411E616-076E-4B91-BC15-BAF0966349C1}"/>
               </a:ext>
             </a:extLst>
           </p:cNvPr>
@@ -9600,7 +9600,7 @@
           <p:cNvPr id="20" name="">
             <a:extLst xmlns:a="http://schemas.openxmlformats.org/drawingml/2006/main">
               <a:ext uri="{FF2B5EF4-FFF2-40B4-BE49-F238E27FC236}">
-                <a16:creationId xmlns:a16="http://schemas.microsoft.com/office/drawing/2014/main" id="{9EFAF5AD-5CAE-4D7E-AC37-13E1EEE84846}"/>
+                <a16:creationId xmlns:a16="http://schemas.microsoft.com/office/drawing/2014/main" id="{B679D651-A3A5-47E0-8FD4-CA8B5C21FB4F}"/>
               </a:ext>
             </a:extLst>
           </p:cNvPr>
@@ -9658,7 +9658,7 @@
           <p:cNvPr id="21" name="">
             <a:extLst xmlns:a="http://schemas.openxmlformats.org/drawingml/2006/main">
               <a:ext uri="{FF2B5EF4-FFF2-40B4-BE49-F238E27FC236}">
-                <a16:creationId xmlns:a16="http://schemas.microsoft.com/office/drawing/2014/main" id="{178D6D0B-2514-4137-BAA4-E9D6150B72CA}"/>
+                <a16:creationId xmlns:a16="http://schemas.microsoft.com/office/drawing/2014/main" id="{C24F635D-6E44-4EB7-8FCF-49296A43BFCD}"/>
               </a:ext>
             </a:extLst>
           </p:cNvPr>
@@ -9693,7 +9693,7 @@
           <p:cNvPr id="22" name="">
             <a:extLst xmlns:a="http://schemas.openxmlformats.org/drawingml/2006/main">
               <a:ext uri="{FF2B5EF4-FFF2-40B4-BE49-F238E27FC236}">
-                <a16:creationId xmlns:a16="http://schemas.microsoft.com/office/drawing/2014/main" id="{9B8DEA32-9D04-4BFE-8656-B90018941595}"/>
+                <a16:creationId xmlns:a16="http://schemas.microsoft.com/office/drawing/2014/main" id="{54486D92-841F-4264-9B41-1AB4C7F37607}"/>
               </a:ext>
             </a:extLst>
           </p:cNvPr>
@@ -9753,7 +9753,7 @@
           <p:cNvPr id="23" name="">
             <a:extLst xmlns:a="http://schemas.openxmlformats.org/drawingml/2006/main">
               <a:ext uri="{FF2B5EF4-FFF2-40B4-BE49-F238E27FC236}">
-                <a16:creationId xmlns:a16="http://schemas.microsoft.com/office/drawing/2014/main" id="{D6EC053D-6D8E-4F21-8D2B-E09889CCFC6E}"/>
+                <a16:creationId xmlns:a16="http://schemas.microsoft.com/office/drawing/2014/main" id="{8D2F1B61-3340-4CA6-A48E-6469B70ACC51}"/>
               </a:ext>
             </a:extLst>
           </p:cNvPr>
@@ -9813,7 +9813,7 @@
           <p:cNvPr id="24" name="">
             <a:extLst xmlns:a="http://schemas.openxmlformats.org/drawingml/2006/main">
               <a:ext uri="{FF2B5EF4-FFF2-40B4-BE49-F238E27FC236}">
-                <a16:creationId xmlns:a16="http://schemas.microsoft.com/office/drawing/2014/main" id="{3C4F50BF-1964-4437-ADF5-832A9544E2A0}"/>
+                <a16:creationId xmlns:a16="http://schemas.microsoft.com/office/drawing/2014/main" id="{0EA428D3-9A92-4C5B-9987-FA14A85FD226}"/>
               </a:ext>
             </a:extLst>
           </p:cNvPr>
@@ -9848,7 +9848,7 @@
           <p:cNvPr id="25" name="">
             <a:extLst xmlns:a="http://schemas.openxmlformats.org/drawingml/2006/main">
               <a:ext uri="{FF2B5EF4-FFF2-40B4-BE49-F238E27FC236}">
-                <a16:creationId xmlns:a16="http://schemas.microsoft.com/office/drawing/2014/main" id="{364327CB-9C63-400C-A8FE-2E224BBCFD29}"/>
+                <a16:creationId xmlns:a16="http://schemas.microsoft.com/office/drawing/2014/main" id="{78AED0EF-834F-450A-966E-8E5B9D7CF124}"/>
               </a:ext>
             </a:extLst>
           </p:cNvPr>
@@ -9883,7 +9883,7 @@
           <p:cNvPr id="26" name="">
             <a:extLst xmlns:a="http://schemas.openxmlformats.org/drawingml/2006/main">
               <a:ext uri="{FF2B5EF4-FFF2-40B4-BE49-F238E27FC236}">
-                <a16:creationId xmlns:a16="http://schemas.microsoft.com/office/drawing/2014/main" id="{DD582149-61BF-43B1-A734-5C7E25D2C8A3}"/>
+                <a16:creationId xmlns:a16="http://schemas.microsoft.com/office/drawing/2014/main" id="{C891A6A2-0B5E-4391-A64A-5F3AB75DC2F8}"/>
               </a:ext>
             </a:extLst>
           </p:cNvPr>
@@ -9943,7 +9943,7 @@
           <p:cNvPr id="27" name="">
             <a:extLst xmlns:a="http://schemas.openxmlformats.org/drawingml/2006/main">
               <a:ext uri="{FF2B5EF4-FFF2-40B4-BE49-F238E27FC236}">
-                <a16:creationId xmlns:a16="http://schemas.microsoft.com/office/drawing/2014/main" id="{6EE970B2-59BD-4285-BF22-92591C3B0F3A}"/>
+                <a16:creationId xmlns:a16="http://schemas.microsoft.com/office/drawing/2014/main" id="{C12320E4-CBE3-4070-8739-A36E695C56E2}"/>
               </a:ext>
             </a:extLst>
           </p:cNvPr>
@@ -10003,7 +10003,7 @@
           <p:cNvPr id="28" name="">
             <a:extLst xmlns:a="http://schemas.openxmlformats.org/drawingml/2006/main">
               <a:ext uri="{FF2B5EF4-FFF2-40B4-BE49-F238E27FC236}">
-                <a16:creationId xmlns:a16="http://schemas.microsoft.com/office/drawing/2014/main" id="{B6EB4F99-EE84-4F5F-9279-58E82C8D0036}"/>
+                <a16:creationId xmlns:a16="http://schemas.microsoft.com/office/drawing/2014/main" id="{C62A1932-192E-452E-8CD9-799593CA3416}"/>
               </a:ext>
             </a:extLst>
           </p:cNvPr>
@@ -10038,7 +10038,7 @@
           <p:cNvPr id="29" name="">
             <a:extLst xmlns:a="http://schemas.openxmlformats.org/drawingml/2006/main">
               <a:ext uri="{FF2B5EF4-FFF2-40B4-BE49-F238E27FC236}">
-                <a16:creationId xmlns:a16="http://schemas.microsoft.com/office/drawing/2014/main" id="{DA0FA052-9904-45AB-ADB6-073D6B36F259}"/>
+                <a16:creationId xmlns:a16="http://schemas.microsoft.com/office/drawing/2014/main" id="{7AAC841D-9E6D-4E79-BDF6-28E63C4FF890}"/>
               </a:ext>
             </a:extLst>
           </p:cNvPr>
@@ -10073,7 +10073,7 @@
           <p:cNvPr id="30" name="">
             <a:extLst xmlns:a="http://schemas.openxmlformats.org/drawingml/2006/main">
               <a:ext uri="{FF2B5EF4-FFF2-40B4-BE49-F238E27FC236}">
-                <a16:creationId xmlns:a16="http://schemas.microsoft.com/office/drawing/2014/main" id="{D8DE2120-27A5-41C3-BA9F-1F9D96D3903B}"/>
+                <a16:creationId xmlns:a16="http://schemas.microsoft.com/office/drawing/2014/main" id="{60600FE6-2456-42DE-863E-07B092A33BEB}"/>
               </a:ext>
             </a:extLst>
           </p:cNvPr>
@@ -10133,7 +10133,7 @@
           <p:cNvPr id="31" name="">
             <a:extLst xmlns:a="http://schemas.openxmlformats.org/drawingml/2006/main">
               <a:ext uri="{FF2B5EF4-FFF2-40B4-BE49-F238E27FC236}">
-                <a16:creationId xmlns:a16="http://schemas.microsoft.com/office/drawing/2014/main" id="{CF2F41BC-7B5C-4688-B931-99690E5EB009}"/>
+                <a16:creationId xmlns:a16="http://schemas.microsoft.com/office/drawing/2014/main" id="{4748A589-F306-46A8-A18B-E34DEA81BAB6}"/>
               </a:ext>
             </a:extLst>
           </p:cNvPr>
@@ -10193,7 +10193,7 @@
           <p:cNvPr id="32" name="">
             <a:extLst xmlns:a="http://schemas.openxmlformats.org/drawingml/2006/main">
               <a:ext uri="{FF2B5EF4-FFF2-40B4-BE49-F238E27FC236}">
-                <a16:creationId xmlns:a16="http://schemas.microsoft.com/office/drawing/2014/main" id="{588E50D2-DEB1-4541-B989-5D40929E8C8F}"/>
+                <a16:creationId xmlns:a16="http://schemas.microsoft.com/office/drawing/2014/main" id="{FFF4760A-EED5-485D-83D6-1B591BE8A3BF}"/>
               </a:ext>
             </a:extLst>
           </p:cNvPr>
@@ -10228,7 +10228,7 @@
           <p:cNvPr id="33" name="">
             <a:extLst xmlns:a="http://schemas.openxmlformats.org/drawingml/2006/main">
               <a:ext uri="{FF2B5EF4-FFF2-40B4-BE49-F238E27FC236}">
-                <a16:creationId xmlns:a16="http://schemas.microsoft.com/office/drawing/2014/main" id="{183C4B27-C92C-4794-9204-D979CF103CBC}"/>
+                <a16:creationId xmlns:a16="http://schemas.microsoft.com/office/drawing/2014/main" id="{CFE713FB-1C1B-4FA8-B8B7-1D9C3B8411A1}"/>
               </a:ext>
             </a:extLst>
           </p:cNvPr>
@@ -10263,7 +10263,7 @@
           <p:cNvPr id="34" name="">
             <a:extLst xmlns:a="http://schemas.openxmlformats.org/drawingml/2006/main">
               <a:ext uri="{FF2B5EF4-FFF2-40B4-BE49-F238E27FC236}">
-                <a16:creationId xmlns:a16="http://schemas.microsoft.com/office/drawing/2014/main" id="{AFFA0E35-4EF1-411F-A654-1CB644FA3E92}"/>
+                <a16:creationId xmlns:a16="http://schemas.microsoft.com/office/drawing/2014/main" id="{917E5D40-2F18-46D3-9F9E-95E36ADE95A0}"/>
               </a:ext>
             </a:extLst>
           </p:cNvPr>
@@ -10323,7 +10323,7 @@
           <p:cNvPr id="35" name="">
             <a:extLst xmlns:a="http://schemas.openxmlformats.org/drawingml/2006/main">
               <a:ext uri="{FF2B5EF4-FFF2-40B4-BE49-F238E27FC236}">
-                <a16:creationId xmlns:a16="http://schemas.microsoft.com/office/drawing/2014/main" id="{A0A803D4-E93C-4038-B922-18A2764AB870}"/>
+                <a16:creationId xmlns:a16="http://schemas.microsoft.com/office/drawing/2014/main" id="{9195634E-9EA8-48AA-B511-CB49C0F6A69A}"/>
               </a:ext>
             </a:extLst>
           </p:cNvPr>
@@ -10381,7 +10381,7 @@
     </p:spTree>
     <p:extLst>
       <p:ext uri="{BB962C8B-B14F-4D97-AF65-F5344CB8AC3E}">
-        <p14:creationId xmlns:p14="http://schemas.microsoft.com/office/powerpoint/2010/main" val="827399310"/>
+        <p14:creationId xmlns:p14="http://schemas.microsoft.com/office/powerpoint/2010/main" val="1055168367"/>
       </p:ext>
     </p:extLst>
   </p:cSld>
@@ -10412,7 +10412,7 @@
           <p:cNvPr id="1" name="Slide Number Placeholder 5">
             <a:extLst xmlns:a="http://schemas.openxmlformats.org/drawingml/2006/main">
               <a:ext uri="{FF2B5EF4-FFF2-40B4-BE49-F238E27FC236}">
-                <a16:creationId xmlns:a16="http://schemas.microsoft.com/office/drawing/2014/main" id="{A2D8A6D6-5A49-46F7-8AC4-D6254B37C82A}"/>
+                <a16:creationId xmlns:a16="http://schemas.microsoft.com/office/drawing/2014/main" id="{9EDFBF68-94E1-445A-9556-759B9580ED01}"/>
               </a:ext>
             </a:extLst>
           </p:cNvPr>
@@ -10444,7 +10444,7 @@
           <p:cNvPr id="2" name="">
             <a:extLst xmlns:a="http://schemas.openxmlformats.org/drawingml/2006/main">
               <a:ext uri="{FF2B5EF4-FFF2-40B4-BE49-F238E27FC236}">
-                <a16:creationId xmlns:a16="http://schemas.microsoft.com/office/drawing/2014/main" id="{BB8575E9-1BEA-4DB9-B1C4-056F1B473E75}"/>
+                <a16:creationId xmlns:a16="http://schemas.microsoft.com/office/drawing/2014/main" id="{28A6373F-F9E5-4E3B-B312-78DA0FB44F4E}"/>
               </a:ext>
             </a:extLst>
           </p:cNvPr>
@@ -10479,7 +10479,7 @@
           <p:cNvPr id="3" name="">
             <a:extLst xmlns:a="http://schemas.openxmlformats.org/drawingml/2006/main">
               <a:ext uri="{FF2B5EF4-FFF2-40B4-BE49-F238E27FC236}">
-                <a16:creationId xmlns:a16="http://schemas.microsoft.com/office/drawing/2014/main" id="{4C9E1B53-6243-4181-B555-D1EBD877B1FF}"/>
+                <a16:creationId xmlns:a16="http://schemas.microsoft.com/office/drawing/2014/main" id="{D95187DB-79AC-4B42-9D33-E251C697DC99}"/>
               </a:ext>
             </a:extLst>
           </p:cNvPr>
@@ -10514,7 +10514,7 @@
           <p:cNvPr id="4" name="">
             <a:extLst xmlns:a="http://schemas.openxmlformats.org/drawingml/2006/main">
               <a:ext uri="{FF2B5EF4-FFF2-40B4-BE49-F238E27FC236}">
-                <a16:creationId xmlns:a16="http://schemas.microsoft.com/office/drawing/2014/main" id="{5CD833DA-7CD8-4905-86FA-35145F0DB3D7}"/>
+                <a16:creationId xmlns:a16="http://schemas.microsoft.com/office/drawing/2014/main" id="{ADC4D986-0CCD-4AC4-82D6-016057E071CE}"/>
               </a:ext>
             </a:extLst>
           </p:cNvPr>
@@ -10549,7 +10549,7 @@
           <p:cNvPr id="5" name="">
             <a:extLst xmlns:a="http://schemas.openxmlformats.org/drawingml/2006/main">
               <a:ext uri="{FF2B5EF4-FFF2-40B4-BE49-F238E27FC236}">
-                <a16:creationId xmlns:a16="http://schemas.microsoft.com/office/drawing/2014/main" id="{0F845364-311A-4C83-8235-066171213822}"/>
+                <a16:creationId xmlns:a16="http://schemas.microsoft.com/office/drawing/2014/main" id="{B4B23B45-679B-4636-BB5D-F45449D0E0BE}"/>
               </a:ext>
             </a:extLst>
           </p:cNvPr>
@@ -10584,7 +10584,7 @@
           <p:cNvPr id="6" name="">
             <a:extLst xmlns:a="http://schemas.openxmlformats.org/drawingml/2006/main">
               <a:ext uri="{FF2B5EF4-FFF2-40B4-BE49-F238E27FC236}">
-                <a16:creationId xmlns:a16="http://schemas.microsoft.com/office/drawing/2014/main" id="{2FD226C1-1FB9-4150-9455-19AF6988D888}"/>
+                <a16:creationId xmlns:a16="http://schemas.microsoft.com/office/drawing/2014/main" id="{0A0B8A03-02B3-4692-B478-38FA8876AFEA}"/>
               </a:ext>
             </a:extLst>
           </p:cNvPr>
@@ -10619,7 +10619,7 @@
           <p:cNvPr id="7" name="">
             <a:extLst xmlns:a="http://schemas.openxmlformats.org/drawingml/2006/main">
               <a:ext uri="{FF2B5EF4-FFF2-40B4-BE49-F238E27FC236}">
-                <a16:creationId xmlns:a16="http://schemas.microsoft.com/office/drawing/2014/main" id="{ECA7E056-82F5-491D-B201-52418EDB2245}"/>
+                <a16:creationId xmlns:a16="http://schemas.microsoft.com/office/drawing/2014/main" id="{D4186AF4-E655-483B-A9C9-A4C7B5112CAB}"/>
               </a:ext>
             </a:extLst>
           </p:cNvPr>
@@ -10677,7 +10677,7 @@
           <p:cNvPr id="8" name="">
             <a:extLst xmlns:a="http://schemas.openxmlformats.org/drawingml/2006/main">
               <a:ext uri="{FF2B5EF4-FFF2-40B4-BE49-F238E27FC236}">
-                <a16:creationId xmlns:a16="http://schemas.microsoft.com/office/drawing/2014/main" id="{02676F47-8168-4D21-BE93-AA100A11A29B}"/>
+                <a16:creationId xmlns:a16="http://schemas.microsoft.com/office/drawing/2014/main" id="{7E55873E-DFCD-41C3-A703-336BE882A197}"/>
               </a:ext>
             </a:extLst>
           </p:cNvPr>
@@ -10735,7 +10735,7 @@
           <p:cNvPr id="9" name="">
             <a:extLst xmlns:a="http://schemas.openxmlformats.org/drawingml/2006/main">
               <a:ext uri="{FF2B5EF4-FFF2-40B4-BE49-F238E27FC236}">
-                <a16:creationId xmlns:a16="http://schemas.microsoft.com/office/drawing/2014/main" id="{AA8788BF-7794-44E7-B461-7AE0245EAAB1}"/>
+                <a16:creationId xmlns:a16="http://schemas.microsoft.com/office/drawing/2014/main" id="{082C8755-0ACC-4B01-8282-B7AC12C1D374}"/>
               </a:ext>
             </a:extLst>
           </p:cNvPr>
@@ -10793,7 +10793,7 @@
           <p:cNvPr id="10" name="">
             <a:extLst xmlns:a="http://schemas.openxmlformats.org/drawingml/2006/main">
               <a:ext uri="{FF2B5EF4-FFF2-40B4-BE49-F238E27FC236}">
-                <a16:creationId xmlns:a16="http://schemas.microsoft.com/office/drawing/2014/main" id="{DD9DA037-A858-486F-82B5-C4E2F416570B}"/>
+                <a16:creationId xmlns:a16="http://schemas.microsoft.com/office/drawing/2014/main" id="{D393164D-65D0-48D6-AF08-EC12B6A5FCA3}"/>
               </a:ext>
             </a:extLst>
           </p:cNvPr>
@@ -10828,7 +10828,7 @@
           <p:cNvPr id="11" name="">
             <a:extLst xmlns:a="http://schemas.openxmlformats.org/drawingml/2006/main">
               <a:ext uri="{FF2B5EF4-FFF2-40B4-BE49-F238E27FC236}">
-                <a16:creationId xmlns:a16="http://schemas.microsoft.com/office/drawing/2014/main" id="{6F17777B-B204-47BA-B633-739AB4B38B02}"/>
+                <a16:creationId xmlns:a16="http://schemas.microsoft.com/office/drawing/2014/main" id="{B92570CE-F559-4BB5-B8D0-E19A8007D984}"/>
               </a:ext>
             </a:extLst>
           </p:cNvPr>
@@ -10888,7 +10888,7 @@
           <p:cNvPr id="12" name="">
             <a:extLst xmlns:a="http://schemas.openxmlformats.org/drawingml/2006/main">
               <a:ext uri="{FF2B5EF4-FFF2-40B4-BE49-F238E27FC236}">
-                <a16:creationId xmlns:a16="http://schemas.microsoft.com/office/drawing/2014/main" id="{69B56C05-592F-4547-B5E1-CA55B8540AD7}"/>
+                <a16:creationId xmlns:a16="http://schemas.microsoft.com/office/drawing/2014/main" id="{3A6553F1-99B7-4CC2-B9E1-44C8EF119D18}"/>
               </a:ext>
             </a:extLst>
           </p:cNvPr>
@@ -10948,7 +10948,7 @@
           <p:cNvPr id="13" name="">
             <a:extLst xmlns:a="http://schemas.openxmlformats.org/drawingml/2006/main">
               <a:ext uri="{FF2B5EF4-FFF2-40B4-BE49-F238E27FC236}">
-                <a16:creationId xmlns:a16="http://schemas.microsoft.com/office/drawing/2014/main" id="{CBE36ECE-79AD-40A0-BEC2-679BD294C41C}"/>
+                <a16:creationId xmlns:a16="http://schemas.microsoft.com/office/drawing/2014/main" id="{539F5D43-1721-44E8-8412-2C6447ACA405}"/>
               </a:ext>
             </a:extLst>
           </p:cNvPr>
@@ -10983,7 +10983,7 @@
           <p:cNvPr id="14" name="">
             <a:extLst xmlns:a="http://schemas.openxmlformats.org/drawingml/2006/main">
               <a:ext uri="{FF2B5EF4-FFF2-40B4-BE49-F238E27FC236}">
-                <a16:creationId xmlns:a16="http://schemas.microsoft.com/office/drawing/2014/main" id="{A17656B1-5942-48A0-A56D-A7EA95F21FCB}"/>
+                <a16:creationId xmlns:a16="http://schemas.microsoft.com/office/drawing/2014/main" id="{E94A0C89-0985-468D-849E-562022B5232A}"/>
               </a:ext>
             </a:extLst>
           </p:cNvPr>
@@ -11043,7 +11043,7 @@
           <p:cNvPr id="15" name="">
             <a:extLst xmlns:a="http://schemas.openxmlformats.org/drawingml/2006/main">
               <a:ext uri="{FF2B5EF4-FFF2-40B4-BE49-F238E27FC236}">
-                <a16:creationId xmlns:a16="http://schemas.microsoft.com/office/drawing/2014/main" id="{DF707AEA-A24C-4BDE-A36A-D83B0B188391}"/>
+                <a16:creationId xmlns:a16="http://schemas.microsoft.com/office/drawing/2014/main" id="{1CABFC47-1214-48D5-97DF-09725154A696}"/>
               </a:ext>
             </a:extLst>
           </p:cNvPr>
@@ -11103,7 +11103,7 @@
           <p:cNvPr id="16" name="">
             <a:extLst xmlns:a="http://schemas.openxmlformats.org/drawingml/2006/main">
               <a:ext uri="{FF2B5EF4-FFF2-40B4-BE49-F238E27FC236}">
-                <a16:creationId xmlns:a16="http://schemas.microsoft.com/office/drawing/2014/main" id="{386922C5-D063-4E2C-83C6-CF099D660FB1}"/>
+                <a16:creationId xmlns:a16="http://schemas.microsoft.com/office/drawing/2014/main" id="{2C2BD24F-CA9E-48D6-B102-9CBA9AA903FC}"/>
               </a:ext>
             </a:extLst>
           </p:cNvPr>
@@ -11138,7 +11138,7 @@
           <p:cNvPr id="17" name="">
             <a:extLst xmlns:a="http://schemas.openxmlformats.org/drawingml/2006/main">
               <a:ext uri="{FF2B5EF4-FFF2-40B4-BE49-F238E27FC236}">
-                <a16:creationId xmlns:a16="http://schemas.microsoft.com/office/drawing/2014/main" id="{C4EF1A68-2FC6-4D5A-BB60-9D8698B9DB6D}"/>
+                <a16:creationId xmlns:a16="http://schemas.microsoft.com/office/drawing/2014/main" id="{7CAD176B-83A9-426D-8DF8-BBF4F31214A4}"/>
               </a:ext>
             </a:extLst>
           </p:cNvPr>
@@ -11198,7 +11198,7 @@
           <p:cNvPr id="18" name="">
             <a:extLst xmlns:a="http://schemas.openxmlformats.org/drawingml/2006/main">
               <a:ext uri="{FF2B5EF4-FFF2-40B4-BE49-F238E27FC236}">
-                <a16:creationId xmlns:a16="http://schemas.microsoft.com/office/drawing/2014/main" id="{F01F1712-37BB-4E84-BCF1-9AD14A3EB97D}"/>
+                <a16:creationId xmlns:a16="http://schemas.microsoft.com/office/drawing/2014/main" id="{6872AA98-BC28-435A-B1D1-F730378FBEF8}"/>
               </a:ext>
             </a:extLst>
           </p:cNvPr>
@@ -11258,7 +11258,7 @@
           <p:cNvPr id="19" name="">
             <a:extLst xmlns:a="http://schemas.openxmlformats.org/drawingml/2006/main">
               <a:ext uri="{FF2B5EF4-FFF2-40B4-BE49-F238E27FC236}">
-                <a16:creationId xmlns:a16="http://schemas.microsoft.com/office/drawing/2014/main" id="{A57E8DCE-E8E4-43B9-8F22-79B03E48A1EF}"/>
+                <a16:creationId xmlns:a16="http://schemas.microsoft.com/office/drawing/2014/main" id="{8CCA4BED-4454-410B-96AA-1C3D6AD78718}"/>
               </a:ext>
             </a:extLst>
           </p:cNvPr>
@@ -11293,7 +11293,7 @@
           <p:cNvPr id="20" name="">
             <a:extLst xmlns:a="http://schemas.openxmlformats.org/drawingml/2006/main">
               <a:ext uri="{FF2B5EF4-FFF2-40B4-BE49-F238E27FC236}">
-                <a16:creationId xmlns:a16="http://schemas.microsoft.com/office/drawing/2014/main" id="{70456216-3444-40F6-A302-FA97654A2315}"/>
+                <a16:creationId xmlns:a16="http://schemas.microsoft.com/office/drawing/2014/main" id="{ADBFDA72-54CA-43E6-B5C0-DFD688F98795}"/>
               </a:ext>
             </a:extLst>
           </p:cNvPr>
@@ -11328,7 +11328,7 @@
           <p:cNvPr id="21" name="">
             <a:extLst xmlns:a="http://schemas.openxmlformats.org/drawingml/2006/main">
               <a:ext uri="{FF2B5EF4-FFF2-40B4-BE49-F238E27FC236}">
-                <a16:creationId xmlns:a16="http://schemas.microsoft.com/office/drawing/2014/main" id="{E5AD0B23-9646-4997-A5FF-8BD713B07221}"/>
+                <a16:creationId xmlns:a16="http://schemas.microsoft.com/office/drawing/2014/main" id="{93B46316-1C20-4C54-AE8C-D1E2E76350B3}"/>
               </a:ext>
             </a:extLst>
           </p:cNvPr>
@@ -11388,7 +11388,7 @@
           <p:cNvPr id="22" name="">
             <a:extLst xmlns:a="http://schemas.openxmlformats.org/drawingml/2006/main">
               <a:ext uri="{FF2B5EF4-FFF2-40B4-BE49-F238E27FC236}">
-                <a16:creationId xmlns:a16="http://schemas.microsoft.com/office/drawing/2014/main" id="{99EB2772-CF25-4381-BA5E-2FF1562B2E04}"/>
+                <a16:creationId xmlns:a16="http://schemas.microsoft.com/office/drawing/2014/main" id="{D8E22E69-49CA-4D44-9B67-11D3F9979B30}"/>
               </a:ext>
             </a:extLst>
           </p:cNvPr>
@@ -11448,7 +11448,7 @@
           <p:cNvPr id="23" name="">
             <a:extLst xmlns:a="http://schemas.openxmlformats.org/drawingml/2006/main">
               <a:ext uri="{FF2B5EF4-FFF2-40B4-BE49-F238E27FC236}">
-                <a16:creationId xmlns:a16="http://schemas.microsoft.com/office/drawing/2014/main" id="{74A66F7D-F059-4EDB-9467-BBD0AFE21E2B}"/>
+                <a16:creationId xmlns:a16="http://schemas.microsoft.com/office/drawing/2014/main" id="{A2125A19-B240-44D7-B411-3EFC15C0896B}"/>
               </a:ext>
             </a:extLst>
           </p:cNvPr>
@@ -11483,7 +11483,7 @@
           <p:cNvPr id="24" name="">
             <a:extLst xmlns:a="http://schemas.openxmlformats.org/drawingml/2006/main">
               <a:ext uri="{FF2B5EF4-FFF2-40B4-BE49-F238E27FC236}">
-                <a16:creationId xmlns:a16="http://schemas.microsoft.com/office/drawing/2014/main" id="{8E2E212B-1359-4A87-89D2-467FB9846551}"/>
+                <a16:creationId xmlns:a16="http://schemas.microsoft.com/office/drawing/2014/main" id="{9DFB4903-2942-4E6A-8DDD-73CE719719AE}"/>
               </a:ext>
             </a:extLst>
           </p:cNvPr>
@@ -11518,7 +11518,7 @@
           <p:cNvPr id="25" name="">
             <a:extLst xmlns:a="http://schemas.openxmlformats.org/drawingml/2006/main">
               <a:ext uri="{FF2B5EF4-FFF2-40B4-BE49-F238E27FC236}">
-                <a16:creationId xmlns:a16="http://schemas.microsoft.com/office/drawing/2014/main" id="{CD983F9C-1B49-40B1-A095-CDBA66F6A26E}"/>
+                <a16:creationId xmlns:a16="http://schemas.microsoft.com/office/drawing/2014/main" id="{BC07C11E-0574-4D05-9A1C-602F2848B444}"/>
               </a:ext>
             </a:extLst>
           </p:cNvPr>
@@ -11578,7 +11578,7 @@
           <p:cNvPr id="26" name="">
             <a:extLst xmlns:a="http://schemas.openxmlformats.org/drawingml/2006/main">
               <a:ext uri="{FF2B5EF4-FFF2-40B4-BE49-F238E27FC236}">
-                <a16:creationId xmlns:a16="http://schemas.microsoft.com/office/drawing/2014/main" id="{4088A994-E344-41EA-82E4-B1507DD90AE0}"/>
+                <a16:creationId xmlns:a16="http://schemas.microsoft.com/office/drawing/2014/main" id="{C92F64FD-88AC-4943-9E8A-0B7E2356CF58}"/>
               </a:ext>
             </a:extLst>
           </p:cNvPr>
@@ -11638,7 +11638,7 @@
           <p:cNvPr id="27" name="">
             <a:extLst xmlns:a="http://schemas.openxmlformats.org/drawingml/2006/main">
               <a:ext uri="{FF2B5EF4-FFF2-40B4-BE49-F238E27FC236}">
-                <a16:creationId xmlns:a16="http://schemas.microsoft.com/office/drawing/2014/main" id="{90CF4EB1-BD09-4770-BC21-53E432080A55}"/>
+                <a16:creationId xmlns:a16="http://schemas.microsoft.com/office/drawing/2014/main" id="{3B99CC5A-5FC4-4719-A1AB-40AF4A114E6A}"/>
               </a:ext>
             </a:extLst>
           </p:cNvPr>
@@ -11673,7 +11673,7 @@
           <p:cNvPr id="28" name="">
             <a:extLst xmlns:a="http://schemas.openxmlformats.org/drawingml/2006/main">
               <a:ext uri="{FF2B5EF4-FFF2-40B4-BE49-F238E27FC236}">
-                <a16:creationId xmlns:a16="http://schemas.microsoft.com/office/drawing/2014/main" id="{952C90EE-0D0E-48EE-8C88-A2CEE3471DED}"/>
+                <a16:creationId xmlns:a16="http://schemas.microsoft.com/office/drawing/2014/main" id="{B0384336-915E-448D-B892-C75508F1A8D4}"/>
               </a:ext>
             </a:extLst>
           </p:cNvPr>
@@ -11708,7 +11708,7 @@
           <p:cNvPr id="29" name="">
             <a:extLst xmlns:a="http://schemas.openxmlformats.org/drawingml/2006/main">
               <a:ext uri="{FF2B5EF4-FFF2-40B4-BE49-F238E27FC236}">
-                <a16:creationId xmlns:a16="http://schemas.microsoft.com/office/drawing/2014/main" id="{3737F9B6-D63B-43F2-B270-0CC0561FD7A8}"/>
+                <a16:creationId xmlns:a16="http://schemas.microsoft.com/office/drawing/2014/main" id="{F24E4AAD-3D4C-411C-946B-F78798146B2A}"/>
               </a:ext>
             </a:extLst>
           </p:cNvPr>
@@ -11768,7 +11768,7 @@
           <p:cNvPr id="30" name="">
             <a:extLst xmlns:a="http://schemas.openxmlformats.org/drawingml/2006/main">
               <a:ext uri="{FF2B5EF4-FFF2-40B4-BE49-F238E27FC236}">
-                <a16:creationId xmlns:a16="http://schemas.microsoft.com/office/drawing/2014/main" id="{361F46FD-4A1F-4B94-B62A-9CC74039DF51}"/>
+                <a16:creationId xmlns:a16="http://schemas.microsoft.com/office/drawing/2014/main" id="{26DA16F7-D607-4688-A3BC-899B725C9290}"/>
               </a:ext>
             </a:extLst>
           </p:cNvPr>
@@ -11826,7 +11826,7 @@
     </p:spTree>
     <p:extLst>
       <p:ext uri="{BB962C8B-B14F-4D97-AF65-F5344CB8AC3E}">
-        <p14:creationId xmlns:p14="http://schemas.microsoft.com/office/powerpoint/2010/main" val="2011580111"/>
+        <p14:creationId xmlns:p14="http://schemas.microsoft.com/office/powerpoint/2010/main" val="401256559"/>
       </p:ext>
     </p:extLst>
   </p:cSld>
@@ -11857,7 +11857,7 @@
           <p:cNvPr id="1" name="Slide Number Placeholder 5">
             <a:extLst xmlns:a="http://schemas.openxmlformats.org/drawingml/2006/main">
               <a:ext uri="{FF2B5EF4-FFF2-40B4-BE49-F238E27FC236}">
-                <a16:creationId xmlns:a16="http://schemas.microsoft.com/office/drawing/2014/main" id="{A2D8A6D6-5A49-46F7-8AC4-D6254B37C82A}"/>
+                <a16:creationId xmlns:a16="http://schemas.microsoft.com/office/drawing/2014/main" id="{9EDFBF68-94E1-445A-9556-759B9580ED01}"/>
               </a:ext>
             </a:extLst>
           </p:cNvPr>
@@ -11889,7 +11889,7 @@
           <p:cNvPr id="2" name="">
             <a:extLst xmlns:a="http://schemas.openxmlformats.org/drawingml/2006/main">
               <a:ext uri="{FF2B5EF4-FFF2-40B4-BE49-F238E27FC236}">
-                <a16:creationId xmlns:a16="http://schemas.microsoft.com/office/drawing/2014/main" id="{586B6168-2FAB-4981-97E4-46221F972749}"/>
+                <a16:creationId xmlns:a16="http://schemas.microsoft.com/office/drawing/2014/main" id="{9D20F0E3-AAC5-4D3F-A308-96CE9CD38031}"/>
               </a:ext>
             </a:extLst>
           </p:cNvPr>
@@ -11924,7 +11924,7 @@
           <p:cNvPr id="3" name="">
             <a:extLst xmlns:a="http://schemas.openxmlformats.org/drawingml/2006/main">
               <a:ext uri="{FF2B5EF4-FFF2-40B4-BE49-F238E27FC236}">
-                <a16:creationId xmlns:a16="http://schemas.microsoft.com/office/drawing/2014/main" id="{D6D48C8C-C1F8-4F80-922A-70CBFF53FE27}"/>
+                <a16:creationId xmlns:a16="http://schemas.microsoft.com/office/drawing/2014/main" id="{3D20C7A5-0F3B-4D99-8AE7-5D944DC61F21}"/>
               </a:ext>
             </a:extLst>
           </p:cNvPr>
@@ -11959,7 +11959,7 @@
           <p:cNvPr id="4" name="">
             <a:extLst xmlns:a="http://schemas.openxmlformats.org/drawingml/2006/main">
               <a:ext uri="{FF2B5EF4-FFF2-40B4-BE49-F238E27FC236}">
-                <a16:creationId xmlns:a16="http://schemas.microsoft.com/office/drawing/2014/main" id="{E15A7D35-576F-465D-B9E0-EF35D18CC1F7}"/>
+                <a16:creationId xmlns:a16="http://schemas.microsoft.com/office/drawing/2014/main" id="{13222684-F80A-47A9-8900-8C46431144A6}"/>
               </a:ext>
             </a:extLst>
           </p:cNvPr>
@@ -11994,7 +11994,7 @@
           <p:cNvPr id="5" name="">
             <a:extLst xmlns:a="http://schemas.openxmlformats.org/drawingml/2006/main">
               <a:ext uri="{FF2B5EF4-FFF2-40B4-BE49-F238E27FC236}">
-                <a16:creationId xmlns:a16="http://schemas.microsoft.com/office/drawing/2014/main" id="{129A3130-254C-4F5A-9C2F-769D8C127A78}"/>
+                <a16:creationId xmlns:a16="http://schemas.microsoft.com/office/drawing/2014/main" id="{89B76AE3-CEE6-4B33-BA06-9941ADB6C20B}"/>
               </a:ext>
             </a:extLst>
           </p:cNvPr>
@@ -12029,7 +12029,7 @@
           <p:cNvPr id="6" name="">
             <a:extLst xmlns:a="http://schemas.openxmlformats.org/drawingml/2006/main">
               <a:ext uri="{FF2B5EF4-FFF2-40B4-BE49-F238E27FC236}">
-                <a16:creationId xmlns:a16="http://schemas.microsoft.com/office/drawing/2014/main" id="{75A10AC9-DE37-4229-8513-6F68601215A4}"/>
+                <a16:creationId xmlns:a16="http://schemas.microsoft.com/office/drawing/2014/main" id="{0E8780E4-791F-4530-8876-271896ECFABA}"/>
               </a:ext>
             </a:extLst>
           </p:cNvPr>
@@ -12064,7 +12064,7 @@
           <p:cNvPr id="7" name="">
             <a:extLst xmlns:a="http://schemas.openxmlformats.org/drawingml/2006/main">
               <a:ext uri="{FF2B5EF4-FFF2-40B4-BE49-F238E27FC236}">
-                <a16:creationId xmlns:a16="http://schemas.microsoft.com/office/drawing/2014/main" id="{0BE048E4-F84F-4299-BA96-E91E082EDA56}"/>
+                <a16:creationId xmlns:a16="http://schemas.microsoft.com/office/drawing/2014/main" id="{6D92FD6C-4345-49FA-A21D-25951C7029F6}"/>
               </a:ext>
             </a:extLst>
           </p:cNvPr>
@@ -12122,7 +12122,7 @@
           <p:cNvPr id="8" name="">
             <a:extLst xmlns:a="http://schemas.openxmlformats.org/drawingml/2006/main">
               <a:ext uri="{FF2B5EF4-FFF2-40B4-BE49-F238E27FC236}">
-                <a16:creationId xmlns:a16="http://schemas.microsoft.com/office/drawing/2014/main" id="{DFCB5A8B-4684-4FCF-90B2-65993FEFD029}"/>
+                <a16:creationId xmlns:a16="http://schemas.microsoft.com/office/drawing/2014/main" id="{1AE70096-BBB7-4804-BBAE-E62BE584DA4C}"/>
               </a:ext>
             </a:extLst>
           </p:cNvPr>
@@ -12180,7 +12180,7 @@
           <p:cNvPr id="9" name="">
             <a:extLst xmlns:a="http://schemas.openxmlformats.org/drawingml/2006/main">
               <a:ext uri="{FF2B5EF4-FFF2-40B4-BE49-F238E27FC236}">
-                <a16:creationId xmlns:a16="http://schemas.microsoft.com/office/drawing/2014/main" id="{55A2151D-DC66-4F22-92AC-8B2D6EA3FD98}"/>
+                <a16:creationId xmlns:a16="http://schemas.microsoft.com/office/drawing/2014/main" id="{92C56539-BB25-4FBE-A32F-FF58A272CA3E}"/>
               </a:ext>
             </a:extLst>
           </p:cNvPr>
@@ -12238,7 +12238,7 @@
           <p:cNvPr id="10" name="">
             <a:extLst xmlns:a="http://schemas.openxmlformats.org/drawingml/2006/main">
               <a:ext uri="{FF2B5EF4-FFF2-40B4-BE49-F238E27FC236}">
-                <a16:creationId xmlns:a16="http://schemas.microsoft.com/office/drawing/2014/main" id="{86F6784F-88F4-4FA4-9EC4-00C5D1C6B12C}"/>
+                <a16:creationId xmlns:a16="http://schemas.microsoft.com/office/drawing/2014/main" id="{CD798884-513A-4F82-9831-B71621597926}"/>
               </a:ext>
             </a:extLst>
           </p:cNvPr>
@@ -12273,7 +12273,7 @@
           <p:cNvPr id="11" name="">
             <a:extLst xmlns:a="http://schemas.openxmlformats.org/drawingml/2006/main">
               <a:ext uri="{FF2B5EF4-FFF2-40B4-BE49-F238E27FC236}">
-                <a16:creationId xmlns:a16="http://schemas.microsoft.com/office/drawing/2014/main" id="{A446699A-AB7F-4936-AD6B-2376AF06A324}"/>
+                <a16:creationId xmlns:a16="http://schemas.microsoft.com/office/drawing/2014/main" id="{6115F0D9-FF66-4241-8B7D-1044A463E416}"/>
               </a:ext>
             </a:extLst>
           </p:cNvPr>
@@ -12333,7 +12333,7 @@
           <p:cNvPr id="12" name="">
             <a:extLst xmlns:a="http://schemas.openxmlformats.org/drawingml/2006/main">
               <a:ext uri="{FF2B5EF4-FFF2-40B4-BE49-F238E27FC236}">
-                <a16:creationId xmlns:a16="http://schemas.microsoft.com/office/drawing/2014/main" id="{F4271AEF-5EF8-4E76-8DC7-84EAA7FDB429}"/>
+                <a16:creationId xmlns:a16="http://schemas.microsoft.com/office/drawing/2014/main" id="{FFBD71DA-5432-41B2-997E-4123285AF88E}"/>
               </a:ext>
             </a:extLst>
           </p:cNvPr>
@@ -12393,7 +12393,7 @@
           <p:cNvPr id="13" name="">
             <a:extLst xmlns:a="http://schemas.openxmlformats.org/drawingml/2006/main">
               <a:ext uri="{FF2B5EF4-FFF2-40B4-BE49-F238E27FC236}">
-                <a16:creationId xmlns:a16="http://schemas.microsoft.com/office/drawing/2014/main" id="{705449CE-A851-4A0E-9D96-77DD51F13C26}"/>
+                <a16:creationId xmlns:a16="http://schemas.microsoft.com/office/drawing/2014/main" id="{802243D9-CF59-4DAA-A4EE-E69EF1F16785}"/>
               </a:ext>
             </a:extLst>
           </p:cNvPr>
@@ -12428,7 +12428,7 @@
           <p:cNvPr id="14" name="">
             <a:extLst xmlns:a="http://schemas.openxmlformats.org/drawingml/2006/main">
               <a:ext uri="{FF2B5EF4-FFF2-40B4-BE49-F238E27FC236}">
-                <a16:creationId xmlns:a16="http://schemas.microsoft.com/office/drawing/2014/main" id="{B5CFD1AC-6A30-429B-AEA7-18406CE0B6B4}"/>
+                <a16:creationId xmlns:a16="http://schemas.microsoft.com/office/drawing/2014/main" id="{8709032D-AB72-4958-809C-1E0D16936659}"/>
               </a:ext>
             </a:extLst>
           </p:cNvPr>
@@ -12463,7 +12463,7 @@
           <p:cNvPr id="15" name="">
             <a:extLst xmlns:a="http://schemas.openxmlformats.org/drawingml/2006/main">
               <a:ext uri="{FF2B5EF4-FFF2-40B4-BE49-F238E27FC236}">
-                <a16:creationId xmlns:a16="http://schemas.microsoft.com/office/drawing/2014/main" id="{B4BAFCE6-F273-4FF1-811C-27984DA0DF3E}"/>
+                <a16:creationId xmlns:a16="http://schemas.microsoft.com/office/drawing/2014/main" id="{A635491E-8CEB-49E5-8923-1D986F159320}"/>
               </a:ext>
             </a:extLst>
           </p:cNvPr>
@@ -12523,7 +12523,7 @@
           <p:cNvPr id="16" name="">
             <a:extLst xmlns:a="http://schemas.openxmlformats.org/drawingml/2006/main">
               <a:ext uri="{FF2B5EF4-FFF2-40B4-BE49-F238E27FC236}">
-                <a16:creationId xmlns:a16="http://schemas.microsoft.com/office/drawing/2014/main" id="{B63E6AE9-CC7F-4B55-BF6C-BD40FBE2EEFE}"/>
+                <a16:creationId xmlns:a16="http://schemas.microsoft.com/office/drawing/2014/main" id="{9206B268-6FB1-42EA-B770-8F6737AC4EF5}"/>
               </a:ext>
             </a:extLst>
           </p:cNvPr>
@@ -12583,7 +12583,7 @@
           <p:cNvPr id="17" name="">
             <a:extLst xmlns:a="http://schemas.openxmlformats.org/drawingml/2006/main">
               <a:ext uri="{FF2B5EF4-FFF2-40B4-BE49-F238E27FC236}">
-                <a16:creationId xmlns:a16="http://schemas.microsoft.com/office/drawing/2014/main" id="{43DB4128-D2BB-49FB-AD4A-3E5BD454270F}"/>
+                <a16:creationId xmlns:a16="http://schemas.microsoft.com/office/drawing/2014/main" id="{AB18F52A-09F3-4767-A7A3-B1F19416C87B}"/>
               </a:ext>
             </a:extLst>
           </p:cNvPr>
@@ -12618,7 +12618,7 @@
           <p:cNvPr id="18" name="">
             <a:extLst xmlns:a="http://schemas.openxmlformats.org/drawingml/2006/main">
               <a:ext uri="{FF2B5EF4-FFF2-40B4-BE49-F238E27FC236}">
-                <a16:creationId xmlns:a16="http://schemas.microsoft.com/office/drawing/2014/main" id="{17A96E7E-ECAC-4363-BD6C-CE17988C5085}"/>
+                <a16:creationId xmlns:a16="http://schemas.microsoft.com/office/drawing/2014/main" id="{9689515E-BC35-4F39-AFAA-5442EC2CB75F}"/>
               </a:ext>
             </a:extLst>
           </p:cNvPr>
@@ -12653,7 +12653,7 @@
           <p:cNvPr id="19" name="">
             <a:extLst xmlns:a="http://schemas.openxmlformats.org/drawingml/2006/main">
               <a:ext uri="{FF2B5EF4-FFF2-40B4-BE49-F238E27FC236}">
-                <a16:creationId xmlns:a16="http://schemas.microsoft.com/office/drawing/2014/main" id="{E3386820-64BC-4DAB-A38A-2EE763DDFCCB}"/>
+                <a16:creationId xmlns:a16="http://schemas.microsoft.com/office/drawing/2014/main" id="{AF08E7D8-3C57-4ADF-BE83-20D855D4620F}"/>
               </a:ext>
             </a:extLst>
           </p:cNvPr>
@@ -12713,7 +12713,7 @@
           <p:cNvPr id="20" name="">
             <a:extLst xmlns:a="http://schemas.openxmlformats.org/drawingml/2006/main">
               <a:ext uri="{FF2B5EF4-FFF2-40B4-BE49-F238E27FC236}">
-                <a16:creationId xmlns:a16="http://schemas.microsoft.com/office/drawing/2014/main" id="{06803096-F157-48AD-AA1A-AE0A66426DCA}"/>
+                <a16:creationId xmlns:a16="http://schemas.microsoft.com/office/drawing/2014/main" id="{B993C502-8BB9-45A4-B43B-37574005D511}"/>
               </a:ext>
             </a:extLst>
           </p:cNvPr>
@@ -12773,7 +12773,7 @@
           <p:cNvPr id="21" name="">
             <a:extLst xmlns:a="http://schemas.openxmlformats.org/drawingml/2006/main">
               <a:ext uri="{FF2B5EF4-FFF2-40B4-BE49-F238E27FC236}">
-                <a16:creationId xmlns:a16="http://schemas.microsoft.com/office/drawing/2014/main" id="{9FB38E4F-D4F2-4402-B211-A463201A59D7}"/>
+                <a16:creationId xmlns:a16="http://schemas.microsoft.com/office/drawing/2014/main" id="{AB533834-75EB-4F20-A674-5E3F34FA3871}"/>
               </a:ext>
             </a:extLst>
           </p:cNvPr>
@@ -12808,7 +12808,7 @@
           <p:cNvPr id="22" name="">
             <a:extLst xmlns:a="http://schemas.openxmlformats.org/drawingml/2006/main">
               <a:ext uri="{FF2B5EF4-FFF2-40B4-BE49-F238E27FC236}">
-                <a16:creationId xmlns:a16="http://schemas.microsoft.com/office/drawing/2014/main" id="{1ECCCE0F-FBFA-4F87-9747-E2256E75E24B}"/>
+                <a16:creationId xmlns:a16="http://schemas.microsoft.com/office/drawing/2014/main" id="{CCC4968A-E550-43F3-8DB8-1AA80412DB4B}"/>
               </a:ext>
             </a:extLst>
           </p:cNvPr>
@@ -12843,7 +12843,7 @@
           <p:cNvPr id="23" name="">
             <a:extLst xmlns:a="http://schemas.openxmlformats.org/drawingml/2006/main">
               <a:ext uri="{FF2B5EF4-FFF2-40B4-BE49-F238E27FC236}">
-                <a16:creationId xmlns:a16="http://schemas.microsoft.com/office/drawing/2014/main" id="{2CF560F9-43AB-485A-A701-A3B59650083F}"/>
+                <a16:creationId xmlns:a16="http://schemas.microsoft.com/office/drawing/2014/main" id="{B32859E9-3FAA-4EFB-9A5A-B5C9B3251705}"/>
               </a:ext>
             </a:extLst>
           </p:cNvPr>
@@ -12903,7 +12903,7 @@
           <p:cNvPr id="24" name="">
             <a:extLst xmlns:a="http://schemas.openxmlformats.org/drawingml/2006/main">
               <a:ext uri="{FF2B5EF4-FFF2-40B4-BE49-F238E27FC236}">
-                <a16:creationId xmlns:a16="http://schemas.microsoft.com/office/drawing/2014/main" id="{66ACF229-102D-4D17-BD36-7E1648BC76F1}"/>
+                <a16:creationId xmlns:a16="http://schemas.microsoft.com/office/drawing/2014/main" id="{18E701D9-1F17-4F2C-9EFB-90831E34AD8D}"/>
               </a:ext>
             </a:extLst>
           </p:cNvPr>
@@ -12963,7 +12963,7 @@
           <p:cNvPr id="25" name="">
             <a:extLst xmlns:a="http://schemas.openxmlformats.org/drawingml/2006/main">
               <a:ext uri="{FF2B5EF4-FFF2-40B4-BE49-F238E27FC236}">
-                <a16:creationId xmlns:a16="http://schemas.microsoft.com/office/drawing/2014/main" id="{538895EA-CEB1-4253-868B-C17D99158C89}"/>
+                <a16:creationId xmlns:a16="http://schemas.microsoft.com/office/drawing/2014/main" id="{64EDE155-0B5D-4F4C-94DE-CF846C1EE5CA}"/>
               </a:ext>
             </a:extLst>
           </p:cNvPr>
@@ -12998,7 +12998,7 @@
           <p:cNvPr id="26" name="">
             <a:extLst xmlns:a="http://schemas.openxmlformats.org/drawingml/2006/main">
               <a:ext uri="{FF2B5EF4-FFF2-40B4-BE49-F238E27FC236}">
-                <a16:creationId xmlns:a16="http://schemas.microsoft.com/office/drawing/2014/main" id="{B57AEC34-1DBB-419E-BF57-AB35EDFE2B27}"/>
+                <a16:creationId xmlns:a16="http://schemas.microsoft.com/office/drawing/2014/main" id="{DBA4051C-1A42-45C9-86EC-98CC3242BBAC}"/>
               </a:ext>
             </a:extLst>
           </p:cNvPr>
@@ -13033,7 +13033,7 @@
           <p:cNvPr id="27" name="">
             <a:extLst xmlns:a="http://schemas.openxmlformats.org/drawingml/2006/main">
               <a:ext uri="{FF2B5EF4-FFF2-40B4-BE49-F238E27FC236}">
-                <a16:creationId xmlns:a16="http://schemas.microsoft.com/office/drawing/2014/main" id="{E37DB732-D84D-4B59-8CE3-75846D4FF161}"/>
+                <a16:creationId xmlns:a16="http://schemas.microsoft.com/office/drawing/2014/main" id="{2306AFBE-61E2-4A5C-AB82-45A198170AC2}"/>
               </a:ext>
             </a:extLst>
           </p:cNvPr>
@@ -13093,7 +13093,7 @@
           <p:cNvPr id="28" name="">
             <a:extLst xmlns:a="http://schemas.openxmlformats.org/drawingml/2006/main">
               <a:ext uri="{FF2B5EF4-FFF2-40B4-BE49-F238E27FC236}">
-                <a16:creationId xmlns:a16="http://schemas.microsoft.com/office/drawing/2014/main" id="{1C7A6378-9685-4E42-B18F-59BDFA6E30AB}"/>
+                <a16:creationId xmlns:a16="http://schemas.microsoft.com/office/drawing/2014/main" id="{8E8EC7B8-3B00-4B24-8565-D3459C22A9B0}"/>
               </a:ext>
             </a:extLst>
           </p:cNvPr>
@@ -13153,7 +13153,7 @@
           <p:cNvPr id="29" name="">
             <a:extLst xmlns:a="http://schemas.openxmlformats.org/drawingml/2006/main">
               <a:ext uri="{FF2B5EF4-FFF2-40B4-BE49-F238E27FC236}">
-                <a16:creationId xmlns:a16="http://schemas.microsoft.com/office/drawing/2014/main" id="{7258B9E3-4406-4F06-AF62-2486D1B6EA1B}"/>
+                <a16:creationId xmlns:a16="http://schemas.microsoft.com/office/drawing/2014/main" id="{A85A9E72-175A-4EB1-8C6A-1B8C80959198}"/>
               </a:ext>
             </a:extLst>
           </p:cNvPr>
@@ -13188,7 +13188,7 @@
           <p:cNvPr id="30" name="">
             <a:extLst xmlns:a="http://schemas.openxmlformats.org/drawingml/2006/main">
               <a:ext uri="{FF2B5EF4-FFF2-40B4-BE49-F238E27FC236}">
-                <a16:creationId xmlns:a16="http://schemas.microsoft.com/office/drawing/2014/main" id="{1A73B757-7F52-484A-8DAF-E67C82FC0576}"/>
+                <a16:creationId xmlns:a16="http://schemas.microsoft.com/office/drawing/2014/main" id="{54C57BE8-1032-4AE9-A6C2-4FAD947ADFF1}"/>
               </a:ext>
             </a:extLst>
           </p:cNvPr>
@@ -13248,7 +13248,7 @@
           <p:cNvPr id="31" name="">
             <a:extLst xmlns:a="http://schemas.openxmlformats.org/drawingml/2006/main">
               <a:ext uri="{FF2B5EF4-FFF2-40B4-BE49-F238E27FC236}">
-                <a16:creationId xmlns:a16="http://schemas.microsoft.com/office/drawing/2014/main" id="{F1A494F2-D07C-49D6-82AC-350844A344D8}"/>
+                <a16:creationId xmlns:a16="http://schemas.microsoft.com/office/drawing/2014/main" id="{914C797D-0D59-4B88-BE7B-AD5841E8F0A3}"/>
               </a:ext>
             </a:extLst>
           </p:cNvPr>
@@ -13308,7 +13308,7 @@
           <p:cNvPr id="32" name="">
             <a:extLst xmlns:a="http://schemas.openxmlformats.org/drawingml/2006/main">
               <a:ext uri="{FF2B5EF4-FFF2-40B4-BE49-F238E27FC236}">
-                <a16:creationId xmlns:a16="http://schemas.microsoft.com/office/drawing/2014/main" id="{4B4A4B62-56E5-49CB-B2D5-54AF937F7044}"/>
+                <a16:creationId xmlns:a16="http://schemas.microsoft.com/office/drawing/2014/main" id="{AE3ABA17-FE8C-4579-A06D-79C68CC00B6F}"/>
               </a:ext>
             </a:extLst>
           </p:cNvPr>
@@ -13343,7 +13343,7 @@
           <p:cNvPr id="33" name="">
             <a:extLst xmlns:a="http://schemas.openxmlformats.org/drawingml/2006/main">
               <a:ext uri="{FF2B5EF4-FFF2-40B4-BE49-F238E27FC236}">
-                <a16:creationId xmlns:a16="http://schemas.microsoft.com/office/drawing/2014/main" id="{F558B3B8-07A0-42FA-B838-38FA4D5084AE}"/>
+                <a16:creationId xmlns:a16="http://schemas.microsoft.com/office/drawing/2014/main" id="{BF3BAD01-0C38-4DFB-BD51-BD8B6F660735}"/>
               </a:ext>
             </a:extLst>
           </p:cNvPr>
@@ -13403,7 +13403,7 @@
           <p:cNvPr id="34" name="">
             <a:extLst xmlns:a="http://schemas.openxmlformats.org/drawingml/2006/main">
               <a:ext uri="{FF2B5EF4-FFF2-40B4-BE49-F238E27FC236}">
-                <a16:creationId xmlns:a16="http://schemas.microsoft.com/office/drawing/2014/main" id="{3092A7D1-D313-4738-9347-C79FE848F0E9}"/>
+                <a16:creationId xmlns:a16="http://schemas.microsoft.com/office/drawing/2014/main" id="{9765B39E-0067-45A0-A337-FDA282C0A0FC}"/>
               </a:ext>
             </a:extLst>
           </p:cNvPr>
@@ -13461,7 +13461,7 @@
     </p:spTree>
     <p:extLst>
       <p:ext uri="{BB962C8B-B14F-4D97-AF65-F5344CB8AC3E}">
-        <p14:creationId xmlns:p14="http://schemas.microsoft.com/office/powerpoint/2010/main" val="1312996113"/>
+        <p14:creationId xmlns:p14="http://schemas.microsoft.com/office/powerpoint/2010/main" val="319210099"/>
       </p:ext>
     </p:extLst>
   </p:cSld>
@@ -13492,7 +13492,7 @@
           <p:cNvPr id="1" name="Slide Number Placeholder 5">
             <a:extLst xmlns:a="http://schemas.openxmlformats.org/drawingml/2006/main">
               <a:ext uri="{FF2B5EF4-FFF2-40B4-BE49-F238E27FC236}">
-                <a16:creationId xmlns:a16="http://schemas.microsoft.com/office/drawing/2014/main" id="{A2D8A6D6-5A49-46F7-8AC4-D6254B37C82A}"/>
+                <a16:creationId xmlns:a16="http://schemas.microsoft.com/office/drawing/2014/main" id="{9EDFBF68-94E1-445A-9556-759B9580ED01}"/>
               </a:ext>
             </a:extLst>
           </p:cNvPr>
@@ -13524,7 +13524,7 @@
           <p:cNvPr id="2" name="">
             <a:extLst xmlns:a="http://schemas.openxmlformats.org/drawingml/2006/main">
               <a:ext uri="{FF2B5EF4-FFF2-40B4-BE49-F238E27FC236}">
-                <a16:creationId xmlns:a16="http://schemas.microsoft.com/office/drawing/2014/main" id="{6B084F58-9B8F-41AF-99EF-32FCC9A2E8E2}"/>
+                <a16:creationId xmlns:a16="http://schemas.microsoft.com/office/drawing/2014/main" id="{DE729335-63FD-461C-B2C1-1230BA9F6160}"/>
               </a:ext>
             </a:extLst>
           </p:cNvPr>
@@ -13559,7 +13559,7 @@
           <p:cNvPr id="3" name="">
             <a:extLst xmlns:a="http://schemas.openxmlformats.org/drawingml/2006/main">
               <a:ext uri="{FF2B5EF4-FFF2-40B4-BE49-F238E27FC236}">
-                <a16:creationId xmlns:a16="http://schemas.microsoft.com/office/drawing/2014/main" id="{C98EF2C3-A800-45D5-B853-EF6B17DC599F}"/>
+                <a16:creationId xmlns:a16="http://schemas.microsoft.com/office/drawing/2014/main" id="{4E738D4B-2E69-4EF3-92C2-4B0DC7D03148}"/>
               </a:ext>
             </a:extLst>
           </p:cNvPr>
@@ -13594,7 +13594,7 @@
           <p:cNvPr id="4" name="">
             <a:extLst xmlns:a="http://schemas.openxmlformats.org/drawingml/2006/main">
               <a:ext uri="{FF2B5EF4-FFF2-40B4-BE49-F238E27FC236}">
-                <a16:creationId xmlns:a16="http://schemas.microsoft.com/office/drawing/2014/main" id="{960FB198-AF21-4619-A107-E25C39C4825B}"/>
+                <a16:creationId xmlns:a16="http://schemas.microsoft.com/office/drawing/2014/main" id="{BC523810-70D1-47E0-8929-B067E511CF22}"/>
               </a:ext>
             </a:extLst>
           </p:cNvPr>
@@ -13629,7 +13629,7 @@
           <p:cNvPr id="5" name="">
             <a:extLst xmlns:a="http://schemas.openxmlformats.org/drawingml/2006/main">
               <a:ext uri="{FF2B5EF4-FFF2-40B4-BE49-F238E27FC236}">
-                <a16:creationId xmlns:a16="http://schemas.microsoft.com/office/drawing/2014/main" id="{F5276667-90D3-416D-9A10-2C935A57F206}"/>
+                <a16:creationId xmlns:a16="http://schemas.microsoft.com/office/drawing/2014/main" id="{87BBC1F1-EBD6-4B9E-B18D-14046AAC09B8}"/>
               </a:ext>
             </a:extLst>
           </p:cNvPr>
@@ -13664,7 +13664,7 @@
           <p:cNvPr id="6" name="">
             <a:extLst xmlns:a="http://schemas.openxmlformats.org/drawingml/2006/main">
               <a:ext uri="{FF2B5EF4-FFF2-40B4-BE49-F238E27FC236}">
-                <a16:creationId xmlns:a16="http://schemas.microsoft.com/office/drawing/2014/main" id="{3007FB4C-1B65-4D64-8AE1-1677874606E0}"/>
+                <a16:creationId xmlns:a16="http://schemas.microsoft.com/office/drawing/2014/main" id="{C2B04871-6404-4733-8E33-43A0D2D1E13E}"/>
               </a:ext>
             </a:extLst>
           </p:cNvPr>
@@ -13699,7 +13699,7 @@
           <p:cNvPr id="7" name="">
             <a:extLst xmlns:a="http://schemas.openxmlformats.org/drawingml/2006/main">
               <a:ext uri="{FF2B5EF4-FFF2-40B4-BE49-F238E27FC236}">
-                <a16:creationId xmlns:a16="http://schemas.microsoft.com/office/drawing/2014/main" id="{A6FAAE31-1075-4392-BFC0-B18969073F5D}"/>
+                <a16:creationId xmlns:a16="http://schemas.microsoft.com/office/drawing/2014/main" id="{375DA870-B142-46B8-A078-7594ECD1BF29}"/>
               </a:ext>
             </a:extLst>
           </p:cNvPr>
@@ -13757,7 +13757,7 @@
           <p:cNvPr id="8" name="">
             <a:extLst xmlns:a="http://schemas.openxmlformats.org/drawingml/2006/main">
               <a:ext uri="{FF2B5EF4-FFF2-40B4-BE49-F238E27FC236}">
-                <a16:creationId xmlns:a16="http://schemas.microsoft.com/office/drawing/2014/main" id="{4E82ED9E-DFB8-4A6B-BC5A-107D4322962D}"/>
+                <a16:creationId xmlns:a16="http://schemas.microsoft.com/office/drawing/2014/main" id="{6DBD2096-3E63-4459-AC2C-12B6255C4246}"/>
               </a:ext>
             </a:extLst>
           </p:cNvPr>
@@ -13815,7 +13815,7 @@
           <p:cNvPr id="9" name="">
             <a:extLst xmlns:a="http://schemas.openxmlformats.org/drawingml/2006/main">
               <a:ext uri="{FF2B5EF4-FFF2-40B4-BE49-F238E27FC236}">
-                <a16:creationId xmlns:a16="http://schemas.microsoft.com/office/drawing/2014/main" id="{B772A6FE-3D02-4EB9-BEA5-C91E08A7BAD1}"/>
+                <a16:creationId xmlns:a16="http://schemas.microsoft.com/office/drawing/2014/main" id="{61058DBF-0EB9-4D49-8D4E-C529C0A084AF}"/>
               </a:ext>
             </a:extLst>
           </p:cNvPr>
@@ -13873,7 +13873,7 @@
           <p:cNvPr id="10" name="">
             <a:extLst xmlns:a="http://schemas.openxmlformats.org/drawingml/2006/main">
               <a:ext uri="{FF2B5EF4-FFF2-40B4-BE49-F238E27FC236}">
-                <a16:creationId xmlns:a16="http://schemas.microsoft.com/office/drawing/2014/main" id="{3F6FBDB7-A523-42B6-BA03-14FFEA98D3DF}"/>
+                <a16:creationId xmlns:a16="http://schemas.microsoft.com/office/drawing/2014/main" id="{7A66DFDB-CB62-4CF5-8090-D0B9341F2F54}"/>
               </a:ext>
             </a:extLst>
           </p:cNvPr>
@@ -13908,7 +13908,7 @@
           <p:cNvPr id="11" name="">
             <a:extLst xmlns:a="http://schemas.openxmlformats.org/drawingml/2006/main">
               <a:ext uri="{FF2B5EF4-FFF2-40B4-BE49-F238E27FC236}">
-                <a16:creationId xmlns:a16="http://schemas.microsoft.com/office/drawing/2014/main" id="{3826D203-3C7B-4BD3-9CB6-A2476B16EC4C}"/>
+                <a16:creationId xmlns:a16="http://schemas.microsoft.com/office/drawing/2014/main" id="{E8AAE10D-47B8-41D1-B11C-FA8B71B90225}"/>
               </a:ext>
             </a:extLst>
           </p:cNvPr>
@@ -13968,7 +13968,7 @@
           <p:cNvPr id="12" name="">
             <a:extLst xmlns:a="http://schemas.openxmlformats.org/drawingml/2006/main">
               <a:ext uri="{FF2B5EF4-FFF2-40B4-BE49-F238E27FC236}">
-                <a16:creationId xmlns:a16="http://schemas.microsoft.com/office/drawing/2014/main" id="{50C27611-D6D3-45D0-9989-55EF518AFB85}"/>
+                <a16:creationId xmlns:a16="http://schemas.microsoft.com/office/drawing/2014/main" id="{E3EEAEEE-3799-4F62-9309-72C9FD270D5C}"/>
               </a:ext>
             </a:extLst>
           </p:cNvPr>
@@ -14028,7 +14028,7 @@
           <p:cNvPr id="13" name="">
             <a:extLst xmlns:a="http://schemas.openxmlformats.org/drawingml/2006/main">
               <a:ext uri="{FF2B5EF4-FFF2-40B4-BE49-F238E27FC236}">
-                <a16:creationId xmlns:a16="http://schemas.microsoft.com/office/drawing/2014/main" id="{44ACA7B0-7059-4874-A41C-2A586A238014}"/>
+                <a16:creationId xmlns:a16="http://schemas.microsoft.com/office/drawing/2014/main" id="{14576331-A81E-41B3-98A6-20172D4045BB}"/>
               </a:ext>
             </a:extLst>
           </p:cNvPr>
@@ -14063,7 +14063,7 @@
           <p:cNvPr id="14" name="">
             <a:extLst xmlns:a="http://schemas.openxmlformats.org/drawingml/2006/main">
               <a:ext uri="{FF2B5EF4-FFF2-40B4-BE49-F238E27FC236}">
-                <a16:creationId xmlns:a16="http://schemas.microsoft.com/office/drawing/2014/main" id="{10269E41-1B20-421E-B057-3D2FE327F7F0}"/>
+                <a16:creationId xmlns:a16="http://schemas.microsoft.com/office/drawing/2014/main" id="{589302FF-2B3F-4459-B99D-3FB92F5151E1}"/>
               </a:ext>
             </a:extLst>
           </p:cNvPr>
@@ -14096,7 +14096,7 @@
           <p:cNvPr id="15" name="">
             <a:extLst xmlns:a="http://schemas.openxmlformats.org/drawingml/2006/main">
               <a:ext uri="{FF2B5EF4-FFF2-40B4-BE49-F238E27FC236}">
-                <a16:creationId xmlns:a16="http://schemas.microsoft.com/office/drawing/2014/main" id="{5F1C0407-2AA6-42BB-9FC8-543B0CC6BDF7}"/>
+                <a16:creationId xmlns:a16="http://schemas.microsoft.com/office/drawing/2014/main" id="{F2B43420-3777-41CD-B9B0-6BBCCC3A1398}"/>
               </a:ext>
             </a:extLst>
           </p:cNvPr>
@@ -14154,7 +14154,7 @@
           <p:cNvPr id="16" name="">
             <a:extLst xmlns:a="http://schemas.openxmlformats.org/drawingml/2006/main">
               <a:ext uri="{FF2B5EF4-FFF2-40B4-BE49-F238E27FC236}">
-                <a16:creationId xmlns:a16="http://schemas.microsoft.com/office/drawing/2014/main" id="{9DE62E32-F3E4-49AC-85C1-4E76D0245E82}"/>
+                <a16:creationId xmlns:a16="http://schemas.microsoft.com/office/drawing/2014/main" id="{B680FB80-3BF2-4CAC-8787-D9CDCBD8D99C}"/>
               </a:ext>
             </a:extLst>
           </p:cNvPr>
@@ -14214,7 +14214,7 @@
           <p:cNvPr id="17" name="">
             <a:extLst xmlns:a="http://schemas.openxmlformats.org/drawingml/2006/main">
               <a:ext uri="{FF2B5EF4-FFF2-40B4-BE49-F238E27FC236}">
-                <a16:creationId xmlns:a16="http://schemas.microsoft.com/office/drawing/2014/main" id="{408F20E1-2C23-4B9E-8FCF-6379FCC97898}"/>
+                <a16:creationId xmlns:a16="http://schemas.microsoft.com/office/drawing/2014/main" id="{2E7E6458-6B97-460A-B80A-C1D6D00CF0B0}"/>
               </a:ext>
             </a:extLst>
           </p:cNvPr>
@@ -14249,7 +14249,7 @@
           <p:cNvPr id="18" name="">
             <a:extLst xmlns:a="http://schemas.openxmlformats.org/drawingml/2006/main">
               <a:ext uri="{FF2B5EF4-FFF2-40B4-BE49-F238E27FC236}">
-                <a16:creationId xmlns:a16="http://schemas.microsoft.com/office/drawing/2014/main" id="{C720E267-90DE-44A2-9149-8744E84DA676}"/>
+                <a16:creationId xmlns:a16="http://schemas.microsoft.com/office/drawing/2014/main" id="{C9C6E8A8-E0CF-4B82-A35E-C83472C1CCCB}"/>
               </a:ext>
             </a:extLst>
           </p:cNvPr>
@@ -14284,7 +14284,7 @@
           <p:cNvPr id="19" name="">
             <a:extLst xmlns:a="http://schemas.openxmlformats.org/drawingml/2006/main">
               <a:ext uri="{FF2B5EF4-FFF2-40B4-BE49-F238E27FC236}">
-                <a16:creationId xmlns:a16="http://schemas.microsoft.com/office/drawing/2014/main" id="{407F7310-7CD1-4768-BA88-416DCFF365CF}"/>
+                <a16:creationId xmlns:a16="http://schemas.microsoft.com/office/drawing/2014/main" id="{77DE3840-E013-4B5A-8D1D-902D05800030}"/>
               </a:ext>
             </a:extLst>
           </p:cNvPr>
@@ -14317,7 +14317,7 @@
           <p:cNvPr id="20" name="">
             <a:extLst xmlns:a="http://schemas.openxmlformats.org/drawingml/2006/main">
               <a:ext uri="{FF2B5EF4-FFF2-40B4-BE49-F238E27FC236}">
-                <a16:creationId xmlns:a16="http://schemas.microsoft.com/office/drawing/2014/main" id="{B4E00D49-E5A7-43A6-BFD3-D0ED85A1EF10}"/>
+                <a16:creationId xmlns:a16="http://schemas.microsoft.com/office/drawing/2014/main" id="{BC129D3C-EA91-4F9D-8F1B-8FAD79AE1C49}"/>
               </a:ext>
             </a:extLst>
           </p:cNvPr>
@@ -14375,7 +14375,7 @@
           <p:cNvPr id="21" name="">
             <a:extLst xmlns:a="http://schemas.openxmlformats.org/drawingml/2006/main">
               <a:ext uri="{FF2B5EF4-FFF2-40B4-BE49-F238E27FC236}">
-                <a16:creationId xmlns:a16="http://schemas.microsoft.com/office/drawing/2014/main" id="{F2199921-E054-4D2A-85B4-7A85BE419E21}"/>
+                <a16:creationId xmlns:a16="http://schemas.microsoft.com/office/drawing/2014/main" id="{7BDA8310-AB9C-49AD-B152-353948F2A181}"/>
               </a:ext>
             </a:extLst>
           </p:cNvPr>
@@ -14435,7 +14435,7 @@
           <p:cNvPr id="22" name="">
             <a:extLst xmlns:a="http://schemas.openxmlformats.org/drawingml/2006/main">
               <a:ext uri="{FF2B5EF4-FFF2-40B4-BE49-F238E27FC236}">
-                <a16:creationId xmlns:a16="http://schemas.microsoft.com/office/drawing/2014/main" id="{A2F68155-F08F-4B74-B39F-4233ACED98E6}"/>
+                <a16:creationId xmlns:a16="http://schemas.microsoft.com/office/drawing/2014/main" id="{C2C98F4B-4099-48EF-B9BB-ACB4012D8E04}"/>
               </a:ext>
             </a:extLst>
           </p:cNvPr>
@@ -14470,7 +14470,7 @@
           <p:cNvPr id="23" name="">
             <a:extLst xmlns:a="http://schemas.openxmlformats.org/drawingml/2006/main">
               <a:ext uri="{FF2B5EF4-FFF2-40B4-BE49-F238E27FC236}">
-                <a16:creationId xmlns:a16="http://schemas.microsoft.com/office/drawing/2014/main" id="{CA708E41-F729-4A2C-BDC7-D7B4E402C661}"/>
+                <a16:creationId xmlns:a16="http://schemas.microsoft.com/office/drawing/2014/main" id="{F51C6089-7EC2-44B6-B191-62A439B2459F}"/>
               </a:ext>
             </a:extLst>
           </p:cNvPr>
@@ -14505,7 +14505,7 @@
           <p:cNvPr id="24" name="">
             <a:extLst xmlns:a="http://schemas.openxmlformats.org/drawingml/2006/main">
               <a:ext uri="{FF2B5EF4-FFF2-40B4-BE49-F238E27FC236}">
-                <a16:creationId xmlns:a16="http://schemas.microsoft.com/office/drawing/2014/main" id="{E25D9C8F-8836-4A54-88F9-26674C287554}"/>
+                <a16:creationId xmlns:a16="http://schemas.microsoft.com/office/drawing/2014/main" id="{4274F79E-7A05-4C70-9EF0-C986C9D6257A}"/>
               </a:ext>
             </a:extLst>
           </p:cNvPr>
@@ -14538,7 +14538,7 @@
           <p:cNvPr id="25" name="">
             <a:extLst xmlns:a="http://schemas.openxmlformats.org/drawingml/2006/main">
               <a:ext uri="{FF2B5EF4-FFF2-40B4-BE49-F238E27FC236}">
-                <a16:creationId xmlns:a16="http://schemas.microsoft.com/office/drawing/2014/main" id="{1307CA79-2DD4-4733-B794-724FD75B5BA3}"/>
+                <a16:creationId xmlns:a16="http://schemas.microsoft.com/office/drawing/2014/main" id="{AAB79BD2-6BDC-4D79-9E70-E9932906F4C6}"/>
               </a:ext>
             </a:extLst>
           </p:cNvPr>
@@ -14596,7 +14596,7 @@
           <p:cNvPr id="26" name="">
             <a:extLst xmlns:a="http://schemas.openxmlformats.org/drawingml/2006/main">
               <a:ext uri="{FF2B5EF4-FFF2-40B4-BE49-F238E27FC236}">
-                <a16:creationId xmlns:a16="http://schemas.microsoft.com/office/drawing/2014/main" id="{FA6CA154-2E16-493A-9DAA-34A9A24BBDB2}"/>
+                <a16:creationId xmlns:a16="http://schemas.microsoft.com/office/drawing/2014/main" id="{6218880C-3AA1-4C19-B9CC-DFA50956CB80}"/>
               </a:ext>
             </a:extLst>
           </p:cNvPr>
@@ -14656,7 +14656,7 @@
           <p:cNvPr id="27" name="">
             <a:extLst xmlns:a="http://schemas.openxmlformats.org/drawingml/2006/main">
               <a:ext uri="{FF2B5EF4-FFF2-40B4-BE49-F238E27FC236}">
-                <a16:creationId xmlns:a16="http://schemas.microsoft.com/office/drawing/2014/main" id="{2DC02581-E28A-4BE0-B4BC-2F470486CAA9}"/>
+                <a16:creationId xmlns:a16="http://schemas.microsoft.com/office/drawing/2014/main" id="{58BDB5C8-FDFC-42EF-910A-062C6E3CEC2A}"/>
               </a:ext>
             </a:extLst>
           </p:cNvPr>
@@ -14691,7 +14691,7 @@
           <p:cNvPr id="28" name="">
             <a:extLst xmlns:a="http://schemas.openxmlformats.org/drawingml/2006/main">
               <a:ext uri="{FF2B5EF4-FFF2-40B4-BE49-F238E27FC236}">
-                <a16:creationId xmlns:a16="http://schemas.microsoft.com/office/drawing/2014/main" id="{2A677761-E163-4111-891C-112719A12060}"/>
+                <a16:creationId xmlns:a16="http://schemas.microsoft.com/office/drawing/2014/main" id="{35467816-BE5C-4E6C-9DF2-4A15467B93BB}"/>
               </a:ext>
             </a:extLst>
           </p:cNvPr>
@@ -14726,7 +14726,7 @@
           <p:cNvPr id="29" name="">
             <a:extLst xmlns:a="http://schemas.openxmlformats.org/drawingml/2006/main">
               <a:ext uri="{FF2B5EF4-FFF2-40B4-BE49-F238E27FC236}">
-                <a16:creationId xmlns:a16="http://schemas.microsoft.com/office/drawing/2014/main" id="{1F4170CD-E6CA-49A2-95A9-F85B70CA6A7D}"/>
+                <a16:creationId xmlns:a16="http://schemas.microsoft.com/office/drawing/2014/main" id="{FE0536C8-C048-4193-AED3-38A720D77320}"/>
               </a:ext>
             </a:extLst>
           </p:cNvPr>
@@ -14759,7 +14759,7 @@
           <p:cNvPr id="30" name="">
             <a:extLst xmlns:a="http://schemas.openxmlformats.org/drawingml/2006/main">
               <a:ext uri="{FF2B5EF4-FFF2-40B4-BE49-F238E27FC236}">
-                <a16:creationId xmlns:a16="http://schemas.microsoft.com/office/drawing/2014/main" id="{52986D98-39F2-4F45-9870-51AF39AE0062}"/>
+                <a16:creationId xmlns:a16="http://schemas.microsoft.com/office/drawing/2014/main" id="{44A8BB82-11F3-42E6-80B7-5A8A75C64DBE}"/>
               </a:ext>
             </a:extLst>
           </p:cNvPr>
@@ -14817,7 +14817,7 @@
           <p:cNvPr id="31" name="">
             <a:extLst xmlns:a="http://schemas.openxmlformats.org/drawingml/2006/main">
               <a:ext uri="{FF2B5EF4-FFF2-40B4-BE49-F238E27FC236}">
-                <a16:creationId xmlns:a16="http://schemas.microsoft.com/office/drawing/2014/main" id="{7E148DD1-EF5A-447E-90D1-D3AF0C3A1C78}"/>
+                <a16:creationId xmlns:a16="http://schemas.microsoft.com/office/drawing/2014/main" id="{AA744BFB-2E3B-4E56-A035-5D917AE89754}"/>
               </a:ext>
             </a:extLst>
           </p:cNvPr>
@@ -14877,7 +14877,7 @@
           <p:cNvPr id="32" name="">
             <a:extLst xmlns:a="http://schemas.openxmlformats.org/drawingml/2006/main">
               <a:ext uri="{FF2B5EF4-FFF2-40B4-BE49-F238E27FC236}">
-                <a16:creationId xmlns:a16="http://schemas.microsoft.com/office/drawing/2014/main" id="{889EB462-4866-4C89-8110-945739964ADF}"/>
+                <a16:creationId xmlns:a16="http://schemas.microsoft.com/office/drawing/2014/main" id="{E7835F08-E270-4A27-8E42-5129D5396DE1}"/>
               </a:ext>
             </a:extLst>
           </p:cNvPr>
@@ -14912,7 +14912,7 @@
           <p:cNvPr id="33" name="">
             <a:extLst xmlns:a="http://schemas.openxmlformats.org/drawingml/2006/main">
               <a:ext uri="{FF2B5EF4-FFF2-40B4-BE49-F238E27FC236}">
-                <a16:creationId xmlns:a16="http://schemas.microsoft.com/office/drawing/2014/main" id="{B035A690-504C-460B-A20A-325969ACA565}"/>
+                <a16:creationId xmlns:a16="http://schemas.microsoft.com/office/drawing/2014/main" id="{95461801-8CE2-45BB-BFB8-23DE41D6DCDB}"/>
               </a:ext>
             </a:extLst>
           </p:cNvPr>
@@ -14947,7 +14947,7 @@
           <p:cNvPr id="34" name="">
             <a:extLst xmlns:a="http://schemas.openxmlformats.org/drawingml/2006/main">
               <a:ext uri="{FF2B5EF4-FFF2-40B4-BE49-F238E27FC236}">
-                <a16:creationId xmlns:a16="http://schemas.microsoft.com/office/drawing/2014/main" id="{9698F859-AF02-4A98-9C26-6B6AAED8D1CB}"/>
+                <a16:creationId xmlns:a16="http://schemas.microsoft.com/office/drawing/2014/main" id="{AD54DF70-8C69-4DAF-B445-ABB7B68BF2E4}"/>
               </a:ext>
             </a:extLst>
           </p:cNvPr>
@@ -15007,7 +15007,7 @@
           <p:cNvPr id="35" name="">
             <a:extLst xmlns:a="http://schemas.openxmlformats.org/drawingml/2006/main">
               <a:ext uri="{FF2B5EF4-FFF2-40B4-BE49-F238E27FC236}">
-                <a16:creationId xmlns:a16="http://schemas.microsoft.com/office/drawing/2014/main" id="{FA508286-87CD-4886-85B5-F7684EF3EAC7}"/>
+                <a16:creationId xmlns:a16="http://schemas.microsoft.com/office/drawing/2014/main" id="{C7B69503-4F37-4594-83C7-1D8B388AABCC}"/>
               </a:ext>
             </a:extLst>
           </p:cNvPr>
@@ -15067,7 +15067,7 @@
           <p:cNvPr id="36" name="">
             <a:extLst xmlns:a="http://schemas.openxmlformats.org/drawingml/2006/main">
               <a:ext uri="{FF2B5EF4-FFF2-40B4-BE49-F238E27FC236}">
-                <a16:creationId xmlns:a16="http://schemas.microsoft.com/office/drawing/2014/main" id="{22CA5A0D-8D22-4408-9AA3-678E4E7166C1}"/>
+                <a16:creationId xmlns:a16="http://schemas.microsoft.com/office/drawing/2014/main" id="{CCBB5896-7451-46A7-8F23-C1D3AB625CFE}"/>
               </a:ext>
             </a:extLst>
           </p:cNvPr>
@@ -15102,7 +15102,7 @@
           <p:cNvPr id="37" name="">
             <a:extLst xmlns:a="http://schemas.openxmlformats.org/drawingml/2006/main">
               <a:ext uri="{FF2B5EF4-FFF2-40B4-BE49-F238E27FC236}">
-                <a16:creationId xmlns:a16="http://schemas.microsoft.com/office/drawing/2014/main" id="{5BDCEC24-8F98-4258-AD2D-0C875CDE98E2}"/>
+                <a16:creationId xmlns:a16="http://schemas.microsoft.com/office/drawing/2014/main" id="{F0FCDF23-A54B-4323-B9E7-5E966B096548}"/>
               </a:ext>
             </a:extLst>
           </p:cNvPr>
@@ -15137,7 +15137,7 @@
           <p:cNvPr id="38" name="">
             <a:extLst xmlns:a="http://schemas.openxmlformats.org/drawingml/2006/main">
               <a:ext uri="{FF2B5EF4-FFF2-40B4-BE49-F238E27FC236}">
-                <a16:creationId xmlns:a16="http://schemas.microsoft.com/office/drawing/2014/main" id="{407856AF-B617-4441-A4B6-D3501D361485}"/>
+                <a16:creationId xmlns:a16="http://schemas.microsoft.com/office/drawing/2014/main" id="{B8E24A72-947B-4D74-9A74-F4B2DA4655F4}"/>
               </a:ext>
             </a:extLst>
           </p:cNvPr>
@@ -15197,7 +15197,7 @@
           <p:cNvPr id="39" name="">
             <a:extLst xmlns:a="http://schemas.openxmlformats.org/drawingml/2006/main">
               <a:ext uri="{FF2B5EF4-FFF2-40B4-BE49-F238E27FC236}">
-                <a16:creationId xmlns:a16="http://schemas.microsoft.com/office/drawing/2014/main" id="{B5803D9B-C562-4CC8-B7AB-3F4B1BBD0FDE}"/>
+                <a16:creationId xmlns:a16="http://schemas.microsoft.com/office/drawing/2014/main" id="{9743527C-4916-4485-B452-AF93DA74D26E}"/>
               </a:ext>
             </a:extLst>
           </p:cNvPr>
@@ -15257,7 +15257,7 @@
           <p:cNvPr id="40" name="">
             <a:extLst xmlns:a="http://schemas.openxmlformats.org/drawingml/2006/main">
               <a:ext uri="{FF2B5EF4-FFF2-40B4-BE49-F238E27FC236}">
-                <a16:creationId xmlns:a16="http://schemas.microsoft.com/office/drawing/2014/main" id="{B80CD7CA-9F7C-477D-A6F7-0FEEDBB43521}"/>
+                <a16:creationId xmlns:a16="http://schemas.microsoft.com/office/drawing/2014/main" id="{A8FED023-B277-47C8-BF31-33FBA75677C2}"/>
               </a:ext>
             </a:extLst>
           </p:cNvPr>
@@ -15292,7 +15292,7 @@
           <p:cNvPr id="41" name="">
             <a:extLst xmlns:a="http://schemas.openxmlformats.org/drawingml/2006/main">
               <a:ext uri="{FF2B5EF4-FFF2-40B4-BE49-F238E27FC236}">
-                <a16:creationId xmlns:a16="http://schemas.microsoft.com/office/drawing/2014/main" id="{522F6C86-1133-46C6-8D96-6979B9776372}"/>
+                <a16:creationId xmlns:a16="http://schemas.microsoft.com/office/drawing/2014/main" id="{C7E75A4C-B7BA-4514-8FD5-742FE694ED14}"/>
               </a:ext>
             </a:extLst>
           </p:cNvPr>
@@ -15327,7 +15327,7 @@
           <p:cNvPr id="42" name="">
             <a:extLst xmlns:a="http://schemas.openxmlformats.org/drawingml/2006/main">
               <a:ext uri="{FF2B5EF4-FFF2-40B4-BE49-F238E27FC236}">
-                <a16:creationId xmlns:a16="http://schemas.microsoft.com/office/drawing/2014/main" id="{395B11DC-E0F7-4500-A1CF-EA227CDBC22A}"/>
+                <a16:creationId xmlns:a16="http://schemas.microsoft.com/office/drawing/2014/main" id="{A610CC0F-B158-443F-840F-A174973616AF}"/>
               </a:ext>
             </a:extLst>
           </p:cNvPr>
@@ -15387,7 +15387,7 @@
           <p:cNvPr id="43" name="">
             <a:extLst xmlns:a="http://schemas.openxmlformats.org/drawingml/2006/main">
               <a:ext uri="{FF2B5EF4-FFF2-40B4-BE49-F238E27FC236}">
-                <a16:creationId xmlns:a16="http://schemas.microsoft.com/office/drawing/2014/main" id="{CB7C77D4-39E5-4EAB-86DD-4391E1A2277F}"/>
+                <a16:creationId xmlns:a16="http://schemas.microsoft.com/office/drawing/2014/main" id="{116FA259-20B7-4089-ACAE-DF02B7D4C71C}"/>
               </a:ext>
             </a:extLst>
           </p:cNvPr>
@@ -15445,7 +15445,7 @@
     </p:spTree>
     <p:extLst>
       <p:ext uri="{BB962C8B-B14F-4D97-AF65-F5344CB8AC3E}">
-        <p14:creationId xmlns:p14="http://schemas.microsoft.com/office/powerpoint/2010/main" val="1803499428"/>
+        <p14:creationId xmlns:p14="http://schemas.microsoft.com/office/powerpoint/2010/main" val="1549095856"/>
       </p:ext>
     </p:extLst>
   </p:cSld>
@@ -15476,7 +15476,7 @@
           <p:cNvPr id="1" name="Slide Number Placeholder 5">
             <a:extLst xmlns:a="http://schemas.openxmlformats.org/drawingml/2006/main">
               <a:ext uri="{FF2B5EF4-FFF2-40B4-BE49-F238E27FC236}">
-                <a16:creationId xmlns:a16="http://schemas.microsoft.com/office/drawing/2014/main" id="{A2D8A6D6-5A49-46F7-8AC4-D6254B37C82A}"/>
+                <a16:creationId xmlns:a16="http://schemas.microsoft.com/office/drawing/2014/main" id="{9EDFBF68-94E1-445A-9556-759B9580ED01}"/>
               </a:ext>
             </a:extLst>
           </p:cNvPr>
@@ -15508,7 +15508,7 @@
           <p:cNvPr id="2" name="">
             <a:extLst xmlns:a="http://schemas.openxmlformats.org/drawingml/2006/main">
               <a:ext uri="{FF2B5EF4-FFF2-40B4-BE49-F238E27FC236}">
-                <a16:creationId xmlns:a16="http://schemas.microsoft.com/office/drawing/2014/main" id="{AFA012E3-3EA4-4985-9736-995433696C00}"/>
+                <a16:creationId xmlns:a16="http://schemas.microsoft.com/office/drawing/2014/main" id="{7BEB4340-2025-4BE2-9B48-32CFF5DE31DD}"/>
               </a:ext>
             </a:extLst>
           </p:cNvPr>
@@ -15543,7 +15543,7 @@
           <p:cNvPr id="3" name="">
             <a:extLst xmlns:a="http://schemas.openxmlformats.org/drawingml/2006/main">
               <a:ext uri="{FF2B5EF4-FFF2-40B4-BE49-F238E27FC236}">
-                <a16:creationId xmlns:a16="http://schemas.microsoft.com/office/drawing/2014/main" id="{0219A750-29B4-45BE-BEF2-B6726609EAB7}"/>
+                <a16:creationId xmlns:a16="http://schemas.microsoft.com/office/drawing/2014/main" id="{BFC2EC77-20BB-41FC-AA43-C0F0D06A0E10}"/>
               </a:ext>
             </a:extLst>
           </p:cNvPr>
@@ -15578,7 +15578,7 @@
           <p:cNvPr id="4" name="">
             <a:extLst xmlns:a="http://schemas.openxmlformats.org/drawingml/2006/main">
               <a:ext uri="{FF2B5EF4-FFF2-40B4-BE49-F238E27FC236}">
-                <a16:creationId xmlns:a16="http://schemas.microsoft.com/office/drawing/2014/main" id="{66CB809B-9112-44F1-93F3-B29D558FA78E}"/>
+                <a16:creationId xmlns:a16="http://schemas.microsoft.com/office/drawing/2014/main" id="{28E371F6-F69F-4020-A509-203373AB96FD}"/>
               </a:ext>
             </a:extLst>
           </p:cNvPr>
@@ -15613,7 +15613,7 @@
           <p:cNvPr id="5" name="">
             <a:extLst xmlns:a="http://schemas.openxmlformats.org/drawingml/2006/main">
               <a:ext uri="{FF2B5EF4-FFF2-40B4-BE49-F238E27FC236}">
-                <a16:creationId xmlns:a16="http://schemas.microsoft.com/office/drawing/2014/main" id="{830C65E2-0BB4-478D-90C7-95468BD9EFA4}"/>
+                <a16:creationId xmlns:a16="http://schemas.microsoft.com/office/drawing/2014/main" id="{084E76A6-937B-401D-A674-4734FD978AA0}"/>
               </a:ext>
             </a:extLst>
           </p:cNvPr>
@@ -15648,7 +15648,7 @@
           <p:cNvPr id="6" name="">
             <a:extLst xmlns:a="http://schemas.openxmlformats.org/drawingml/2006/main">
               <a:ext uri="{FF2B5EF4-FFF2-40B4-BE49-F238E27FC236}">
-                <a16:creationId xmlns:a16="http://schemas.microsoft.com/office/drawing/2014/main" id="{AF386CE9-49FF-4385-8AF6-5A5E642D8609}"/>
+                <a16:creationId xmlns:a16="http://schemas.microsoft.com/office/drawing/2014/main" id="{120DB5B3-265E-4BF7-BF00-9314488AD194}"/>
               </a:ext>
             </a:extLst>
           </p:cNvPr>
@@ -15683,7 +15683,7 @@
           <p:cNvPr id="7" name="">
             <a:extLst xmlns:a="http://schemas.openxmlformats.org/drawingml/2006/main">
               <a:ext uri="{FF2B5EF4-FFF2-40B4-BE49-F238E27FC236}">
-                <a16:creationId xmlns:a16="http://schemas.microsoft.com/office/drawing/2014/main" id="{C585A5FF-C889-4ECE-B5BB-9B46E12C38A7}"/>
+                <a16:creationId xmlns:a16="http://schemas.microsoft.com/office/drawing/2014/main" id="{F4E8D56F-350F-44C1-B8D2-257FE98DFDA9}"/>
               </a:ext>
             </a:extLst>
           </p:cNvPr>
@@ -15741,7 +15741,7 @@
           <p:cNvPr id="8" name="">
             <a:extLst xmlns:a="http://schemas.openxmlformats.org/drawingml/2006/main">
               <a:ext uri="{FF2B5EF4-FFF2-40B4-BE49-F238E27FC236}">
-                <a16:creationId xmlns:a16="http://schemas.microsoft.com/office/drawing/2014/main" id="{9A668E65-AEE8-4DDB-A725-2BA551F7382E}"/>
+                <a16:creationId xmlns:a16="http://schemas.microsoft.com/office/drawing/2014/main" id="{6594C6D6-C80A-4C04-BE97-924714BD0494}"/>
               </a:ext>
             </a:extLst>
           </p:cNvPr>
@@ -15799,7 +15799,7 @@
           <p:cNvPr id="9" name="">
             <a:extLst xmlns:a="http://schemas.openxmlformats.org/drawingml/2006/main">
               <a:ext uri="{FF2B5EF4-FFF2-40B4-BE49-F238E27FC236}">
-                <a16:creationId xmlns:a16="http://schemas.microsoft.com/office/drawing/2014/main" id="{5C200997-5AE9-4EF3-9689-02507C053382}"/>
+                <a16:creationId xmlns:a16="http://schemas.microsoft.com/office/drawing/2014/main" id="{29C86260-DA3C-42FB-B11D-22E5D02F1515}"/>
               </a:ext>
             </a:extLst>
           </p:cNvPr>
@@ -15857,7 +15857,7 @@
           <p:cNvPr id="10" name="">
             <a:extLst xmlns:a="http://schemas.openxmlformats.org/drawingml/2006/main">
               <a:ext uri="{FF2B5EF4-FFF2-40B4-BE49-F238E27FC236}">
-                <a16:creationId xmlns:a16="http://schemas.microsoft.com/office/drawing/2014/main" id="{1E8DD5BF-0E7D-4E95-834E-BB9AA6A51FBD}"/>
+                <a16:creationId xmlns:a16="http://schemas.microsoft.com/office/drawing/2014/main" id="{A1A7CDB0-029E-4393-A76F-A5C4814CD06F}"/>
               </a:ext>
             </a:extLst>
           </p:cNvPr>
@@ -15892,7 +15892,7 @@
           <p:cNvPr id="11" name="">
             <a:extLst xmlns:a="http://schemas.openxmlformats.org/drawingml/2006/main">
               <a:ext uri="{FF2B5EF4-FFF2-40B4-BE49-F238E27FC236}">
-                <a16:creationId xmlns:a16="http://schemas.microsoft.com/office/drawing/2014/main" id="{1FF8E1CF-17CC-415D-9405-812A08B66EE9}"/>
+                <a16:creationId xmlns:a16="http://schemas.microsoft.com/office/drawing/2014/main" id="{9246731F-3344-4A5F-9D4D-CB27F13F15BB}"/>
               </a:ext>
             </a:extLst>
           </p:cNvPr>
@@ -15952,7 +15952,7 @@
           <p:cNvPr id="12" name="">
             <a:extLst xmlns:a="http://schemas.openxmlformats.org/drawingml/2006/main">
               <a:ext uri="{FF2B5EF4-FFF2-40B4-BE49-F238E27FC236}">
-                <a16:creationId xmlns:a16="http://schemas.microsoft.com/office/drawing/2014/main" id="{8F281BB4-A2DA-4D36-9045-6AB576FBBB27}"/>
+                <a16:creationId xmlns:a16="http://schemas.microsoft.com/office/drawing/2014/main" id="{38B313E4-B50F-4E01-9D45-14CE495F6CCE}"/>
               </a:ext>
             </a:extLst>
           </p:cNvPr>
@@ -16002,7 +16002,7 @@
                   <a:srgbClr val="5D757C"/>
                 </a:solidFill>
               </a:rPr>
-              <a:t>The workflow is designed around operational data, clinic control, and lightweight onboarding.</a:t>
+              <a:t>The workflow is designed around operational data, clinic control, and lightweight onboarding without patient accounts in v1.</a:t>
             </a:r>
           </a:p>
         </p:txBody>
@@ -16012,7 +16012,7 @@
           <p:cNvPr id="13" name="">
             <a:extLst xmlns:a="http://schemas.openxmlformats.org/drawingml/2006/main">
               <a:ext uri="{FF2B5EF4-FFF2-40B4-BE49-F238E27FC236}">
-                <a16:creationId xmlns:a16="http://schemas.microsoft.com/office/drawing/2014/main" id="{D19A1603-B5F8-4406-A586-B97A66C6EE71}"/>
+                <a16:creationId xmlns:a16="http://schemas.microsoft.com/office/drawing/2014/main" id="{198AE81D-17D7-4716-BFDB-7FA26EBA5019}"/>
               </a:ext>
             </a:extLst>
           </p:cNvPr>
@@ -16047,7 +16047,7 @@
           <p:cNvPr id="14" name="">
             <a:extLst xmlns:a="http://schemas.openxmlformats.org/drawingml/2006/main">
               <a:ext uri="{FF2B5EF4-FFF2-40B4-BE49-F238E27FC236}">
-                <a16:creationId xmlns:a16="http://schemas.microsoft.com/office/drawing/2014/main" id="{B9190E95-6987-44FC-92A0-748A10D75141}"/>
+                <a16:creationId xmlns:a16="http://schemas.microsoft.com/office/drawing/2014/main" id="{477B2D70-BEBA-43A7-97B0-7817EB0B10EA}"/>
               </a:ext>
             </a:extLst>
           </p:cNvPr>
@@ -16082,7 +16082,7 @@
           <p:cNvPr id="15" name="">
             <a:extLst xmlns:a="http://schemas.openxmlformats.org/drawingml/2006/main">
               <a:ext uri="{FF2B5EF4-FFF2-40B4-BE49-F238E27FC236}">
-                <a16:creationId xmlns:a16="http://schemas.microsoft.com/office/drawing/2014/main" id="{EA6AB952-A29E-4611-AA28-71561610606C}"/>
+                <a16:creationId xmlns:a16="http://schemas.microsoft.com/office/drawing/2014/main" id="{A4D9071D-34AD-42C4-AEED-856982C278DF}"/>
               </a:ext>
             </a:extLst>
           </p:cNvPr>
@@ -16142,7 +16142,7 @@
           <p:cNvPr id="16" name="">
             <a:extLst xmlns:a="http://schemas.openxmlformats.org/drawingml/2006/main">
               <a:ext uri="{FF2B5EF4-FFF2-40B4-BE49-F238E27FC236}">
-                <a16:creationId xmlns:a16="http://schemas.microsoft.com/office/drawing/2014/main" id="{ACF197FE-C153-4278-9F6C-E066208E4C1D}"/>
+                <a16:creationId xmlns:a16="http://schemas.microsoft.com/office/drawing/2014/main" id="{BAD17979-6B22-4F5A-B09C-1C1AB70A932F}"/>
               </a:ext>
             </a:extLst>
           </p:cNvPr>
@@ -16202,7 +16202,7 @@
           <p:cNvPr id="17" name="">
             <a:extLst xmlns:a="http://schemas.openxmlformats.org/drawingml/2006/main">
               <a:ext uri="{FF2B5EF4-FFF2-40B4-BE49-F238E27FC236}">
-                <a16:creationId xmlns:a16="http://schemas.microsoft.com/office/drawing/2014/main" id="{2538A090-1651-4578-B77E-41EE8DB1A000}"/>
+                <a16:creationId xmlns:a16="http://schemas.microsoft.com/office/drawing/2014/main" id="{7C4F8533-A80A-4A68-83AE-90C8DB331A52}"/>
               </a:ext>
             </a:extLst>
           </p:cNvPr>
@@ -16237,7 +16237,7 @@
           <p:cNvPr id="18" name="">
             <a:extLst xmlns:a="http://schemas.openxmlformats.org/drawingml/2006/main">
               <a:ext uri="{FF2B5EF4-FFF2-40B4-BE49-F238E27FC236}">
-                <a16:creationId xmlns:a16="http://schemas.microsoft.com/office/drawing/2014/main" id="{D0292E90-AFEB-4D48-978F-8DDD27A1E8CD}"/>
+                <a16:creationId xmlns:a16="http://schemas.microsoft.com/office/drawing/2014/main" id="{34D79C4A-E4A9-4B05-9C3F-51AA5EF979EF}"/>
               </a:ext>
             </a:extLst>
           </p:cNvPr>
@@ -16272,7 +16272,7 @@
           <p:cNvPr id="19" name="">
             <a:extLst xmlns:a="http://schemas.openxmlformats.org/drawingml/2006/main">
               <a:ext uri="{FF2B5EF4-FFF2-40B4-BE49-F238E27FC236}">
-                <a16:creationId xmlns:a16="http://schemas.microsoft.com/office/drawing/2014/main" id="{86B12214-EE5A-45A7-A714-6F7DB0152C44}"/>
+                <a16:creationId xmlns:a16="http://schemas.microsoft.com/office/drawing/2014/main" id="{D54E296C-CF52-4631-8357-6006CCE7EA98}"/>
               </a:ext>
             </a:extLst>
           </p:cNvPr>
@@ -16332,7 +16332,7 @@
           <p:cNvPr id="20" name="">
             <a:extLst xmlns:a="http://schemas.openxmlformats.org/drawingml/2006/main">
               <a:ext uri="{FF2B5EF4-FFF2-40B4-BE49-F238E27FC236}">
-                <a16:creationId xmlns:a16="http://schemas.microsoft.com/office/drawing/2014/main" id="{13C5850F-A335-4EDA-A164-001ED4EA6469}"/>
+                <a16:creationId xmlns:a16="http://schemas.microsoft.com/office/drawing/2014/main" id="{15B13F55-79D0-4565-9B9B-063B9A4E75F8}"/>
               </a:ext>
             </a:extLst>
           </p:cNvPr>
@@ -16392,7 +16392,7 @@
           <p:cNvPr id="21" name="">
             <a:extLst xmlns:a="http://schemas.openxmlformats.org/drawingml/2006/main">
               <a:ext uri="{FF2B5EF4-FFF2-40B4-BE49-F238E27FC236}">
-                <a16:creationId xmlns:a16="http://schemas.microsoft.com/office/drawing/2014/main" id="{B797E619-E12F-4270-9D12-7BD232948446}"/>
+                <a16:creationId xmlns:a16="http://schemas.microsoft.com/office/drawing/2014/main" id="{B411717A-F637-475E-B3EE-6F19F6348B6A}"/>
               </a:ext>
             </a:extLst>
           </p:cNvPr>
@@ -16427,7 +16427,7 @@
           <p:cNvPr id="22" name="">
             <a:extLst xmlns:a="http://schemas.openxmlformats.org/drawingml/2006/main">
               <a:ext uri="{FF2B5EF4-FFF2-40B4-BE49-F238E27FC236}">
-                <a16:creationId xmlns:a16="http://schemas.microsoft.com/office/drawing/2014/main" id="{7001FC1A-D2E8-4169-B7FE-47DF3A096B9C}"/>
+                <a16:creationId xmlns:a16="http://schemas.microsoft.com/office/drawing/2014/main" id="{1815052C-93DD-477E-866C-C32E044ABF1E}"/>
               </a:ext>
             </a:extLst>
           </p:cNvPr>
@@ -16462,7 +16462,7 @@
           <p:cNvPr id="23" name="">
             <a:extLst xmlns:a="http://schemas.openxmlformats.org/drawingml/2006/main">
               <a:ext uri="{FF2B5EF4-FFF2-40B4-BE49-F238E27FC236}">
-                <a16:creationId xmlns:a16="http://schemas.microsoft.com/office/drawing/2014/main" id="{371E91CE-848D-4233-8ED1-2A7A71F3D636}"/>
+                <a16:creationId xmlns:a16="http://schemas.microsoft.com/office/drawing/2014/main" id="{2A5FBCC8-7D9D-4575-BBDD-EEA46CF25E67}"/>
               </a:ext>
             </a:extLst>
           </p:cNvPr>
@@ -16512,7 +16512,7 @@
                   <a:srgbClr val="18343C"/>
                 </a:solidFill>
               </a:rPr>
-              <a:t>Clinic control and auditability</a:t>
+              <a:t>No patient accounts in v1</a:t>
             </a:r>
           </a:p>
         </p:txBody>
@@ -16522,7 +16522,7 @@
           <p:cNvPr id="24" name="">
             <a:extLst xmlns:a="http://schemas.openxmlformats.org/drawingml/2006/main">
               <a:ext uri="{FF2B5EF4-FFF2-40B4-BE49-F238E27FC236}">
-                <a16:creationId xmlns:a16="http://schemas.microsoft.com/office/drawing/2014/main" id="{55EC34E4-5E47-4E83-9F45-B16081C35F7E}"/>
+                <a16:creationId xmlns:a16="http://schemas.microsoft.com/office/drawing/2014/main" id="{163DDAD0-B31F-44A2-9BB1-18EFB333C55E}"/>
               </a:ext>
             </a:extLst>
           </p:cNvPr>
@@ -16555,7 +16555,7 @@
         </p:spPr>
         <p:txBody>
           <a:bodyPr xmlns:a="http://schemas.openxmlformats.org/drawingml/2006/main" lIns="0" tIns="0" rIns="0" bIns="0" anchor="t">
-            <a:normAutofit fontScale="55882"/>
+            <a:normAutofit fontScale="43590"/>
           </a:bodyPr>
           <a:lstStyle xmlns:a="http://schemas.openxmlformats.org/drawingml/2006/main"/>
           <a:p xmlns:a="http://schemas.openxmlformats.org/drawingml/2006/main">
@@ -16572,7 +16572,7 @@
                   <a:srgbClr val="5D757C"/>
                 </a:solidFill>
               </a:rPr>
-              <a:t>The clinic stays in control of patient workflows and operational decisions.</a:t>
+              <a:t>Patient confirmations and rescheduling can happen through secure links without adding a new patient portal.</a:t>
             </a:r>
           </a:p>
         </p:txBody>
@@ -16582,7 +16582,7 @@
           <p:cNvPr id="25" name="">
             <a:extLst xmlns:a="http://schemas.openxmlformats.org/drawingml/2006/main">
               <a:ext uri="{FF2B5EF4-FFF2-40B4-BE49-F238E27FC236}">
-                <a16:creationId xmlns:a16="http://schemas.microsoft.com/office/drawing/2014/main" id="{8DC664C4-8A64-4E7A-BA0B-F1876ACA5310}"/>
+                <a16:creationId xmlns:a16="http://schemas.microsoft.com/office/drawing/2014/main" id="{1F7597AF-8C19-4B3E-BAF3-447EF5CAD23F}"/>
               </a:ext>
             </a:extLst>
           </p:cNvPr>
@@ -16617,7 +16617,7 @@
           <p:cNvPr id="26" name="">
             <a:extLst xmlns:a="http://schemas.openxmlformats.org/drawingml/2006/main">
               <a:ext uri="{FF2B5EF4-FFF2-40B4-BE49-F238E27FC236}">
-                <a16:creationId xmlns:a16="http://schemas.microsoft.com/office/drawing/2014/main" id="{F70DD397-9BE4-4E47-B295-5F83F1AC3A94}"/>
+                <a16:creationId xmlns:a16="http://schemas.microsoft.com/office/drawing/2014/main" id="{76A978AC-3ADC-4378-B890-101D49504674}"/>
               </a:ext>
             </a:extLst>
           </p:cNvPr>
@@ -16677,7 +16677,7 @@
           <p:cNvPr id="27" name="">
             <a:extLst xmlns:a="http://schemas.openxmlformats.org/drawingml/2006/main">
               <a:ext uri="{FF2B5EF4-FFF2-40B4-BE49-F238E27FC236}">
-                <a16:creationId xmlns:a16="http://schemas.microsoft.com/office/drawing/2014/main" id="{CF4B4722-3E3A-4883-90C0-6FEDECE0248F}"/>
+                <a16:creationId xmlns:a16="http://schemas.microsoft.com/office/drawing/2014/main" id="{8DBFA080-1981-43D5-8385-5278446DE426}"/>
               </a:ext>
             </a:extLst>
           </p:cNvPr>
@@ -16712,7 +16712,7 @@
           <p:cNvPr id="28" name="">
             <a:extLst xmlns:a="http://schemas.openxmlformats.org/drawingml/2006/main">
               <a:ext uri="{FF2B5EF4-FFF2-40B4-BE49-F238E27FC236}">
-                <a16:creationId xmlns:a16="http://schemas.microsoft.com/office/drawing/2014/main" id="{EC5D1A6B-13B2-423B-8710-C1B9555039B0}"/>
+                <a16:creationId xmlns:a16="http://schemas.microsoft.com/office/drawing/2014/main" id="{5AEE5830-87E3-458D-A929-78DA31D88319}"/>
               </a:ext>
             </a:extLst>
           </p:cNvPr>
@@ -16772,7 +16772,7 @@
           <p:cNvPr id="29" name="">
             <a:extLst xmlns:a="http://schemas.openxmlformats.org/drawingml/2006/main">
               <a:ext uri="{FF2B5EF4-FFF2-40B4-BE49-F238E27FC236}">
-                <a16:creationId xmlns:a16="http://schemas.microsoft.com/office/drawing/2014/main" id="{BF41B703-0746-4F10-9967-42F7C15874A4}"/>
+                <a16:creationId xmlns:a16="http://schemas.microsoft.com/office/drawing/2014/main" id="{D8D18091-CBBA-4DA6-A7BF-9A0100EDC8C1}"/>
               </a:ext>
             </a:extLst>
           </p:cNvPr>
@@ -16832,7 +16832,7 @@
           <p:cNvPr id="30" name="">
             <a:extLst xmlns:a="http://schemas.openxmlformats.org/drawingml/2006/main">
               <a:ext uri="{FF2B5EF4-FFF2-40B4-BE49-F238E27FC236}">
-                <a16:creationId xmlns:a16="http://schemas.microsoft.com/office/drawing/2014/main" id="{2D0A058A-1B25-43C6-A225-2162D969778A}"/>
+                <a16:creationId xmlns:a16="http://schemas.microsoft.com/office/drawing/2014/main" id="{2055E638-58F5-45DD-95D5-D479E4AC4B25}"/>
               </a:ext>
             </a:extLst>
           </p:cNvPr>
@@ -16867,7 +16867,7 @@
           <p:cNvPr id="31" name="">
             <a:extLst xmlns:a="http://schemas.openxmlformats.org/drawingml/2006/main">
               <a:ext uri="{FF2B5EF4-FFF2-40B4-BE49-F238E27FC236}">
-                <a16:creationId xmlns:a16="http://schemas.microsoft.com/office/drawing/2014/main" id="{31A483F9-3781-4BFA-9693-B9DFB04EA97A}"/>
+                <a16:creationId xmlns:a16="http://schemas.microsoft.com/office/drawing/2014/main" id="{EF34FFD7-1C1E-4814-A161-2FA80D4FD308}"/>
               </a:ext>
             </a:extLst>
           </p:cNvPr>
@@ -16927,7 +16927,7 @@
           <p:cNvPr id="32" name="">
             <a:extLst xmlns:a="http://schemas.openxmlformats.org/drawingml/2006/main">
               <a:ext uri="{FF2B5EF4-FFF2-40B4-BE49-F238E27FC236}">
-                <a16:creationId xmlns:a16="http://schemas.microsoft.com/office/drawing/2014/main" id="{31316444-73A2-4EE7-A14D-96B07BC51243}"/>
+                <a16:creationId xmlns:a16="http://schemas.microsoft.com/office/drawing/2014/main" id="{AFDFD9E2-25AD-4D8B-BFDF-A80EC38173E7}"/>
               </a:ext>
             </a:extLst>
           </p:cNvPr>
@@ -16987,7 +16987,7 @@
           <p:cNvPr id="33" name="">
             <a:extLst xmlns:a="http://schemas.openxmlformats.org/drawingml/2006/main">
               <a:ext uri="{FF2B5EF4-FFF2-40B4-BE49-F238E27FC236}">
-                <a16:creationId xmlns:a16="http://schemas.microsoft.com/office/drawing/2014/main" id="{FE42C935-39E9-4121-A2E0-AD7D992A1CF3}"/>
+                <a16:creationId xmlns:a16="http://schemas.microsoft.com/office/drawing/2014/main" id="{3326B08F-4549-46E4-A195-9D492A965628}"/>
               </a:ext>
             </a:extLst>
           </p:cNvPr>
@@ -17022,7 +17022,7 @@
           <p:cNvPr id="34" name="">
             <a:extLst xmlns:a="http://schemas.openxmlformats.org/drawingml/2006/main">
               <a:ext uri="{FF2B5EF4-FFF2-40B4-BE49-F238E27FC236}">
-                <a16:creationId xmlns:a16="http://schemas.microsoft.com/office/drawing/2014/main" id="{8344288C-BA44-4CE9-A5DD-C96F6A981022}"/>
+                <a16:creationId xmlns:a16="http://schemas.microsoft.com/office/drawing/2014/main" id="{686779A3-9A56-4222-9818-F9B028D865C0}"/>
               </a:ext>
             </a:extLst>
           </p:cNvPr>
@@ -17082,7 +17082,7 @@
           <p:cNvPr id="35" name="">
             <a:extLst xmlns:a="http://schemas.openxmlformats.org/drawingml/2006/main">
               <a:ext uri="{FF2B5EF4-FFF2-40B4-BE49-F238E27FC236}">
-                <a16:creationId xmlns:a16="http://schemas.microsoft.com/office/drawing/2014/main" id="{C497879C-0F77-41A8-A720-8DC25519E7B2}"/>
+                <a16:creationId xmlns:a16="http://schemas.microsoft.com/office/drawing/2014/main" id="{AF341657-87C5-4A34-AA6E-368B1EA5B4F8}"/>
               </a:ext>
             </a:extLst>
           </p:cNvPr>
@@ -17142,7 +17142,7 @@
           <p:cNvPr id="36" name="">
             <a:extLst xmlns:a="http://schemas.openxmlformats.org/drawingml/2006/main">
               <a:ext uri="{FF2B5EF4-FFF2-40B4-BE49-F238E27FC236}">
-                <a16:creationId xmlns:a16="http://schemas.microsoft.com/office/drawing/2014/main" id="{EE1B1E5B-5858-4501-8386-7B82E49466B1}"/>
+                <a16:creationId xmlns:a16="http://schemas.microsoft.com/office/drawing/2014/main" id="{EA514025-2C64-46A4-90C1-D38052646A44}"/>
               </a:ext>
             </a:extLst>
           </p:cNvPr>
@@ -17177,7 +17177,7 @@
           <p:cNvPr id="37" name="">
             <a:extLst xmlns:a="http://schemas.openxmlformats.org/drawingml/2006/main">
               <a:ext uri="{FF2B5EF4-FFF2-40B4-BE49-F238E27FC236}">
-                <a16:creationId xmlns:a16="http://schemas.microsoft.com/office/drawing/2014/main" id="{398B3E58-A0E1-47A3-A1A8-8322E6480B57}"/>
+                <a16:creationId xmlns:a16="http://schemas.microsoft.com/office/drawing/2014/main" id="{2B62F810-A653-4DFC-A03C-67342EA3C6C3}"/>
               </a:ext>
             </a:extLst>
           </p:cNvPr>
@@ -17212,7 +17212,7 @@
           <p:cNvPr id="38" name="">
             <a:extLst xmlns:a="http://schemas.openxmlformats.org/drawingml/2006/main">
               <a:ext uri="{FF2B5EF4-FFF2-40B4-BE49-F238E27FC236}">
-                <a16:creationId xmlns:a16="http://schemas.microsoft.com/office/drawing/2014/main" id="{7C5273E0-ABD6-4931-B448-CD091EF634B8}"/>
+                <a16:creationId xmlns:a16="http://schemas.microsoft.com/office/drawing/2014/main" id="{FE4EA403-29FF-4E5B-9C01-194BE640D3C9}"/>
               </a:ext>
             </a:extLst>
           </p:cNvPr>
@@ -17247,7 +17247,7 @@
           <p:cNvPr id="39" name="">
             <a:extLst xmlns:a="http://schemas.openxmlformats.org/drawingml/2006/main">
               <a:ext uri="{FF2B5EF4-FFF2-40B4-BE49-F238E27FC236}">
-                <a16:creationId xmlns:a16="http://schemas.microsoft.com/office/drawing/2014/main" id="{0E4614F0-298A-4147-8B8B-3B6572B8EAC0}"/>
+                <a16:creationId xmlns:a16="http://schemas.microsoft.com/office/drawing/2014/main" id="{79EF0298-FD6C-4A42-AE28-924AC6D996D4}"/>
               </a:ext>
             </a:extLst>
           </p:cNvPr>
@@ -17282,7 +17282,7 @@
           <p:cNvPr id="40" name="">
             <a:extLst xmlns:a="http://schemas.openxmlformats.org/drawingml/2006/main">
               <a:ext uri="{FF2B5EF4-FFF2-40B4-BE49-F238E27FC236}">
-                <a16:creationId xmlns:a16="http://schemas.microsoft.com/office/drawing/2014/main" id="{02492314-70FF-4C3A-BF69-3B243D200340}"/>
+                <a16:creationId xmlns:a16="http://schemas.microsoft.com/office/drawing/2014/main" id="{FFF51DF9-AEA1-4193-9A1F-AC3500B88E3A}"/>
               </a:ext>
             </a:extLst>
           </p:cNvPr>
@@ -17317,7 +17317,7 @@
           <p:cNvPr id="41" name="">
             <a:extLst xmlns:a="http://schemas.openxmlformats.org/drawingml/2006/main">
               <a:ext uri="{FF2B5EF4-FFF2-40B4-BE49-F238E27FC236}">
-                <a16:creationId xmlns:a16="http://schemas.microsoft.com/office/drawing/2014/main" id="{75B96BA4-BD9B-4705-8B8E-820AD8856D57}"/>
+                <a16:creationId xmlns:a16="http://schemas.microsoft.com/office/drawing/2014/main" id="{A51302C6-AD86-49FD-9460-C2235CF52153}"/>
               </a:ext>
             </a:extLst>
           </p:cNvPr>
@@ -17373,7 +17373,7 @@
     </p:spTree>
     <p:extLst>
       <p:ext uri="{BB962C8B-B14F-4D97-AF65-F5344CB8AC3E}">
-        <p14:creationId xmlns:p14="http://schemas.microsoft.com/office/powerpoint/2010/main" val="412901499"/>
+        <p14:creationId xmlns:p14="http://schemas.microsoft.com/office/powerpoint/2010/main" val="615133399"/>
       </p:ext>
     </p:extLst>
   </p:cSld>
@@ -17404,7 +17404,7 @@
           <p:cNvPr id="1" name="Slide Number Placeholder 5">
             <a:extLst xmlns:a="http://schemas.openxmlformats.org/drawingml/2006/main">
               <a:ext uri="{FF2B5EF4-FFF2-40B4-BE49-F238E27FC236}">
-                <a16:creationId xmlns:a16="http://schemas.microsoft.com/office/drawing/2014/main" id="{A2D8A6D6-5A49-46F7-8AC4-D6254B37C82A}"/>
+                <a16:creationId xmlns:a16="http://schemas.microsoft.com/office/drawing/2014/main" id="{9EDFBF68-94E1-445A-9556-759B9580ED01}"/>
               </a:ext>
             </a:extLst>
           </p:cNvPr>
@@ -17436,7 +17436,7 @@
           <p:cNvPr id="2" name="">
             <a:extLst xmlns:a="http://schemas.openxmlformats.org/drawingml/2006/main">
               <a:ext uri="{FF2B5EF4-FFF2-40B4-BE49-F238E27FC236}">
-                <a16:creationId xmlns:a16="http://schemas.microsoft.com/office/drawing/2014/main" id="{40CAC84B-1B88-4491-BCB3-C95D620D628E}"/>
+                <a16:creationId xmlns:a16="http://schemas.microsoft.com/office/drawing/2014/main" id="{C89C4903-ED4D-4598-B2F0-07B49191E9FE}"/>
               </a:ext>
             </a:extLst>
           </p:cNvPr>
@@ -17471,7 +17471,7 @@
           <p:cNvPr id="3" name="">
             <a:extLst xmlns:a="http://schemas.openxmlformats.org/drawingml/2006/main">
               <a:ext uri="{FF2B5EF4-FFF2-40B4-BE49-F238E27FC236}">
-                <a16:creationId xmlns:a16="http://schemas.microsoft.com/office/drawing/2014/main" id="{F6CBA962-AEB5-4A8C-B2D6-D43CC65072A7}"/>
+                <a16:creationId xmlns:a16="http://schemas.microsoft.com/office/drawing/2014/main" id="{0F66B6FD-86FC-403E-9123-52420D772F3D}"/>
               </a:ext>
             </a:extLst>
           </p:cNvPr>
@@ -17506,7 +17506,7 @@
           <p:cNvPr id="4" name="">
             <a:extLst xmlns:a="http://schemas.openxmlformats.org/drawingml/2006/main">
               <a:ext uri="{FF2B5EF4-FFF2-40B4-BE49-F238E27FC236}">
-                <a16:creationId xmlns:a16="http://schemas.microsoft.com/office/drawing/2014/main" id="{214F725A-674A-434B-BABD-81F47F8C49A9}"/>
+                <a16:creationId xmlns:a16="http://schemas.microsoft.com/office/drawing/2014/main" id="{D5BF055C-982B-4E4B-A6D9-9CB42C94879A}"/>
               </a:ext>
             </a:extLst>
           </p:cNvPr>
@@ -17541,7 +17541,7 @@
           <p:cNvPr id="5" name="">
             <a:extLst xmlns:a="http://schemas.openxmlformats.org/drawingml/2006/main">
               <a:ext uri="{FF2B5EF4-FFF2-40B4-BE49-F238E27FC236}">
-                <a16:creationId xmlns:a16="http://schemas.microsoft.com/office/drawing/2014/main" id="{E8BEB57F-1FB8-4346-BF22-FA46A75762E8}"/>
+                <a16:creationId xmlns:a16="http://schemas.microsoft.com/office/drawing/2014/main" id="{83746188-CE9F-4778-A1D2-36C2E3F4E1CC}"/>
               </a:ext>
             </a:extLst>
           </p:cNvPr>
@@ -17576,7 +17576,7 @@
           <p:cNvPr id="6" name="">
             <a:extLst xmlns:a="http://schemas.openxmlformats.org/drawingml/2006/main">
               <a:ext uri="{FF2B5EF4-FFF2-40B4-BE49-F238E27FC236}">
-                <a16:creationId xmlns:a16="http://schemas.microsoft.com/office/drawing/2014/main" id="{C6A0592B-A5A2-414C-83DA-49A044D7C785}"/>
+                <a16:creationId xmlns:a16="http://schemas.microsoft.com/office/drawing/2014/main" id="{595172C7-D261-4B4D-9EB7-26401FABB37C}"/>
               </a:ext>
             </a:extLst>
           </p:cNvPr>
@@ -17611,7 +17611,7 @@
           <p:cNvPr id="7" name="">
             <a:extLst xmlns:a="http://schemas.openxmlformats.org/drawingml/2006/main">
               <a:ext uri="{FF2B5EF4-FFF2-40B4-BE49-F238E27FC236}">
-                <a16:creationId xmlns:a16="http://schemas.microsoft.com/office/drawing/2014/main" id="{6D0DA64D-53AF-4E8B-A924-C387CD7D7AE3}"/>
+                <a16:creationId xmlns:a16="http://schemas.microsoft.com/office/drawing/2014/main" id="{47BDA3A7-0BA6-477D-B6F1-7814B6E21BB2}"/>
               </a:ext>
             </a:extLst>
           </p:cNvPr>
@@ -17669,7 +17669,7 @@
           <p:cNvPr id="8" name="">
             <a:extLst xmlns:a="http://schemas.openxmlformats.org/drawingml/2006/main">
               <a:ext uri="{FF2B5EF4-FFF2-40B4-BE49-F238E27FC236}">
-                <a16:creationId xmlns:a16="http://schemas.microsoft.com/office/drawing/2014/main" id="{F502A677-7C85-4B90-BA90-294B00F584FE}"/>
+                <a16:creationId xmlns:a16="http://schemas.microsoft.com/office/drawing/2014/main" id="{BBE161A7-FBEE-4D6D-A079-2834A0CECCF9}"/>
               </a:ext>
             </a:extLst>
           </p:cNvPr>
@@ -17727,7 +17727,7 @@
           <p:cNvPr id="9" name="">
             <a:extLst xmlns:a="http://schemas.openxmlformats.org/drawingml/2006/main">
               <a:ext uri="{FF2B5EF4-FFF2-40B4-BE49-F238E27FC236}">
-                <a16:creationId xmlns:a16="http://schemas.microsoft.com/office/drawing/2014/main" id="{EFB40EEC-5A51-4E99-8AB7-E721F913776B}"/>
+                <a16:creationId xmlns:a16="http://schemas.microsoft.com/office/drawing/2014/main" id="{05F0D6FD-22B1-4620-A636-7E2A7DFFA372}"/>
               </a:ext>
             </a:extLst>
           </p:cNvPr>
@@ -17785,7 +17785,7 @@
           <p:cNvPr id="10" name="">
             <a:extLst xmlns:a="http://schemas.openxmlformats.org/drawingml/2006/main">
               <a:ext uri="{FF2B5EF4-FFF2-40B4-BE49-F238E27FC236}">
-                <a16:creationId xmlns:a16="http://schemas.microsoft.com/office/drawing/2014/main" id="{31CBFDE6-3425-46F5-BFC8-1E1427F5C4DE}"/>
+                <a16:creationId xmlns:a16="http://schemas.microsoft.com/office/drawing/2014/main" id="{62DDFA2F-EE72-4778-B7AF-79CB25303D78}"/>
               </a:ext>
             </a:extLst>
           </p:cNvPr>
@@ -17820,7 +17820,7 @@
           <p:cNvPr id="11" name="">
             <a:extLst xmlns:a="http://schemas.openxmlformats.org/drawingml/2006/main">
               <a:ext uri="{FF2B5EF4-FFF2-40B4-BE49-F238E27FC236}">
-                <a16:creationId xmlns:a16="http://schemas.microsoft.com/office/drawing/2014/main" id="{E23B87BB-9E29-4BC1-964B-47B60BCC6588}"/>
+                <a16:creationId xmlns:a16="http://schemas.microsoft.com/office/drawing/2014/main" id="{A50AA424-42A8-4FF9-8E01-D708A6DD9B7F}"/>
               </a:ext>
             </a:extLst>
           </p:cNvPr>
@@ -17880,7 +17880,7 @@
           <p:cNvPr id="12" name="">
             <a:extLst xmlns:a="http://schemas.openxmlformats.org/drawingml/2006/main">
               <a:ext uri="{FF2B5EF4-FFF2-40B4-BE49-F238E27FC236}">
-                <a16:creationId xmlns:a16="http://schemas.microsoft.com/office/drawing/2014/main" id="{9E3CB13C-0F47-47E8-B53A-BFD5438807B5}"/>
+                <a16:creationId xmlns:a16="http://schemas.microsoft.com/office/drawing/2014/main" id="{761E05E7-6AEB-464D-AA46-7F658D4D1A7D}"/>
               </a:ext>
             </a:extLst>
           </p:cNvPr>
@@ -17940,7 +17940,7 @@
           <p:cNvPr id="13" name="">
             <a:extLst xmlns:a="http://schemas.openxmlformats.org/drawingml/2006/main">
               <a:ext uri="{FF2B5EF4-FFF2-40B4-BE49-F238E27FC236}">
-                <a16:creationId xmlns:a16="http://schemas.microsoft.com/office/drawing/2014/main" id="{3F42EB96-BC03-4FF1-89D8-2E26BFAF6A4A}"/>
+                <a16:creationId xmlns:a16="http://schemas.microsoft.com/office/drawing/2014/main" id="{4473274D-342E-47C2-9D65-D0BB3D8614A7}"/>
               </a:ext>
             </a:extLst>
           </p:cNvPr>
@@ -17975,7 +17975,7 @@
           <p:cNvPr id="14" name="">
             <a:extLst xmlns:a="http://schemas.openxmlformats.org/drawingml/2006/main">
               <a:ext uri="{FF2B5EF4-FFF2-40B4-BE49-F238E27FC236}">
-                <a16:creationId xmlns:a16="http://schemas.microsoft.com/office/drawing/2014/main" id="{935D699B-F3B3-4FFB-B5ED-4EEF22418ABE}"/>
+                <a16:creationId xmlns:a16="http://schemas.microsoft.com/office/drawing/2014/main" id="{4A9869D0-90D1-4602-8DBE-691B1E65FBA3}"/>
               </a:ext>
             </a:extLst>
           </p:cNvPr>
@@ -18033,7 +18033,7 @@
           <p:cNvPr id="15" name="">
             <a:extLst xmlns:a="http://schemas.openxmlformats.org/drawingml/2006/main">
               <a:ext uri="{FF2B5EF4-FFF2-40B4-BE49-F238E27FC236}">
-                <a16:creationId xmlns:a16="http://schemas.microsoft.com/office/drawing/2014/main" id="{11C80214-47E7-4A3A-9AAC-33A06B1AC6F1}"/>
+                <a16:creationId xmlns:a16="http://schemas.microsoft.com/office/drawing/2014/main" id="{5E3577BC-67ED-42F0-9549-BD03B38EF442}"/>
               </a:ext>
             </a:extLst>
           </p:cNvPr>
@@ -18093,7 +18093,7 @@
           <p:cNvPr id="16" name="">
             <a:extLst xmlns:a="http://schemas.openxmlformats.org/drawingml/2006/main">
               <a:ext uri="{FF2B5EF4-FFF2-40B4-BE49-F238E27FC236}">
-                <a16:creationId xmlns:a16="http://schemas.microsoft.com/office/drawing/2014/main" id="{2CEB828A-9046-49AA-A6AD-EBB850331FB4}"/>
+                <a16:creationId xmlns:a16="http://schemas.microsoft.com/office/drawing/2014/main" id="{D3423386-BA72-4BCE-9B20-E6491C5992FD}"/>
               </a:ext>
             </a:extLst>
           </p:cNvPr>
@@ -18128,7 +18128,7 @@
           <p:cNvPr id="17" name="">
             <a:extLst xmlns:a="http://schemas.openxmlformats.org/drawingml/2006/main">
               <a:ext uri="{FF2B5EF4-FFF2-40B4-BE49-F238E27FC236}">
-                <a16:creationId xmlns:a16="http://schemas.microsoft.com/office/drawing/2014/main" id="{B7BA46A5-D64D-41A9-896C-F577C0C5280B}"/>
+                <a16:creationId xmlns:a16="http://schemas.microsoft.com/office/drawing/2014/main" id="{85AD2EC2-21A2-4C90-AB69-8BA3F1E43DFF}"/>
               </a:ext>
             </a:extLst>
           </p:cNvPr>
@@ -18163,7 +18163,7 @@
           <p:cNvPr id="18" name="">
             <a:extLst xmlns:a="http://schemas.openxmlformats.org/drawingml/2006/main">
               <a:ext uri="{FF2B5EF4-FFF2-40B4-BE49-F238E27FC236}">
-                <a16:creationId xmlns:a16="http://schemas.microsoft.com/office/drawing/2014/main" id="{944A4B66-5EC1-42EA-A55C-2740B6A1C6EE}"/>
+                <a16:creationId xmlns:a16="http://schemas.microsoft.com/office/drawing/2014/main" id="{93ECE54F-31D9-4941-8F65-13D961D4B8CB}"/>
               </a:ext>
             </a:extLst>
           </p:cNvPr>
@@ -18223,7 +18223,7 @@
           <p:cNvPr id="19" name="">
             <a:extLst xmlns:a="http://schemas.openxmlformats.org/drawingml/2006/main">
               <a:ext uri="{FF2B5EF4-FFF2-40B4-BE49-F238E27FC236}">
-                <a16:creationId xmlns:a16="http://schemas.microsoft.com/office/drawing/2014/main" id="{11A8819D-72D2-45A5-90DF-DE112D61D4B3}"/>
+                <a16:creationId xmlns:a16="http://schemas.microsoft.com/office/drawing/2014/main" id="{2A02A345-EFB9-48AA-B698-38A8853CD9CF}"/>
               </a:ext>
             </a:extLst>
           </p:cNvPr>
@@ -18283,7 +18283,7 @@
           <p:cNvPr id="20" name="">
             <a:extLst xmlns:a="http://schemas.openxmlformats.org/drawingml/2006/main">
               <a:ext uri="{FF2B5EF4-FFF2-40B4-BE49-F238E27FC236}">
-                <a16:creationId xmlns:a16="http://schemas.microsoft.com/office/drawing/2014/main" id="{EBA4F295-79C1-473F-8A73-2C44896922EC}"/>
+                <a16:creationId xmlns:a16="http://schemas.microsoft.com/office/drawing/2014/main" id="{C6FDE2FD-9D24-418A-AD50-ED17872C6756}"/>
               </a:ext>
             </a:extLst>
           </p:cNvPr>
@@ -18318,7 +18318,7 @@
           <p:cNvPr id="21" name="">
             <a:extLst xmlns:a="http://schemas.openxmlformats.org/drawingml/2006/main">
               <a:ext uri="{FF2B5EF4-FFF2-40B4-BE49-F238E27FC236}">
-                <a16:creationId xmlns:a16="http://schemas.microsoft.com/office/drawing/2014/main" id="{EFE3CB3E-699C-48FD-B475-D81CAB064CBE}"/>
+                <a16:creationId xmlns:a16="http://schemas.microsoft.com/office/drawing/2014/main" id="{8A3DDD05-2D5F-4E8D-B1B7-C8B152212D61}"/>
               </a:ext>
             </a:extLst>
           </p:cNvPr>
@@ -18353,7 +18353,7 @@
           <p:cNvPr id="22" name="">
             <a:extLst xmlns:a="http://schemas.openxmlformats.org/drawingml/2006/main">
               <a:ext uri="{FF2B5EF4-FFF2-40B4-BE49-F238E27FC236}">
-                <a16:creationId xmlns:a16="http://schemas.microsoft.com/office/drawing/2014/main" id="{29B2018B-1984-4D7B-BC7C-802C3A8B66DC}"/>
+                <a16:creationId xmlns:a16="http://schemas.microsoft.com/office/drawing/2014/main" id="{76E55142-6348-48EB-978F-8C03829F84E6}"/>
               </a:ext>
             </a:extLst>
           </p:cNvPr>
@@ -18413,7 +18413,7 @@
           <p:cNvPr id="23" name="">
             <a:extLst xmlns:a="http://schemas.openxmlformats.org/drawingml/2006/main">
               <a:ext uri="{FF2B5EF4-FFF2-40B4-BE49-F238E27FC236}">
-                <a16:creationId xmlns:a16="http://schemas.microsoft.com/office/drawing/2014/main" id="{6469B295-54E1-4396-993A-E1B864E27F15}"/>
+                <a16:creationId xmlns:a16="http://schemas.microsoft.com/office/drawing/2014/main" id="{6D03CACC-D12B-412E-B440-E2289A1E156B}"/>
               </a:ext>
             </a:extLst>
           </p:cNvPr>
@@ -18473,7 +18473,7 @@
           <p:cNvPr id="24" name="">
             <a:extLst xmlns:a="http://schemas.openxmlformats.org/drawingml/2006/main">
               <a:ext uri="{FF2B5EF4-FFF2-40B4-BE49-F238E27FC236}">
-                <a16:creationId xmlns:a16="http://schemas.microsoft.com/office/drawing/2014/main" id="{900C9256-9BBB-434E-85F4-9B766BE16685}"/>
+                <a16:creationId xmlns:a16="http://schemas.microsoft.com/office/drawing/2014/main" id="{DDCD287B-26CC-4746-ACCE-1EB7D5F5DB04}"/>
               </a:ext>
             </a:extLst>
           </p:cNvPr>
@@ -18508,7 +18508,7 @@
           <p:cNvPr id="25" name="">
             <a:extLst xmlns:a="http://schemas.openxmlformats.org/drawingml/2006/main">
               <a:ext uri="{FF2B5EF4-FFF2-40B4-BE49-F238E27FC236}">
-                <a16:creationId xmlns:a16="http://schemas.microsoft.com/office/drawing/2014/main" id="{AAD1C227-E48D-4F56-B778-507BA14B58C8}"/>
+                <a16:creationId xmlns:a16="http://schemas.microsoft.com/office/drawing/2014/main" id="{0F86EEF9-7620-43B0-A407-04B719E46B21}"/>
               </a:ext>
             </a:extLst>
           </p:cNvPr>
@@ -18543,7 +18543,7 @@
           <p:cNvPr id="26" name="">
             <a:extLst xmlns:a="http://schemas.openxmlformats.org/drawingml/2006/main">
               <a:ext uri="{FF2B5EF4-FFF2-40B4-BE49-F238E27FC236}">
-                <a16:creationId xmlns:a16="http://schemas.microsoft.com/office/drawing/2014/main" id="{1D6E6AB3-99A6-4764-9ED1-83364882BB4D}"/>
+                <a16:creationId xmlns:a16="http://schemas.microsoft.com/office/drawing/2014/main" id="{D20D272F-C095-4C87-A34D-0FCD9B680EBC}"/>
               </a:ext>
             </a:extLst>
           </p:cNvPr>
@@ -18603,7 +18603,7 @@
           <p:cNvPr id="27" name="">
             <a:extLst xmlns:a="http://schemas.openxmlformats.org/drawingml/2006/main">
               <a:ext uri="{FF2B5EF4-FFF2-40B4-BE49-F238E27FC236}">
-                <a16:creationId xmlns:a16="http://schemas.microsoft.com/office/drawing/2014/main" id="{126FCBCC-8C69-4239-BA86-E31C9DADF650}"/>
+                <a16:creationId xmlns:a16="http://schemas.microsoft.com/office/drawing/2014/main" id="{613F34EA-C9E4-4179-BC69-AC580A2E7F87}"/>
               </a:ext>
             </a:extLst>
           </p:cNvPr>
@@ -18661,7 +18661,7 @@
     </p:spTree>
     <p:extLst>
       <p:ext uri="{BB962C8B-B14F-4D97-AF65-F5344CB8AC3E}">
-        <p14:creationId xmlns:p14="http://schemas.microsoft.com/office/powerpoint/2010/main" val="997318800"/>
+        <p14:creationId xmlns:p14="http://schemas.microsoft.com/office/powerpoint/2010/main" val="1223522399"/>
       </p:ext>
     </p:extLst>
   </p:cSld>

</xml_diff>